<commit_message>
Added Optimizer details and Parameter info to presentation
</commit_message>
<xml_diff>
--- a/slides/midterm-slides.pptx
+++ b/slides/midterm-slides.pptx
@@ -10,12 +10,14 @@
     <p:sldId id="258" r:id="rId4"/>
     <p:sldId id="259" r:id="rId5"/>
     <p:sldId id="260" r:id="rId6"/>
-    <p:sldId id="261" r:id="rId7"/>
-    <p:sldId id="262" r:id="rId8"/>
-    <p:sldId id="263" r:id="rId9"/>
-    <p:sldId id="264" r:id="rId10"/>
-    <p:sldId id="265" r:id="rId11"/>
-    <p:sldId id="267" r:id="rId12"/>
+    <p:sldId id="268" r:id="rId7"/>
+    <p:sldId id="269" r:id="rId8"/>
+    <p:sldId id="261" r:id="rId9"/>
+    <p:sldId id="262" r:id="rId10"/>
+    <p:sldId id="263" r:id="rId11"/>
+    <p:sldId id="264" r:id="rId12"/>
+    <p:sldId id="265" r:id="rId13"/>
+    <p:sldId id="267" r:id="rId14"/>
   </p:sldIdLst>
   <p:sldSz cx="12192000" cy="6858000"/>
   <p:notesSz cx="6858000" cy="9144000"/>
@@ -114,6 +116,11 @@
       </a:defRPr>
     </a:lvl9pPr>
   </p:defaultTextStyle>
+  <p:extLst>
+    <p:ext uri="{EFAFB233-063F-42B5-8137-9DF3F51BA10A}">
+      <p15:sldGuideLst xmlns:p15="http://schemas.microsoft.com/office/powerpoint/2012/main"/>
+    </p:ext>
+  </p:extLst>
 </p:presentation>
 </file>
 
@@ -306,7 +313,7 @@
             <a:fld id="{B61BEF0D-F0BB-DE4B-95CE-6DB70DBA9567}" type="datetimeFigureOut">
               <a:rPr lang="en-US" dirty="0"/>
               <a:pPr/>
-              <a:t>6/20/26</a:t>
+              <a:t>6/21/2026</a:t>
             </a:fld>
             <a:endParaRPr lang="en-US" dirty="0"/>
           </a:p>
@@ -648,7 +655,7 @@
             <a:fld id="{B61BEF0D-F0BB-DE4B-95CE-6DB70DBA9567}" type="datetimeFigureOut">
               <a:rPr lang="en-US" dirty="0"/>
               <a:pPr/>
-              <a:t>6/20/26</a:t>
+              <a:t>6/21/2026</a:t>
             </a:fld>
             <a:endParaRPr lang="en-US" dirty="0"/>
           </a:p>
@@ -1046,7 +1053,7 @@
             <a:fld id="{B61BEF0D-F0BB-DE4B-95CE-6DB70DBA9567}" type="datetimeFigureOut">
               <a:rPr lang="en-US" dirty="0"/>
               <a:pPr/>
-              <a:t>6/20/26</a:t>
+              <a:t>6/21/2026</a:t>
             </a:fld>
             <a:endParaRPr lang="en-US" dirty="0"/>
           </a:p>
@@ -1379,7 +1386,7 @@
             <a:fld id="{B61BEF0D-F0BB-DE4B-95CE-6DB70DBA9567}" type="datetimeFigureOut">
               <a:rPr lang="en-US" dirty="0"/>
               <a:pPr/>
-              <a:t>6/20/26</a:t>
+              <a:t>6/21/2026</a:t>
             </a:fld>
             <a:endParaRPr lang="en-US" dirty="0"/>
           </a:p>
@@ -1696,7 +1703,7 @@
             <a:fld id="{B61BEF0D-F0BB-DE4B-95CE-6DB70DBA9567}" type="datetimeFigureOut">
               <a:rPr lang="en-US" dirty="0"/>
               <a:pPr/>
-              <a:t>6/20/26</a:t>
+              <a:t>6/21/2026</a:t>
             </a:fld>
             <a:endParaRPr lang="en-US" dirty="0"/>
           </a:p>
@@ -2089,7 +2096,7 @@
             <a:fld id="{B61BEF0D-F0BB-DE4B-95CE-6DB70DBA9567}" type="datetimeFigureOut">
               <a:rPr lang="en-US" dirty="0"/>
               <a:pPr/>
-              <a:t>6/20/26</a:t>
+              <a:t>6/21/2026</a:t>
             </a:fld>
             <a:endParaRPr lang="en-US" dirty="0"/>
           </a:p>
@@ -2343,7 +2350,7 @@
             <a:fld id="{B61BEF0D-F0BB-DE4B-95CE-6DB70DBA9567}" type="datetimeFigureOut">
               <a:rPr lang="en-US" dirty="0"/>
               <a:pPr/>
-              <a:t>6/20/26</a:t>
+              <a:t>6/21/2026</a:t>
             </a:fld>
             <a:endParaRPr lang="en-US" dirty="0"/>
           </a:p>
@@ -2602,7 +2609,7 @@
             <a:fld id="{B61BEF0D-F0BB-DE4B-95CE-6DB70DBA9567}" type="datetimeFigureOut">
               <a:rPr lang="en-US" dirty="0"/>
               <a:pPr/>
-              <a:t>6/20/26</a:t>
+              <a:t>6/21/2026</a:t>
             </a:fld>
             <a:endParaRPr lang="en-US" dirty="0"/>
           </a:p>
@@ -2861,7 +2868,7 @@
             <a:fld id="{B61BEF0D-F0BB-DE4B-95CE-6DB70DBA9567}" type="datetimeFigureOut">
               <a:rPr lang="en-US" dirty="0"/>
               <a:pPr/>
-              <a:t>6/20/26</a:t>
+              <a:t>6/21/2026</a:t>
             </a:fld>
             <a:endParaRPr lang="en-US" dirty="0"/>
           </a:p>
@@ -3187,7 +3194,7 @@
             <a:fld id="{B61BEF0D-F0BB-DE4B-95CE-6DB70DBA9567}" type="datetimeFigureOut">
               <a:rPr lang="en-US" dirty="0"/>
               <a:pPr/>
-              <a:t>6/20/26</a:t>
+              <a:t>6/21/2026</a:t>
             </a:fld>
             <a:endParaRPr lang="en-US" dirty="0"/>
           </a:p>
@@ -3507,7 +3514,7 @@
             <a:fld id="{B61BEF0D-F0BB-DE4B-95CE-6DB70DBA9567}" type="datetimeFigureOut">
               <a:rPr lang="en-US" dirty="0"/>
               <a:pPr/>
-              <a:t>6/20/26</a:t>
+              <a:t>6/21/2026</a:t>
             </a:fld>
             <a:endParaRPr lang="en-US" dirty="0"/>
           </a:p>
@@ -3961,7 +3968,7 @@
             <a:fld id="{B61BEF0D-F0BB-DE4B-95CE-6DB70DBA9567}" type="datetimeFigureOut">
               <a:rPr lang="en-US" dirty="0"/>
               <a:pPr/>
-              <a:t>6/20/26</a:t>
+              <a:t>6/21/2026</a:t>
             </a:fld>
             <a:endParaRPr lang="en-US" dirty="0"/>
           </a:p>
@@ -4163,7 +4170,7 @@
             <a:fld id="{B61BEF0D-F0BB-DE4B-95CE-6DB70DBA9567}" type="datetimeFigureOut">
               <a:rPr lang="en-US" dirty="0"/>
               <a:pPr/>
-              <a:t>6/20/26</a:t>
+              <a:t>6/21/2026</a:t>
             </a:fld>
             <a:endParaRPr lang="en-US" dirty="0"/>
           </a:p>
@@ -4337,7 +4344,7 @@
             <a:fld id="{B61BEF0D-F0BB-DE4B-95CE-6DB70DBA9567}" type="datetimeFigureOut">
               <a:rPr lang="en-US" dirty="0"/>
               <a:pPr/>
-              <a:t>6/20/26</a:t>
+              <a:t>6/21/2026</a:t>
             </a:fld>
             <a:endParaRPr lang="en-US" dirty="0"/>
           </a:p>
@@ -4667,7 +4674,7 @@
             <a:fld id="{B61BEF0D-F0BB-DE4B-95CE-6DB70DBA9567}" type="datetimeFigureOut">
               <a:rPr lang="en-US" dirty="0"/>
               <a:pPr/>
-              <a:t>6/20/26</a:t>
+              <a:t>6/21/2026</a:t>
             </a:fld>
             <a:endParaRPr lang="en-US" dirty="0"/>
           </a:p>
@@ -5009,7 +5016,7 @@
             <a:fld id="{B61BEF0D-F0BB-DE4B-95CE-6DB70DBA9567}" type="datetimeFigureOut">
               <a:rPr lang="en-US" dirty="0"/>
               <a:pPr/>
-              <a:t>6/20/26</a:t>
+              <a:t>6/21/2026</a:t>
             </a:fld>
             <a:endParaRPr lang="en-US" dirty="0"/>
           </a:p>
@@ -7298,7 +7305,7 @@
             <a:fld id="{B61BEF0D-F0BB-DE4B-95CE-6DB70DBA9567}" type="datetimeFigureOut">
               <a:rPr lang="en-US" dirty="0"/>
               <a:pPr/>
-              <a:t>6/20/26</a:t>
+              <a:t>6/21/2026</a:t>
             </a:fld>
             <a:endParaRPr lang="en-US" dirty="0"/>
           </a:p>
@@ -11897,6 +11904,172 @@
           <p:cNvPr id="2" name="Title 1">
             <a:extLst>
               <a:ext uri="{FF2B5EF4-FFF2-40B4-BE49-F238E27FC236}">
+                <a16:creationId xmlns:a16="http://schemas.microsoft.com/office/drawing/2014/main" id="{C37705B1-C463-054E-8429-BD4A7B419E2F}"/>
+              </a:ext>
+            </a:extLst>
+          </p:cNvPr>
+          <p:cNvSpPr>
+            <a:spLocks noGrp="1"/>
+          </p:cNvSpPr>
+          <p:nvPr>
+            <p:ph type="title"/>
+          </p:nvPr>
+        </p:nvSpPr>
+        <p:spPr/>
+        <p:txBody>
+          <a:bodyPr/>
+          <a:lstStyle/>
+          <a:p>
+            <a:r>
+              <a:rPr lang="en-US" dirty="0"/>
+              <a:t>Interpretation &amp; Discussion</a:t>
+            </a:r>
+          </a:p>
+        </p:txBody>
+      </p:sp>
+      <p:sp>
+        <p:nvSpPr>
+          <p:cNvPr id="3" name="Content Placeholder 2">
+            <a:extLst>
+              <a:ext uri="{FF2B5EF4-FFF2-40B4-BE49-F238E27FC236}">
+                <a16:creationId xmlns:a16="http://schemas.microsoft.com/office/drawing/2014/main" id="{E842A3CE-0D11-5335-8C0A-EE11A2A2E2AF}"/>
+              </a:ext>
+            </a:extLst>
+          </p:cNvPr>
+          <p:cNvSpPr>
+            <a:spLocks noGrp="1"/>
+          </p:cNvSpPr>
+          <p:nvPr>
+            <p:ph idx="1"/>
+          </p:nvPr>
+        </p:nvSpPr>
+        <p:spPr/>
+        <p:txBody>
+          <a:bodyPr/>
+          <a:lstStyle/>
+          <a:p>
+            <a:endParaRPr lang="en-US"/>
+          </a:p>
+        </p:txBody>
+      </p:sp>
+    </p:spTree>
+    <p:extLst>
+      <p:ext uri="{BB962C8B-B14F-4D97-AF65-F5344CB8AC3E}">
+        <p14:creationId xmlns:p14="http://schemas.microsoft.com/office/powerpoint/2010/main" val="914363862"/>
+      </p:ext>
+    </p:extLst>
+  </p:cSld>
+  <p:clrMapOvr>
+    <a:masterClrMapping/>
+  </p:clrMapOvr>
+</p:sld>
+</file>
+
+<file path=ppt/slides/slide11.xml><?xml version="1.0" encoding="utf-8"?>
+<p:sld xmlns:a="http://schemas.openxmlformats.org/drawingml/2006/main" xmlns:r="http://schemas.openxmlformats.org/officeDocument/2006/relationships" xmlns:p="http://schemas.openxmlformats.org/presentationml/2006/main">
+  <p:cSld>
+    <p:spTree>
+      <p:nvGrpSpPr>
+        <p:cNvPr id="1" name=""/>
+        <p:cNvGrpSpPr/>
+        <p:nvPr/>
+      </p:nvGrpSpPr>
+      <p:grpSpPr>
+        <a:xfrm>
+          <a:off x="0" y="0"/>
+          <a:ext cx="0" cy="0"/>
+          <a:chOff x="0" y="0"/>
+          <a:chExt cx="0" cy="0"/>
+        </a:xfrm>
+      </p:grpSpPr>
+      <p:sp>
+        <p:nvSpPr>
+          <p:cNvPr id="2" name="Title 1">
+            <a:extLst>
+              <a:ext uri="{FF2B5EF4-FFF2-40B4-BE49-F238E27FC236}">
+                <a16:creationId xmlns:a16="http://schemas.microsoft.com/office/drawing/2014/main" id="{169F9636-CCA1-BB83-C04D-21A3B9DE4D4B}"/>
+              </a:ext>
+            </a:extLst>
+          </p:cNvPr>
+          <p:cNvSpPr>
+            <a:spLocks noGrp="1"/>
+          </p:cNvSpPr>
+          <p:nvPr>
+            <p:ph type="title"/>
+          </p:nvPr>
+        </p:nvSpPr>
+        <p:spPr/>
+        <p:txBody>
+          <a:bodyPr/>
+          <a:lstStyle/>
+          <a:p>
+            <a:r>
+              <a:rPr lang="en-US" dirty="0"/>
+              <a:t>Conclusion</a:t>
+            </a:r>
+          </a:p>
+        </p:txBody>
+      </p:sp>
+      <p:sp>
+        <p:nvSpPr>
+          <p:cNvPr id="3" name="Content Placeholder 2">
+            <a:extLst>
+              <a:ext uri="{FF2B5EF4-FFF2-40B4-BE49-F238E27FC236}">
+                <a16:creationId xmlns:a16="http://schemas.microsoft.com/office/drawing/2014/main" id="{5620016E-DDD4-A19E-076E-8BB3344CD165}"/>
+              </a:ext>
+            </a:extLst>
+          </p:cNvPr>
+          <p:cNvSpPr>
+            <a:spLocks noGrp="1"/>
+          </p:cNvSpPr>
+          <p:nvPr>
+            <p:ph idx="1"/>
+          </p:nvPr>
+        </p:nvSpPr>
+        <p:spPr/>
+        <p:txBody>
+          <a:bodyPr/>
+          <a:lstStyle/>
+          <a:p>
+            <a:endParaRPr lang="en-US"/>
+          </a:p>
+        </p:txBody>
+      </p:sp>
+    </p:spTree>
+    <p:extLst>
+      <p:ext uri="{BB962C8B-B14F-4D97-AF65-F5344CB8AC3E}">
+        <p14:creationId xmlns:p14="http://schemas.microsoft.com/office/powerpoint/2010/main" val="1800426027"/>
+      </p:ext>
+    </p:extLst>
+  </p:cSld>
+  <p:clrMapOvr>
+    <a:masterClrMapping/>
+  </p:clrMapOvr>
+</p:sld>
+</file>
+
+<file path=ppt/slides/slide12.xml><?xml version="1.0" encoding="utf-8"?>
+<p:sld xmlns:a="http://schemas.openxmlformats.org/drawingml/2006/main" xmlns:r="http://schemas.openxmlformats.org/officeDocument/2006/relationships" xmlns:p="http://schemas.openxmlformats.org/presentationml/2006/main">
+  <p:cSld>
+    <p:spTree>
+      <p:nvGrpSpPr>
+        <p:cNvPr id="1" name=""/>
+        <p:cNvGrpSpPr/>
+        <p:nvPr/>
+      </p:nvGrpSpPr>
+      <p:grpSpPr>
+        <a:xfrm>
+          <a:off x="0" y="0"/>
+          <a:ext cx="0" cy="0"/>
+          <a:chOff x="0" y="0"/>
+          <a:chExt cx="0" cy="0"/>
+        </a:xfrm>
+      </p:grpSpPr>
+      <p:sp>
+        <p:nvSpPr>
+          <p:cNvPr id="2" name="Title 1">
+            <a:extLst>
+              <a:ext uri="{FF2B5EF4-FFF2-40B4-BE49-F238E27FC236}">
                 <a16:creationId xmlns:a16="http://schemas.microsoft.com/office/drawing/2014/main" id="{0FC7A964-4E2A-6126-DF8E-7BD45E010226}"/>
               </a:ext>
             </a:extLst>
@@ -11958,7 +12131,7 @@
 </p:sld>
 </file>
 
-<file path=ppt/slides/slide11.xml><?xml version="1.0" encoding="utf-8"?>
+<file path=ppt/slides/slide13.xml><?xml version="1.0" encoding="utf-8"?>
 <p:sld xmlns:a="http://schemas.openxmlformats.org/drawingml/2006/main" xmlns:r="http://schemas.openxmlformats.org/officeDocument/2006/relationships" xmlns:p="http://schemas.openxmlformats.org/presentationml/2006/main">
   <p:cSld>
     <p:spTree>
@@ -12273,7 +12446,7 @@
           <a:bodyPr/>
           <a:lstStyle/>
           <a:p>
-            <a:endParaRPr lang="en-US"/>
+            <a:endParaRPr lang="en-US" dirty="0"/>
           </a:p>
         </p:txBody>
       </p:sp>
@@ -12351,12 +12524,1549 @@
             <p:ph idx="1"/>
           </p:nvPr>
         </p:nvSpPr>
-        <p:spPr/>
+        <p:spPr>
+          <a:xfrm>
+            <a:off x="930302" y="1632155"/>
+            <a:ext cx="3392999" cy="3320846"/>
+          </a:xfrm>
+        </p:spPr>
         <p:txBody>
-          <a:bodyPr/>
+          <a:bodyPr>
+            <a:normAutofit/>
+          </a:bodyPr>
           <a:lstStyle/>
           <a:p>
-            <a:endParaRPr lang="en-US"/>
+            <a:r>
+              <a:rPr lang="en-US" sz="2800" b="1" dirty="0"/>
+              <a:t>RMSProp</a:t>
+            </a:r>
+          </a:p>
+          <a:p>
+            <a:r>
+              <a:rPr lang="en-US" b="1" dirty="0"/>
+              <a:t>Root Mean Square Prop</a:t>
+            </a:r>
+            <a:r>
+              <a:rPr lang="en-US" dirty="0"/>
+              <a:t>agation</a:t>
+            </a:r>
+          </a:p>
+          <a:p>
+            <a:r>
+              <a:rPr lang="en-US" dirty="0"/>
+              <a:t>Jeffrey Hinton during a lecture, 2012</a:t>
+            </a:r>
+          </a:p>
+          <a:p>
+            <a:r>
+              <a:rPr lang="en-US" dirty="0"/>
+              <a:t>SGD &amp; ADA with improved learning rate</a:t>
+            </a:r>
+          </a:p>
+          <a:p>
+            <a:r>
+              <a:rPr lang="en-US" b="1" dirty="0"/>
+              <a:t>Sliding window </a:t>
+            </a:r>
+            <a:r>
+              <a:rPr lang="en-US" dirty="0"/>
+              <a:t>for past gradients</a:t>
+            </a:r>
+          </a:p>
+          <a:p>
+            <a:pPr marL="0" indent="0">
+              <a:buNone/>
+            </a:pPr>
+            <a:endParaRPr lang="en-US" b="1" dirty="0"/>
+          </a:p>
+        </p:txBody>
+      </p:sp>
+      <p:sp>
+        <p:nvSpPr>
+          <p:cNvPr id="5" name="Content Placeholder 2">
+            <a:extLst>
+              <a:ext uri="{FF2B5EF4-FFF2-40B4-BE49-F238E27FC236}">
+                <a16:creationId xmlns:a16="http://schemas.microsoft.com/office/drawing/2014/main" id="{21E5D3F2-5387-40E4-8C35-3CF59DD773D7}"/>
+              </a:ext>
+            </a:extLst>
+          </p:cNvPr>
+          <p:cNvSpPr txBox="1">
+            <a:spLocks/>
+          </p:cNvSpPr>
+          <p:nvPr/>
+        </p:nvSpPr>
+        <p:spPr>
+          <a:xfrm>
+            <a:off x="4475700" y="1632155"/>
+            <a:ext cx="3392999" cy="3320846"/>
+          </a:xfrm>
+          <a:prstGeom prst="rect">
+            <a:avLst/>
+          </a:prstGeom>
+        </p:spPr>
+        <p:txBody>
+          <a:bodyPr vert="horz" lIns="91440" tIns="45720" rIns="91440" bIns="45720" rtlCol="0">
+            <a:normAutofit/>
+          </a:bodyPr>
+          <a:lstStyle>
+            <a:lvl1pPr marL="342900" indent="-342900" algn="l" defTabSz="457200" rtl="0" eaLnBrk="1" latinLnBrk="0" hangingPunct="1">
+              <a:spcBef>
+                <a:spcPts val="1000"/>
+              </a:spcBef>
+              <a:spcAft>
+                <a:spcPts val="0"/>
+              </a:spcAft>
+              <a:buClr>
+                <a:schemeClr val="accent1"/>
+              </a:buClr>
+              <a:buFont typeface="Wingdings 3" charset="2"/>
+              <a:buChar char=""/>
+              <a:defRPr sz="1800" kern="1200">
+                <a:solidFill>
+                  <a:schemeClr val="tx1">
+                    <a:lumMod val="75000"/>
+                    <a:lumOff val="25000"/>
+                  </a:schemeClr>
+                </a:solidFill>
+                <a:latin typeface="+mn-lt"/>
+                <a:ea typeface="+mn-ea"/>
+                <a:cs typeface="+mn-cs"/>
+              </a:defRPr>
+            </a:lvl1pPr>
+            <a:lvl2pPr marL="742950" indent="-285750" algn="l" defTabSz="457200" rtl="0" eaLnBrk="1" latinLnBrk="0" hangingPunct="1">
+              <a:spcBef>
+                <a:spcPts val="1000"/>
+              </a:spcBef>
+              <a:spcAft>
+                <a:spcPts val="0"/>
+              </a:spcAft>
+              <a:buClr>
+                <a:schemeClr val="accent1"/>
+              </a:buClr>
+              <a:buFont typeface="Wingdings 3" charset="2"/>
+              <a:buChar char=""/>
+              <a:defRPr sz="1600" kern="1200">
+                <a:solidFill>
+                  <a:schemeClr val="tx1">
+                    <a:lumMod val="75000"/>
+                    <a:lumOff val="25000"/>
+                  </a:schemeClr>
+                </a:solidFill>
+                <a:latin typeface="+mn-lt"/>
+                <a:ea typeface="+mn-ea"/>
+                <a:cs typeface="+mn-cs"/>
+              </a:defRPr>
+            </a:lvl2pPr>
+            <a:lvl3pPr marL="1143000" indent="-228600" algn="l" defTabSz="457200" rtl="0" eaLnBrk="1" latinLnBrk="0" hangingPunct="1">
+              <a:spcBef>
+                <a:spcPts val="1000"/>
+              </a:spcBef>
+              <a:spcAft>
+                <a:spcPts val="0"/>
+              </a:spcAft>
+              <a:buClr>
+                <a:schemeClr val="accent1"/>
+              </a:buClr>
+              <a:buFont typeface="Wingdings 3" charset="2"/>
+              <a:buChar char=""/>
+              <a:defRPr sz="1400" kern="1200">
+                <a:solidFill>
+                  <a:schemeClr val="tx1">
+                    <a:lumMod val="75000"/>
+                    <a:lumOff val="25000"/>
+                  </a:schemeClr>
+                </a:solidFill>
+                <a:latin typeface="+mn-lt"/>
+                <a:ea typeface="+mn-ea"/>
+                <a:cs typeface="+mn-cs"/>
+              </a:defRPr>
+            </a:lvl3pPr>
+            <a:lvl4pPr marL="1600200" indent="-228600" algn="l" defTabSz="457200" rtl="0" eaLnBrk="1" latinLnBrk="0" hangingPunct="1">
+              <a:spcBef>
+                <a:spcPts val="1000"/>
+              </a:spcBef>
+              <a:spcAft>
+                <a:spcPts val="0"/>
+              </a:spcAft>
+              <a:buClr>
+                <a:schemeClr val="accent1"/>
+              </a:buClr>
+              <a:buFont typeface="Wingdings 3" charset="2"/>
+              <a:buChar char=""/>
+              <a:defRPr sz="1200" kern="1200">
+                <a:solidFill>
+                  <a:schemeClr val="tx1">
+                    <a:lumMod val="75000"/>
+                    <a:lumOff val="25000"/>
+                  </a:schemeClr>
+                </a:solidFill>
+                <a:latin typeface="+mn-lt"/>
+                <a:ea typeface="+mn-ea"/>
+                <a:cs typeface="+mn-cs"/>
+              </a:defRPr>
+            </a:lvl4pPr>
+            <a:lvl5pPr marL="2057400" indent="-228600" algn="l" defTabSz="457200" rtl="0" eaLnBrk="1" latinLnBrk="0" hangingPunct="1">
+              <a:spcBef>
+                <a:spcPts val="1000"/>
+              </a:spcBef>
+              <a:spcAft>
+                <a:spcPts val="0"/>
+              </a:spcAft>
+              <a:buClr>
+                <a:schemeClr val="accent1"/>
+              </a:buClr>
+              <a:buFont typeface="Wingdings 3" charset="2"/>
+              <a:buChar char=""/>
+              <a:defRPr sz="1200" kern="1200">
+                <a:solidFill>
+                  <a:schemeClr val="tx1">
+                    <a:lumMod val="75000"/>
+                    <a:lumOff val="25000"/>
+                  </a:schemeClr>
+                </a:solidFill>
+                <a:latin typeface="+mn-lt"/>
+                <a:ea typeface="+mn-ea"/>
+                <a:cs typeface="+mn-cs"/>
+              </a:defRPr>
+            </a:lvl5pPr>
+            <a:lvl6pPr marL="2514600" indent="-228600" algn="l" defTabSz="457200" rtl="0" eaLnBrk="1" latinLnBrk="0" hangingPunct="1">
+              <a:spcBef>
+                <a:spcPts val="1000"/>
+              </a:spcBef>
+              <a:spcAft>
+                <a:spcPts val="0"/>
+              </a:spcAft>
+              <a:buClr>
+                <a:schemeClr val="accent1"/>
+              </a:buClr>
+              <a:buFont typeface="Wingdings 3" charset="2"/>
+              <a:buChar char=""/>
+              <a:defRPr sz="1200" kern="1200">
+                <a:solidFill>
+                  <a:schemeClr val="tx1">
+                    <a:lumMod val="75000"/>
+                    <a:lumOff val="25000"/>
+                  </a:schemeClr>
+                </a:solidFill>
+                <a:latin typeface="+mn-lt"/>
+                <a:ea typeface="+mn-ea"/>
+                <a:cs typeface="+mn-cs"/>
+              </a:defRPr>
+            </a:lvl6pPr>
+            <a:lvl7pPr marL="2971800" indent="-228600" algn="l" defTabSz="457200" rtl="0" eaLnBrk="1" latinLnBrk="0" hangingPunct="1">
+              <a:spcBef>
+                <a:spcPts val="1000"/>
+              </a:spcBef>
+              <a:spcAft>
+                <a:spcPts val="0"/>
+              </a:spcAft>
+              <a:buClr>
+                <a:schemeClr val="accent1"/>
+              </a:buClr>
+              <a:buFont typeface="Wingdings 3" charset="2"/>
+              <a:buChar char=""/>
+              <a:defRPr sz="1200" kern="1200">
+                <a:solidFill>
+                  <a:schemeClr val="tx1">
+                    <a:lumMod val="75000"/>
+                    <a:lumOff val="25000"/>
+                  </a:schemeClr>
+                </a:solidFill>
+                <a:latin typeface="+mn-lt"/>
+                <a:ea typeface="+mn-ea"/>
+                <a:cs typeface="+mn-cs"/>
+              </a:defRPr>
+            </a:lvl7pPr>
+            <a:lvl8pPr marL="3429000" indent="-228600" algn="l" defTabSz="457200" rtl="0" eaLnBrk="1" latinLnBrk="0" hangingPunct="1">
+              <a:spcBef>
+                <a:spcPts val="1000"/>
+              </a:spcBef>
+              <a:spcAft>
+                <a:spcPts val="0"/>
+              </a:spcAft>
+              <a:buClr>
+                <a:schemeClr val="accent1"/>
+              </a:buClr>
+              <a:buFont typeface="Wingdings 3" charset="2"/>
+              <a:buChar char=""/>
+              <a:defRPr sz="1200" kern="1200">
+                <a:solidFill>
+                  <a:schemeClr val="tx1">
+                    <a:lumMod val="75000"/>
+                    <a:lumOff val="25000"/>
+                  </a:schemeClr>
+                </a:solidFill>
+                <a:latin typeface="+mn-lt"/>
+                <a:ea typeface="+mn-ea"/>
+                <a:cs typeface="+mn-cs"/>
+              </a:defRPr>
+            </a:lvl8pPr>
+            <a:lvl9pPr marL="3886200" indent="-228600" algn="l" defTabSz="457200" rtl="0" eaLnBrk="1" latinLnBrk="0" hangingPunct="1">
+              <a:spcBef>
+                <a:spcPts val="1000"/>
+              </a:spcBef>
+              <a:spcAft>
+                <a:spcPts val="0"/>
+              </a:spcAft>
+              <a:buClr>
+                <a:schemeClr val="accent1"/>
+              </a:buClr>
+              <a:buFont typeface="Wingdings 3" charset="2"/>
+              <a:buChar char=""/>
+              <a:defRPr sz="1200" kern="1200">
+                <a:solidFill>
+                  <a:schemeClr val="tx1">
+                    <a:lumMod val="75000"/>
+                    <a:lumOff val="25000"/>
+                  </a:schemeClr>
+                </a:solidFill>
+                <a:latin typeface="+mn-lt"/>
+                <a:ea typeface="+mn-ea"/>
+                <a:cs typeface="+mn-cs"/>
+              </a:defRPr>
+            </a:lvl9pPr>
+          </a:lstStyle>
+          <a:p>
+            <a:r>
+              <a:rPr lang="en-US" sz="2800" b="1" dirty="0"/>
+              <a:t>Adam</a:t>
+            </a:r>
+          </a:p>
+          <a:p>
+            <a:r>
+              <a:rPr lang="en-US" b="1" dirty="0" err="1"/>
+              <a:t>ADA</a:t>
+            </a:r>
+            <a:r>
+              <a:rPr lang="en-US" dirty="0" err="1"/>
+              <a:t>ptive</a:t>
+            </a:r>
+            <a:r>
+              <a:rPr lang="en-US" dirty="0"/>
+              <a:t> </a:t>
+            </a:r>
+            <a:r>
+              <a:rPr lang="en-US" b="1" dirty="0"/>
+              <a:t>M</a:t>
+            </a:r>
+            <a:r>
+              <a:rPr lang="en-US" dirty="0"/>
+              <a:t>oment Estimation</a:t>
+            </a:r>
+          </a:p>
+          <a:p>
+            <a:r>
+              <a:rPr lang="en-US" dirty="0"/>
+              <a:t>Kingma &amp; Ba, 2015</a:t>
+            </a:r>
+          </a:p>
+          <a:p>
+            <a:r>
+              <a:rPr lang="en-US" dirty="0"/>
+              <a:t>RMSProp with improved momentum </a:t>
+            </a:r>
+          </a:p>
+          <a:p>
+            <a:r>
+              <a:rPr lang="en-US" dirty="0"/>
+              <a:t>Uses the </a:t>
+            </a:r>
+            <a:r>
+              <a:rPr lang="en-US" b="1" dirty="0"/>
+              <a:t>mean of the gradients </a:t>
+            </a:r>
+            <a:r>
+              <a:rPr lang="en-US" dirty="0"/>
+              <a:t>as momentum</a:t>
+            </a:r>
+          </a:p>
+          <a:p>
+            <a:endParaRPr lang="en-US" b="1" dirty="0"/>
+          </a:p>
+        </p:txBody>
+      </p:sp>
+      <p:sp>
+        <p:nvSpPr>
+          <p:cNvPr id="6" name="Content Placeholder 2">
+            <a:extLst>
+              <a:ext uri="{FF2B5EF4-FFF2-40B4-BE49-F238E27FC236}">
+                <a16:creationId xmlns:a16="http://schemas.microsoft.com/office/drawing/2014/main" id="{F590EBD8-425A-CCC1-6E5D-5A2845DA7AC2}"/>
+              </a:ext>
+            </a:extLst>
+          </p:cNvPr>
+          <p:cNvSpPr txBox="1">
+            <a:spLocks/>
+          </p:cNvSpPr>
+          <p:nvPr/>
+        </p:nvSpPr>
+        <p:spPr>
+          <a:xfrm>
+            <a:off x="7868699" y="1632155"/>
+            <a:ext cx="3556385" cy="3406877"/>
+          </a:xfrm>
+          <a:prstGeom prst="rect">
+            <a:avLst/>
+          </a:prstGeom>
+        </p:spPr>
+        <p:txBody>
+          <a:bodyPr vert="horz" lIns="91440" tIns="45720" rIns="91440" bIns="45720" rtlCol="0">
+            <a:normAutofit/>
+          </a:bodyPr>
+          <a:lstStyle>
+            <a:lvl1pPr marL="342900" indent="-342900" algn="l" defTabSz="457200" rtl="0" eaLnBrk="1" latinLnBrk="0" hangingPunct="1">
+              <a:spcBef>
+                <a:spcPts val="1000"/>
+              </a:spcBef>
+              <a:spcAft>
+                <a:spcPts val="0"/>
+              </a:spcAft>
+              <a:buClr>
+                <a:schemeClr val="accent1"/>
+              </a:buClr>
+              <a:buFont typeface="Wingdings 3" charset="2"/>
+              <a:buChar char=""/>
+              <a:defRPr sz="1800" kern="1200">
+                <a:solidFill>
+                  <a:schemeClr val="tx1">
+                    <a:lumMod val="75000"/>
+                    <a:lumOff val="25000"/>
+                  </a:schemeClr>
+                </a:solidFill>
+                <a:latin typeface="+mn-lt"/>
+                <a:ea typeface="+mn-ea"/>
+                <a:cs typeface="+mn-cs"/>
+              </a:defRPr>
+            </a:lvl1pPr>
+            <a:lvl2pPr marL="742950" indent="-285750" algn="l" defTabSz="457200" rtl="0" eaLnBrk="1" latinLnBrk="0" hangingPunct="1">
+              <a:spcBef>
+                <a:spcPts val="1000"/>
+              </a:spcBef>
+              <a:spcAft>
+                <a:spcPts val="0"/>
+              </a:spcAft>
+              <a:buClr>
+                <a:schemeClr val="accent1"/>
+              </a:buClr>
+              <a:buFont typeface="Wingdings 3" charset="2"/>
+              <a:buChar char=""/>
+              <a:defRPr sz="1600" kern="1200">
+                <a:solidFill>
+                  <a:schemeClr val="tx1">
+                    <a:lumMod val="75000"/>
+                    <a:lumOff val="25000"/>
+                  </a:schemeClr>
+                </a:solidFill>
+                <a:latin typeface="+mn-lt"/>
+                <a:ea typeface="+mn-ea"/>
+                <a:cs typeface="+mn-cs"/>
+              </a:defRPr>
+            </a:lvl2pPr>
+            <a:lvl3pPr marL="1143000" indent="-228600" algn="l" defTabSz="457200" rtl="0" eaLnBrk="1" latinLnBrk="0" hangingPunct="1">
+              <a:spcBef>
+                <a:spcPts val="1000"/>
+              </a:spcBef>
+              <a:spcAft>
+                <a:spcPts val="0"/>
+              </a:spcAft>
+              <a:buClr>
+                <a:schemeClr val="accent1"/>
+              </a:buClr>
+              <a:buFont typeface="Wingdings 3" charset="2"/>
+              <a:buChar char=""/>
+              <a:defRPr sz="1400" kern="1200">
+                <a:solidFill>
+                  <a:schemeClr val="tx1">
+                    <a:lumMod val="75000"/>
+                    <a:lumOff val="25000"/>
+                  </a:schemeClr>
+                </a:solidFill>
+                <a:latin typeface="+mn-lt"/>
+                <a:ea typeface="+mn-ea"/>
+                <a:cs typeface="+mn-cs"/>
+              </a:defRPr>
+            </a:lvl3pPr>
+            <a:lvl4pPr marL="1600200" indent="-228600" algn="l" defTabSz="457200" rtl="0" eaLnBrk="1" latinLnBrk="0" hangingPunct="1">
+              <a:spcBef>
+                <a:spcPts val="1000"/>
+              </a:spcBef>
+              <a:spcAft>
+                <a:spcPts val="0"/>
+              </a:spcAft>
+              <a:buClr>
+                <a:schemeClr val="accent1"/>
+              </a:buClr>
+              <a:buFont typeface="Wingdings 3" charset="2"/>
+              <a:buChar char=""/>
+              <a:defRPr sz="1200" kern="1200">
+                <a:solidFill>
+                  <a:schemeClr val="tx1">
+                    <a:lumMod val="75000"/>
+                    <a:lumOff val="25000"/>
+                  </a:schemeClr>
+                </a:solidFill>
+                <a:latin typeface="+mn-lt"/>
+                <a:ea typeface="+mn-ea"/>
+                <a:cs typeface="+mn-cs"/>
+              </a:defRPr>
+            </a:lvl4pPr>
+            <a:lvl5pPr marL="2057400" indent="-228600" algn="l" defTabSz="457200" rtl="0" eaLnBrk="1" latinLnBrk="0" hangingPunct="1">
+              <a:spcBef>
+                <a:spcPts val="1000"/>
+              </a:spcBef>
+              <a:spcAft>
+                <a:spcPts val="0"/>
+              </a:spcAft>
+              <a:buClr>
+                <a:schemeClr val="accent1"/>
+              </a:buClr>
+              <a:buFont typeface="Wingdings 3" charset="2"/>
+              <a:buChar char=""/>
+              <a:defRPr sz="1200" kern="1200">
+                <a:solidFill>
+                  <a:schemeClr val="tx1">
+                    <a:lumMod val="75000"/>
+                    <a:lumOff val="25000"/>
+                  </a:schemeClr>
+                </a:solidFill>
+                <a:latin typeface="+mn-lt"/>
+                <a:ea typeface="+mn-ea"/>
+                <a:cs typeface="+mn-cs"/>
+              </a:defRPr>
+            </a:lvl5pPr>
+            <a:lvl6pPr marL="2514600" indent="-228600" algn="l" defTabSz="457200" rtl="0" eaLnBrk="1" latinLnBrk="0" hangingPunct="1">
+              <a:spcBef>
+                <a:spcPts val="1000"/>
+              </a:spcBef>
+              <a:spcAft>
+                <a:spcPts val="0"/>
+              </a:spcAft>
+              <a:buClr>
+                <a:schemeClr val="accent1"/>
+              </a:buClr>
+              <a:buFont typeface="Wingdings 3" charset="2"/>
+              <a:buChar char=""/>
+              <a:defRPr sz="1200" kern="1200">
+                <a:solidFill>
+                  <a:schemeClr val="tx1">
+                    <a:lumMod val="75000"/>
+                    <a:lumOff val="25000"/>
+                  </a:schemeClr>
+                </a:solidFill>
+                <a:latin typeface="+mn-lt"/>
+                <a:ea typeface="+mn-ea"/>
+                <a:cs typeface="+mn-cs"/>
+              </a:defRPr>
+            </a:lvl6pPr>
+            <a:lvl7pPr marL="2971800" indent="-228600" algn="l" defTabSz="457200" rtl="0" eaLnBrk="1" latinLnBrk="0" hangingPunct="1">
+              <a:spcBef>
+                <a:spcPts val="1000"/>
+              </a:spcBef>
+              <a:spcAft>
+                <a:spcPts val="0"/>
+              </a:spcAft>
+              <a:buClr>
+                <a:schemeClr val="accent1"/>
+              </a:buClr>
+              <a:buFont typeface="Wingdings 3" charset="2"/>
+              <a:buChar char=""/>
+              <a:defRPr sz="1200" kern="1200">
+                <a:solidFill>
+                  <a:schemeClr val="tx1">
+                    <a:lumMod val="75000"/>
+                    <a:lumOff val="25000"/>
+                  </a:schemeClr>
+                </a:solidFill>
+                <a:latin typeface="+mn-lt"/>
+                <a:ea typeface="+mn-ea"/>
+                <a:cs typeface="+mn-cs"/>
+              </a:defRPr>
+            </a:lvl7pPr>
+            <a:lvl8pPr marL="3429000" indent="-228600" algn="l" defTabSz="457200" rtl="0" eaLnBrk="1" latinLnBrk="0" hangingPunct="1">
+              <a:spcBef>
+                <a:spcPts val="1000"/>
+              </a:spcBef>
+              <a:spcAft>
+                <a:spcPts val="0"/>
+              </a:spcAft>
+              <a:buClr>
+                <a:schemeClr val="accent1"/>
+              </a:buClr>
+              <a:buFont typeface="Wingdings 3" charset="2"/>
+              <a:buChar char=""/>
+              <a:defRPr sz="1200" kern="1200">
+                <a:solidFill>
+                  <a:schemeClr val="tx1">
+                    <a:lumMod val="75000"/>
+                    <a:lumOff val="25000"/>
+                  </a:schemeClr>
+                </a:solidFill>
+                <a:latin typeface="+mn-lt"/>
+                <a:ea typeface="+mn-ea"/>
+                <a:cs typeface="+mn-cs"/>
+              </a:defRPr>
+            </a:lvl8pPr>
+            <a:lvl9pPr marL="3886200" indent="-228600" algn="l" defTabSz="457200" rtl="0" eaLnBrk="1" latinLnBrk="0" hangingPunct="1">
+              <a:spcBef>
+                <a:spcPts val="1000"/>
+              </a:spcBef>
+              <a:spcAft>
+                <a:spcPts val="0"/>
+              </a:spcAft>
+              <a:buClr>
+                <a:schemeClr val="accent1"/>
+              </a:buClr>
+              <a:buFont typeface="Wingdings 3" charset="2"/>
+              <a:buChar char=""/>
+              <a:defRPr sz="1200" kern="1200">
+                <a:solidFill>
+                  <a:schemeClr val="tx1">
+                    <a:lumMod val="75000"/>
+                    <a:lumOff val="25000"/>
+                  </a:schemeClr>
+                </a:solidFill>
+                <a:latin typeface="+mn-lt"/>
+                <a:ea typeface="+mn-ea"/>
+                <a:cs typeface="+mn-cs"/>
+              </a:defRPr>
+            </a:lvl9pPr>
+          </a:lstStyle>
+          <a:p>
+            <a:r>
+              <a:rPr lang="en-US" sz="3000" b="1" dirty="0" err="1"/>
+              <a:t>AdamW</a:t>
+            </a:r>
+            <a:endParaRPr lang="en-US" sz="3000" b="1" dirty="0"/>
+          </a:p>
+          <a:p>
+            <a:r>
+              <a:rPr lang="en-US" b="1" dirty="0"/>
+              <a:t>ADAM </a:t>
+            </a:r>
+            <a:r>
+              <a:rPr lang="en-US" dirty="0"/>
+              <a:t>with decoupled </a:t>
+            </a:r>
+            <a:r>
+              <a:rPr lang="en-US" b="1" dirty="0"/>
+              <a:t>W</a:t>
+            </a:r>
+            <a:r>
+              <a:rPr lang="en-US" dirty="0"/>
+              <a:t>eight Decay</a:t>
+            </a:r>
+          </a:p>
+          <a:p>
+            <a:r>
+              <a:rPr lang="en-US" dirty="0" err="1"/>
+              <a:t>Loschilov</a:t>
+            </a:r>
+            <a:r>
+              <a:rPr lang="en-US" dirty="0"/>
+              <a:t> &amp; Hutter, 2017</a:t>
+            </a:r>
+          </a:p>
+          <a:p>
+            <a:r>
+              <a:rPr lang="en-US" dirty="0" err="1"/>
+              <a:t>AdamW</a:t>
+            </a:r>
+            <a:r>
+              <a:rPr lang="en-US" dirty="0"/>
+              <a:t> with improved weight decay</a:t>
+            </a:r>
+          </a:p>
+          <a:p>
+            <a:r>
+              <a:rPr lang="en-US" dirty="0"/>
+              <a:t>Adds weight decay calculation </a:t>
+            </a:r>
+            <a:r>
+              <a:rPr lang="en-US" b="1" dirty="0"/>
+              <a:t>after</a:t>
+            </a:r>
+            <a:r>
+              <a:rPr lang="en-US" dirty="0"/>
+              <a:t> weight scaling</a:t>
+            </a:r>
+          </a:p>
+          <a:p>
+            <a:pPr marL="0" indent="0">
+              <a:buNone/>
+            </a:pPr>
+            <a:endParaRPr lang="en-US" sz="2800" b="1" dirty="0"/>
+          </a:p>
+          <a:p>
+            <a:endParaRPr lang="en-US" sz="2800" b="1" dirty="0"/>
+          </a:p>
+        </p:txBody>
+      </p:sp>
+      <p:sp>
+        <p:nvSpPr>
+          <p:cNvPr id="7" name="Content Placeholder 2">
+            <a:extLst>
+              <a:ext uri="{FF2B5EF4-FFF2-40B4-BE49-F238E27FC236}">
+                <a16:creationId xmlns:a16="http://schemas.microsoft.com/office/drawing/2014/main" id="{72EFF417-F80E-5913-BD95-E9701796F1A7}"/>
+              </a:ext>
+            </a:extLst>
+          </p:cNvPr>
+          <p:cNvSpPr txBox="1">
+            <a:spLocks/>
+          </p:cNvSpPr>
+          <p:nvPr/>
+        </p:nvSpPr>
+        <p:spPr>
+          <a:xfrm>
+            <a:off x="930302" y="5039033"/>
+            <a:ext cx="3465869" cy="1410928"/>
+          </a:xfrm>
+          <a:prstGeom prst="rect">
+            <a:avLst/>
+          </a:prstGeom>
+        </p:spPr>
+        <p:style>
+          <a:lnRef idx="3">
+            <a:schemeClr val="lt1"/>
+          </a:lnRef>
+          <a:fillRef idx="1">
+            <a:schemeClr val="accent1"/>
+          </a:fillRef>
+          <a:effectRef idx="1">
+            <a:schemeClr val="accent1"/>
+          </a:effectRef>
+          <a:fontRef idx="minor">
+            <a:schemeClr val="lt1"/>
+          </a:fontRef>
+        </p:style>
+        <p:txBody>
+          <a:bodyPr vert="horz" lIns="91440" tIns="45720" rIns="91440" bIns="45720" rtlCol="0">
+            <a:normAutofit/>
+          </a:bodyPr>
+          <a:lstStyle>
+            <a:lvl1pPr marL="342900" indent="-342900" algn="l" defTabSz="457200" rtl="0" eaLnBrk="1" latinLnBrk="0" hangingPunct="1">
+              <a:spcBef>
+                <a:spcPts val="1000"/>
+              </a:spcBef>
+              <a:spcAft>
+                <a:spcPts val="0"/>
+              </a:spcAft>
+              <a:buClr>
+                <a:schemeClr val="accent1"/>
+              </a:buClr>
+              <a:buFont typeface="Wingdings 3" charset="2"/>
+              <a:buChar char=""/>
+              <a:defRPr sz="1800" kern="1200">
+                <a:solidFill>
+                  <a:schemeClr val="tx1">
+                    <a:lumMod val="75000"/>
+                    <a:lumOff val="25000"/>
+                  </a:schemeClr>
+                </a:solidFill>
+                <a:latin typeface="+mn-lt"/>
+                <a:ea typeface="+mn-ea"/>
+                <a:cs typeface="+mn-cs"/>
+              </a:defRPr>
+            </a:lvl1pPr>
+            <a:lvl2pPr marL="742950" indent="-285750" algn="l" defTabSz="457200" rtl="0" eaLnBrk="1" latinLnBrk="0" hangingPunct="1">
+              <a:spcBef>
+                <a:spcPts val="1000"/>
+              </a:spcBef>
+              <a:spcAft>
+                <a:spcPts val="0"/>
+              </a:spcAft>
+              <a:buClr>
+                <a:schemeClr val="accent1"/>
+              </a:buClr>
+              <a:buFont typeface="Wingdings 3" charset="2"/>
+              <a:buChar char=""/>
+              <a:defRPr sz="1600" kern="1200">
+                <a:solidFill>
+                  <a:schemeClr val="tx1">
+                    <a:lumMod val="75000"/>
+                    <a:lumOff val="25000"/>
+                  </a:schemeClr>
+                </a:solidFill>
+                <a:latin typeface="+mn-lt"/>
+                <a:ea typeface="+mn-ea"/>
+                <a:cs typeface="+mn-cs"/>
+              </a:defRPr>
+            </a:lvl2pPr>
+            <a:lvl3pPr marL="1143000" indent="-228600" algn="l" defTabSz="457200" rtl="0" eaLnBrk="1" latinLnBrk="0" hangingPunct="1">
+              <a:spcBef>
+                <a:spcPts val="1000"/>
+              </a:spcBef>
+              <a:spcAft>
+                <a:spcPts val="0"/>
+              </a:spcAft>
+              <a:buClr>
+                <a:schemeClr val="accent1"/>
+              </a:buClr>
+              <a:buFont typeface="Wingdings 3" charset="2"/>
+              <a:buChar char=""/>
+              <a:defRPr sz="1400" kern="1200">
+                <a:solidFill>
+                  <a:schemeClr val="tx1">
+                    <a:lumMod val="75000"/>
+                    <a:lumOff val="25000"/>
+                  </a:schemeClr>
+                </a:solidFill>
+                <a:latin typeface="+mn-lt"/>
+                <a:ea typeface="+mn-ea"/>
+                <a:cs typeface="+mn-cs"/>
+              </a:defRPr>
+            </a:lvl3pPr>
+            <a:lvl4pPr marL="1600200" indent="-228600" algn="l" defTabSz="457200" rtl="0" eaLnBrk="1" latinLnBrk="0" hangingPunct="1">
+              <a:spcBef>
+                <a:spcPts val="1000"/>
+              </a:spcBef>
+              <a:spcAft>
+                <a:spcPts val="0"/>
+              </a:spcAft>
+              <a:buClr>
+                <a:schemeClr val="accent1"/>
+              </a:buClr>
+              <a:buFont typeface="Wingdings 3" charset="2"/>
+              <a:buChar char=""/>
+              <a:defRPr sz="1200" kern="1200">
+                <a:solidFill>
+                  <a:schemeClr val="tx1">
+                    <a:lumMod val="75000"/>
+                    <a:lumOff val="25000"/>
+                  </a:schemeClr>
+                </a:solidFill>
+                <a:latin typeface="+mn-lt"/>
+                <a:ea typeface="+mn-ea"/>
+                <a:cs typeface="+mn-cs"/>
+              </a:defRPr>
+            </a:lvl4pPr>
+            <a:lvl5pPr marL="2057400" indent="-228600" algn="l" defTabSz="457200" rtl="0" eaLnBrk="1" latinLnBrk="0" hangingPunct="1">
+              <a:spcBef>
+                <a:spcPts val="1000"/>
+              </a:spcBef>
+              <a:spcAft>
+                <a:spcPts val="0"/>
+              </a:spcAft>
+              <a:buClr>
+                <a:schemeClr val="accent1"/>
+              </a:buClr>
+              <a:buFont typeface="Wingdings 3" charset="2"/>
+              <a:buChar char=""/>
+              <a:defRPr sz="1200" kern="1200">
+                <a:solidFill>
+                  <a:schemeClr val="tx1">
+                    <a:lumMod val="75000"/>
+                    <a:lumOff val="25000"/>
+                  </a:schemeClr>
+                </a:solidFill>
+                <a:latin typeface="+mn-lt"/>
+                <a:ea typeface="+mn-ea"/>
+                <a:cs typeface="+mn-cs"/>
+              </a:defRPr>
+            </a:lvl5pPr>
+            <a:lvl6pPr marL="2514600" indent="-228600" algn="l" defTabSz="457200" rtl="0" eaLnBrk="1" latinLnBrk="0" hangingPunct="1">
+              <a:spcBef>
+                <a:spcPts val="1000"/>
+              </a:spcBef>
+              <a:spcAft>
+                <a:spcPts val="0"/>
+              </a:spcAft>
+              <a:buClr>
+                <a:schemeClr val="accent1"/>
+              </a:buClr>
+              <a:buFont typeface="Wingdings 3" charset="2"/>
+              <a:buChar char=""/>
+              <a:defRPr sz="1200" kern="1200">
+                <a:solidFill>
+                  <a:schemeClr val="tx1">
+                    <a:lumMod val="75000"/>
+                    <a:lumOff val="25000"/>
+                  </a:schemeClr>
+                </a:solidFill>
+                <a:latin typeface="+mn-lt"/>
+                <a:ea typeface="+mn-ea"/>
+                <a:cs typeface="+mn-cs"/>
+              </a:defRPr>
+            </a:lvl6pPr>
+            <a:lvl7pPr marL="2971800" indent="-228600" algn="l" defTabSz="457200" rtl="0" eaLnBrk="1" latinLnBrk="0" hangingPunct="1">
+              <a:spcBef>
+                <a:spcPts val="1000"/>
+              </a:spcBef>
+              <a:spcAft>
+                <a:spcPts val="0"/>
+              </a:spcAft>
+              <a:buClr>
+                <a:schemeClr val="accent1"/>
+              </a:buClr>
+              <a:buFont typeface="Wingdings 3" charset="2"/>
+              <a:buChar char=""/>
+              <a:defRPr sz="1200" kern="1200">
+                <a:solidFill>
+                  <a:schemeClr val="tx1">
+                    <a:lumMod val="75000"/>
+                    <a:lumOff val="25000"/>
+                  </a:schemeClr>
+                </a:solidFill>
+                <a:latin typeface="+mn-lt"/>
+                <a:ea typeface="+mn-ea"/>
+                <a:cs typeface="+mn-cs"/>
+              </a:defRPr>
+            </a:lvl7pPr>
+            <a:lvl8pPr marL="3429000" indent="-228600" algn="l" defTabSz="457200" rtl="0" eaLnBrk="1" latinLnBrk="0" hangingPunct="1">
+              <a:spcBef>
+                <a:spcPts val="1000"/>
+              </a:spcBef>
+              <a:spcAft>
+                <a:spcPts val="0"/>
+              </a:spcAft>
+              <a:buClr>
+                <a:schemeClr val="accent1"/>
+              </a:buClr>
+              <a:buFont typeface="Wingdings 3" charset="2"/>
+              <a:buChar char=""/>
+              <a:defRPr sz="1200" kern="1200">
+                <a:solidFill>
+                  <a:schemeClr val="tx1">
+                    <a:lumMod val="75000"/>
+                    <a:lumOff val="25000"/>
+                  </a:schemeClr>
+                </a:solidFill>
+                <a:latin typeface="+mn-lt"/>
+                <a:ea typeface="+mn-ea"/>
+                <a:cs typeface="+mn-cs"/>
+              </a:defRPr>
+            </a:lvl8pPr>
+            <a:lvl9pPr marL="3886200" indent="-228600" algn="l" defTabSz="457200" rtl="0" eaLnBrk="1" latinLnBrk="0" hangingPunct="1">
+              <a:spcBef>
+                <a:spcPts val="1000"/>
+              </a:spcBef>
+              <a:spcAft>
+                <a:spcPts val="0"/>
+              </a:spcAft>
+              <a:buClr>
+                <a:schemeClr val="accent1"/>
+              </a:buClr>
+              <a:buFont typeface="Wingdings 3" charset="2"/>
+              <a:buChar char=""/>
+              <a:defRPr sz="1200" kern="1200">
+                <a:solidFill>
+                  <a:schemeClr val="tx1">
+                    <a:lumMod val="75000"/>
+                    <a:lumOff val="25000"/>
+                  </a:schemeClr>
+                </a:solidFill>
+                <a:latin typeface="+mn-lt"/>
+                <a:ea typeface="+mn-ea"/>
+                <a:cs typeface="+mn-cs"/>
+              </a:defRPr>
+            </a:lvl9pPr>
+          </a:lstStyle>
+          <a:p>
+            <a:pPr marL="0" indent="0">
+              <a:buFont typeface="Wingdings 3" charset="2"/>
+              <a:buNone/>
+            </a:pPr>
+            <a:r>
+              <a:rPr lang="en-US" dirty="0"/>
+              <a:t>✅ </a:t>
+            </a:r>
+            <a:r>
+              <a:rPr lang="en-US" b="1" dirty="0">
+                <a:solidFill>
+                  <a:schemeClr val="bg1"/>
+                </a:solidFill>
+              </a:rPr>
+              <a:t>Datasets with rough loss gradients</a:t>
+            </a:r>
+          </a:p>
+          <a:p>
+            <a:pPr marL="0" indent="0">
+              <a:buFont typeface="Wingdings 3" charset="2"/>
+              <a:buNone/>
+            </a:pPr>
+            <a:r>
+              <a:rPr lang="en-US" b="1" dirty="0">
+                <a:solidFill>
+                  <a:schemeClr val="bg1"/>
+                </a:solidFill>
+              </a:rPr>
+              <a:t>❌Lags at datasets with smoother gradients</a:t>
+            </a:r>
+          </a:p>
+          <a:p>
+            <a:endParaRPr lang="en-US" b="1" dirty="0"/>
+          </a:p>
+        </p:txBody>
+      </p:sp>
+      <p:sp>
+        <p:nvSpPr>
+          <p:cNvPr id="9" name="Content Placeholder 2">
+            <a:extLst>
+              <a:ext uri="{FF2B5EF4-FFF2-40B4-BE49-F238E27FC236}">
+                <a16:creationId xmlns:a16="http://schemas.microsoft.com/office/drawing/2014/main" id="{D748078A-07DF-4DCE-BAA5-1DAE3A36CC7A}"/>
+              </a:ext>
+            </a:extLst>
+          </p:cNvPr>
+          <p:cNvSpPr txBox="1">
+            <a:spLocks/>
+          </p:cNvSpPr>
+          <p:nvPr/>
+        </p:nvSpPr>
+        <p:spPr>
+          <a:xfrm>
+            <a:off x="4475699" y="5039031"/>
+            <a:ext cx="3313471" cy="1410927"/>
+          </a:xfrm>
+          <a:prstGeom prst="rect">
+            <a:avLst/>
+          </a:prstGeom>
+        </p:spPr>
+        <p:style>
+          <a:lnRef idx="3">
+            <a:schemeClr val="lt1"/>
+          </a:lnRef>
+          <a:fillRef idx="1">
+            <a:schemeClr val="accent1"/>
+          </a:fillRef>
+          <a:effectRef idx="1">
+            <a:schemeClr val="accent1"/>
+          </a:effectRef>
+          <a:fontRef idx="minor">
+            <a:schemeClr val="lt1"/>
+          </a:fontRef>
+        </p:style>
+        <p:txBody>
+          <a:bodyPr vert="horz" lIns="91440" tIns="45720" rIns="91440" bIns="45720" rtlCol="0">
+            <a:normAutofit/>
+          </a:bodyPr>
+          <a:lstStyle>
+            <a:lvl1pPr marL="342900" indent="-342900" algn="l" defTabSz="457200" rtl="0" eaLnBrk="1" latinLnBrk="0" hangingPunct="1">
+              <a:spcBef>
+                <a:spcPts val="1000"/>
+              </a:spcBef>
+              <a:spcAft>
+                <a:spcPts val="0"/>
+              </a:spcAft>
+              <a:buClr>
+                <a:schemeClr val="accent1"/>
+              </a:buClr>
+              <a:buFont typeface="Wingdings 3" charset="2"/>
+              <a:buChar char=""/>
+              <a:defRPr sz="1800" kern="1200">
+                <a:solidFill>
+                  <a:schemeClr val="tx1">
+                    <a:lumMod val="75000"/>
+                    <a:lumOff val="25000"/>
+                  </a:schemeClr>
+                </a:solidFill>
+                <a:latin typeface="+mn-lt"/>
+                <a:ea typeface="+mn-ea"/>
+                <a:cs typeface="+mn-cs"/>
+              </a:defRPr>
+            </a:lvl1pPr>
+            <a:lvl2pPr marL="742950" indent="-285750" algn="l" defTabSz="457200" rtl="0" eaLnBrk="1" latinLnBrk="0" hangingPunct="1">
+              <a:spcBef>
+                <a:spcPts val="1000"/>
+              </a:spcBef>
+              <a:spcAft>
+                <a:spcPts val="0"/>
+              </a:spcAft>
+              <a:buClr>
+                <a:schemeClr val="accent1"/>
+              </a:buClr>
+              <a:buFont typeface="Wingdings 3" charset="2"/>
+              <a:buChar char=""/>
+              <a:defRPr sz="1600" kern="1200">
+                <a:solidFill>
+                  <a:schemeClr val="tx1">
+                    <a:lumMod val="75000"/>
+                    <a:lumOff val="25000"/>
+                  </a:schemeClr>
+                </a:solidFill>
+                <a:latin typeface="+mn-lt"/>
+                <a:ea typeface="+mn-ea"/>
+                <a:cs typeface="+mn-cs"/>
+              </a:defRPr>
+            </a:lvl2pPr>
+            <a:lvl3pPr marL="1143000" indent="-228600" algn="l" defTabSz="457200" rtl="0" eaLnBrk="1" latinLnBrk="0" hangingPunct="1">
+              <a:spcBef>
+                <a:spcPts val="1000"/>
+              </a:spcBef>
+              <a:spcAft>
+                <a:spcPts val="0"/>
+              </a:spcAft>
+              <a:buClr>
+                <a:schemeClr val="accent1"/>
+              </a:buClr>
+              <a:buFont typeface="Wingdings 3" charset="2"/>
+              <a:buChar char=""/>
+              <a:defRPr sz="1400" kern="1200">
+                <a:solidFill>
+                  <a:schemeClr val="tx1">
+                    <a:lumMod val="75000"/>
+                    <a:lumOff val="25000"/>
+                  </a:schemeClr>
+                </a:solidFill>
+                <a:latin typeface="+mn-lt"/>
+                <a:ea typeface="+mn-ea"/>
+                <a:cs typeface="+mn-cs"/>
+              </a:defRPr>
+            </a:lvl3pPr>
+            <a:lvl4pPr marL="1600200" indent="-228600" algn="l" defTabSz="457200" rtl="0" eaLnBrk="1" latinLnBrk="0" hangingPunct="1">
+              <a:spcBef>
+                <a:spcPts val="1000"/>
+              </a:spcBef>
+              <a:spcAft>
+                <a:spcPts val="0"/>
+              </a:spcAft>
+              <a:buClr>
+                <a:schemeClr val="accent1"/>
+              </a:buClr>
+              <a:buFont typeface="Wingdings 3" charset="2"/>
+              <a:buChar char=""/>
+              <a:defRPr sz="1200" kern="1200">
+                <a:solidFill>
+                  <a:schemeClr val="tx1">
+                    <a:lumMod val="75000"/>
+                    <a:lumOff val="25000"/>
+                  </a:schemeClr>
+                </a:solidFill>
+                <a:latin typeface="+mn-lt"/>
+                <a:ea typeface="+mn-ea"/>
+                <a:cs typeface="+mn-cs"/>
+              </a:defRPr>
+            </a:lvl4pPr>
+            <a:lvl5pPr marL="2057400" indent="-228600" algn="l" defTabSz="457200" rtl="0" eaLnBrk="1" latinLnBrk="0" hangingPunct="1">
+              <a:spcBef>
+                <a:spcPts val="1000"/>
+              </a:spcBef>
+              <a:spcAft>
+                <a:spcPts val="0"/>
+              </a:spcAft>
+              <a:buClr>
+                <a:schemeClr val="accent1"/>
+              </a:buClr>
+              <a:buFont typeface="Wingdings 3" charset="2"/>
+              <a:buChar char=""/>
+              <a:defRPr sz="1200" kern="1200">
+                <a:solidFill>
+                  <a:schemeClr val="tx1">
+                    <a:lumMod val="75000"/>
+                    <a:lumOff val="25000"/>
+                  </a:schemeClr>
+                </a:solidFill>
+                <a:latin typeface="+mn-lt"/>
+                <a:ea typeface="+mn-ea"/>
+                <a:cs typeface="+mn-cs"/>
+              </a:defRPr>
+            </a:lvl5pPr>
+            <a:lvl6pPr marL="2514600" indent="-228600" algn="l" defTabSz="457200" rtl="0" eaLnBrk="1" latinLnBrk="0" hangingPunct="1">
+              <a:spcBef>
+                <a:spcPts val="1000"/>
+              </a:spcBef>
+              <a:spcAft>
+                <a:spcPts val="0"/>
+              </a:spcAft>
+              <a:buClr>
+                <a:schemeClr val="accent1"/>
+              </a:buClr>
+              <a:buFont typeface="Wingdings 3" charset="2"/>
+              <a:buChar char=""/>
+              <a:defRPr sz="1200" kern="1200">
+                <a:solidFill>
+                  <a:schemeClr val="tx1">
+                    <a:lumMod val="75000"/>
+                    <a:lumOff val="25000"/>
+                  </a:schemeClr>
+                </a:solidFill>
+                <a:latin typeface="+mn-lt"/>
+                <a:ea typeface="+mn-ea"/>
+                <a:cs typeface="+mn-cs"/>
+              </a:defRPr>
+            </a:lvl6pPr>
+            <a:lvl7pPr marL="2971800" indent="-228600" algn="l" defTabSz="457200" rtl="0" eaLnBrk="1" latinLnBrk="0" hangingPunct="1">
+              <a:spcBef>
+                <a:spcPts val="1000"/>
+              </a:spcBef>
+              <a:spcAft>
+                <a:spcPts val="0"/>
+              </a:spcAft>
+              <a:buClr>
+                <a:schemeClr val="accent1"/>
+              </a:buClr>
+              <a:buFont typeface="Wingdings 3" charset="2"/>
+              <a:buChar char=""/>
+              <a:defRPr sz="1200" kern="1200">
+                <a:solidFill>
+                  <a:schemeClr val="tx1">
+                    <a:lumMod val="75000"/>
+                    <a:lumOff val="25000"/>
+                  </a:schemeClr>
+                </a:solidFill>
+                <a:latin typeface="+mn-lt"/>
+                <a:ea typeface="+mn-ea"/>
+                <a:cs typeface="+mn-cs"/>
+              </a:defRPr>
+            </a:lvl7pPr>
+            <a:lvl8pPr marL="3429000" indent="-228600" algn="l" defTabSz="457200" rtl="0" eaLnBrk="1" latinLnBrk="0" hangingPunct="1">
+              <a:spcBef>
+                <a:spcPts val="1000"/>
+              </a:spcBef>
+              <a:spcAft>
+                <a:spcPts val="0"/>
+              </a:spcAft>
+              <a:buClr>
+                <a:schemeClr val="accent1"/>
+              </a:buClr>
+              <a:buFont typeface="Wingdings 3" charset="2"/>
+              <a:buChar char=""/>
+              <a:defRPr sz="1200" kern="1200">
+                <a:solidFill>
+                  <a:schemeClr val="tx1">
+                    <a:lumMod val="75000"/>
+                    <a:lumOff val="25000"/>
+                  </a:schemeClr>
+                </a:solidFill>
+                <a:latin typeface="+mn-lt"/>
+                <a:ea typeface="+mn-ea"/>
+                <a:cs typeface="+mn-cs"/>
+              </a:defRPr>
+            </a:lvl8pPr>
+            <a:lvl9pPr marL="3886200" indent="-228600" algn="l" defTabSz="457200" rtl="0" eaLnBrk="1" latinLnBrk="0" hangingPunct="1">
+              <a:spcBef>
+                <a:spcPts val="1000"/>
+              </a:spcBef>
+              <a:spcAft>
+                <a:spcPts val="0"/>
+              </a:spcAft>
+              <a:buClr>
+                <a:schemeClr val="accent1"/>
+              </a:buClr>
+              <a:buFont typeface="Wingdings 3" charset="2"/>
+              <a:buChar char=""/>
+              <a:defRPr sz="1200" kern="1200">
+                <a:solidFill>
+                  <a:schemeClr val="tx1">
+                    <a:lumMod val="75000"/>
+                    <a:lumOff val="25000"/>
+                  </a:schemeClr>
+                </a:solidFill>
+                <a:latin typeface="+mn-lt"/>
+                <a:ea typeface="+mn-ea"/>
+                <a:cs typeface="+mn-cs"/>
+              </a:defRPr>
+            </a:lvl9pPr>
+          </a:lstStyle>
+          <a:p>
+            <a:pPr marL="0" indent="0">
+              <a:buNone/>
+            </a:pPr>
+            <a:r>
+              <a:rPr lang="en-US" b="1" dirty="0">
+                <a:solidFill>
+                  <a:schemeClr val="bg1"/>
+                </a:solidFill>
+              </a:rPr>
+              <a:t>✅ Versatile, well-rounded algorithm</a:t>
+            </a:r>
+          </a:p>
+          <a:p>
+            <a:pPr marL="0" indent="0">
+              <a:buNone/>
+            </a:pPr>
+            <a:r>
+              <a:rPr lang="en-US" b="1" dirty="0">
+                <a:solidFill>
+                  <a:schemeClr val="bg1"/>
+                </a:solidFill>
+              </a:rPr>
+              <a:t>❌ Limited by its weight decay calculation</a:t>
+            </a:r>
+          </a:p>
+        </p:txBody>
+      </p:sp>
+      <p:sp>
+        <p:nvSpPr>
+          <p:cNvPr id="13" name="Content Placeholder 2">
+            <a:extLst>
+              <a:ext uri="{FF2B5EF4-FFF2-40B4-BE49-F238E27FC236}">
+                <a16:creationId xmlns:a16="http://schemas.microsoft.com/office/drawing/2014/main" id="{69F2A5B6-F780-92B0-2D75-1A1EF32453AA}"/>
+              </a:ext>
+            </a:extLst>
+          </p:cNvPr>
+          <p:cNvSpPr txBox="1">
+            <a:spLocks/>
+          </p:cNvSpPr>
+          <p:nvPr/>
+        </p:nvSpPr>
+        <p:spPr>
+          <a:xfrm>
+            <a:off x="7868698" y="5043946"/>
+            <a:ext cx="3313471" cy="1410927"/>
+          </a:xfrm>
+          <a:prstGeom prst="rect">
+            <a:avLst/>
+          </a:prstGeom>
+        </p:spPr>
+        <p:style>
+          <a:lnRef idx="3">
+            <a:schemeClr val="lt1"/>
+          </a:lnRef>
+          <a:fillRef idx="1">
+            <a:schemeClr val="accent1"/>
+          </a:fillRef>
+          <a:effectRef idx="1">
+            <a:schemeClr val="accent1"/>
+          </a:effectRef>
+          <a:fontRef idx="minor">
+            <a:schemeClr val="lt1"/>
+          </a:fontRef>
+        </p:style>
+        <p:txBody>
+          <a:bodyPr vert="horz" lIns="91440" tIns="45720" rIns="91440" bIns="45720" rtlCol="0">
+            <a:normAutofit/>
+          </a:bodyPr>
+          <a:lstStyle>
+            <a:lvl1pPr marL="342900" indent="-342900" algn="l" defTabSz="457200" rtl="0" eaLnBrk="1" latinLnBrk="0" hangingPunct="1">
+              <a:spcBef>
+                <a:spcPts val="1000"/>
+              </a:spcBef>
+              <a:spcAft>
+                <a:spcPts val="0"/>
+              </a:spcAft>
+              <a:buClr>
+                <a:schemeClr val="accent1"/>
+              </a:buClr>
+              <a:buFont typeface="Wingdings 3" charset="2"/>
+              <a:buChar char=""/>
+              <a:defRPr sz="1800" kern="1200">
+                <a:solidFill>
+                  <a:schemeClr val="tx1">
+                    <a:lumMod val="75000"/>
+                    <a:lumOff val="25000"/>
+                  </a:schemeClr>
+                </a:solidFill>
+                <a:latin typeface="+mn-lt"/>
+                <a:ea typeface="+mn-ea"/>
+                <a:cs typeface="+mn-cs"/>
+              </a:defRPr>
+            </a:lvl1pPr>
+            <a:lvl2pPr marL="742950" indent="-285750" algn="l" defTabSz="457200" rtl="0" eaLnBrk="1" latinLnBrk="0" hangingPunct="1">
+              <a:spcBef>
+                <a:spcPts val="1000"/>
+              </a:spcBef>
+              <a:spcAft>
+                <a:spcPts val="0"/>
+              </a:spcAft>
+              <a:buClr>
+                <a:schemeClr val="accent1"/>
+              </a:buClr>
+              <a:buFont typeface="Wingdings 3" charset="2"/>
+              <a:buChar char=""/>
+              <a:defRPr sz="1600" kern="1200">
+                <a:solidFill>
+                  <a:schemeClr val="tx1">
+                    <a:lumMod val="75000"/>
+                    <a:lumOff val="25000"/>
+                  </a:schemeClr>
+                </a:solidFill>
+                <a:latin typeface="+mn-lt"/>
+                <a:ea typeface="+mn-ea"/>
+                <a:cs typeface="+mn-cs"/>
+              </a:defRPr>
+            </a:lvl2pPr>
+            <a:lvl3pPr marL="1143000" indent="-228600" algn="l" defTabSz="457200" rtl="0" eaLnBrk="1" latinLnBrk="0" hangingPunct="1">
+              <a:spcBef>
+                <a:spcPts val="1000"/>
+              </a:spcBef>
+              <a:spcAft>
+                <a:spcPts val="0"/>
+              </a:spcAft>
+              <a:buClr>
+                <a:schemeClr val="accent1"/>
+              </a:buClr>
+              <a:buFont typeface="Wingdings 3" charset="2"/>
+              <a:buChar char=""/>
+              <a:defRPr sz="1400" kern="1200">
+                <a:solidFill>
+                  <a:schemeClr val="tx1">
+                    <a:lumMod val="75000"/>
+                    <a:lumOff val="25000"/>
+                  </a:schemeClr>
+                </a:solidFill>
+                <a:latin typeface="+mn-lt"/>
+                <a:ea typeface="+mn-ea"/>
+                <a:cs typeface="+mn-cs"/>
+              </a:defRPr>
+            </a:lvl3pPr>
+            <a:lvl4pPr marL="1600200" indent="-228600" algn="l" defTabSz="457200" rtl="0" eaLnBrk="1" latinLnBrk="0" hangingPunct="1">
+              <a:spcBef>
+                <a:spcPts val="1000"/>
+              </a:spcBef>
+              <a:spcAft>
+                <a:spcPts val="0"/>
+              </a:spcAft>
+              <a:buClr>
+                <a:schemeClr val="accent1"/>
+              </a:buClr>
+              <a:buFont typeface="Wingdings 3" charset="2"/>
+              <a:buChar char=""/>
+              <a:defRPr sz="1200" kern="1200">
+                <a:solidFill>
+                  <a:schemeClr val="tx1">
+                    <a:lumMod val="75000"/>
+                    <a:lumOff val="25000"/>
+                  </a:schemeClr>
+                </a:solidFill>
+                <a:latin typeface="+mn-lt"/>
+                <a:ea typeface="+mn-ea"/>
+                <a:cs typeface="+mn-cs"/>
+              </a:defRPr>
+            </a:lvl4pPr>
+            <a:lvl5pPr marL="2057400" indent="-228600" algn="l" defTabSz="457200" rtl="0" eaLnBrk="1" latinLnBrk="0" hangingPunct="1">
+              <a:spcBef>
+                <a:spcPts val="1000"/>
+              </a:spcBef>
+              <a:spcAft>
+                <a:spcPts val="0"/>
+              </a:spcAft>
+              <a:buClr>
+                <a:schemeClr val="accent1"/>
+              </a:buClr>
+              <a:buFont typeface="Wingdings 3" charset="2"/>
+              <a:buChar char=""/>
+              <a:defRPr sz="1200" kern="1200">
+                <a:solidFill>
+                  <a:schemeClr val="tx1">
+                    <a:lumMod val="75000"/>
+                    <a:lumOff val="25000"/>
+                  </a:schemeClr>
+                </a:solidFill>
+                <a:latin typeface="+mn-lt"/>
+                <a:ea typeface="+mn-ea"/>
+                <a:cs typeface="+mn-cs"/>
+              </a:defRPr>
+            </a:lvl5pPr>
+            <a:lvl6pPr marL="2514600" indent="-228600" algn="l" defTabSz="457200" rtl="0" eaLnBrk="1" latinLnBrk="0" hangingPunct="1">
+              <a:spcBef>
+                <a:spcPts val="1000"/>
+              </a:spcBef>
+              <a:spcAft>
+                <a:spcPts val="0"/>
+              </a:spcAft>
+              <a:buClr>
+                <a:schemeClr val="accent1"/>
+              </a:buClr>
+              <a:buFont typeface="Wingdings 3" charset="2"/>
+              <a:buChar char=""/>
+              <a:defRPr sz="1200" kern="1200">
+                <a:solidFill>
+                  <a:schemeClr val="tx1">
+                    <a:lumMod val="75000"/>
+                    <a:lumOff val="25000"/>
+                  </a:schemeClr>
+                </a:solidFill>
+                <a:latin typeface="+mn-lt"/>
+                <a:ea typeface="+mn-ea"/>
+                <a:cs typeface="+mn-cs"/>
+              </a:defRPr>
+            </a:lvl6pPr>
+            <a:lvl7pPr marL="2971800" indent="-228600" algn="l" defTabSz="457200" rtl="0" eaLnBrk="1" latinLnBrk="0" hangingPunct="1">
+              <a:spcBef>
+                <a:spcPts val="1000"/>
+              </a:spcBef>
+              <a:spcAft>
+                <a:spcPts val="0"/>
+              </a:spcAft>
+              <a:buClr>
+                <a:schemeClr val="accent1"/>
+              </a:buClr>
+              <a:buFont typeface="Wingdings 3" charset="2"/>
+              <a:buChar char=""/>
+              <a:defRPr sz="1200" kern="1200">
+                <a:solidFill>
+                  <a:schemeClr val="tx1">
+                    <a:lumMod val="75000"/>
+                    <a:lumOff val="25000"/>
+                  </a:schemeClr>
+                </a:solidFill>
+                <a:latin typeface="+mn-lt"/>
+                <a:ea typeface="+mn-ea"/>
+                <a:cs typeface="+mn-cs"/>
+              </a:defRPr>
+            </a:lvl7pPr>
+            <a:lvl8pPr marL="3429000" indent="-228600" algn="l" defTabSz="457200" rtl="0" eaLnBrk="1" latinLnBrk="0" hangingPunct="1">
+              <a:spcBef>
+                <a:spcPts val="1000"/>
+              </a:spcBef>
+              <a:spcAft>
+                <a:spcPts val="0"/>
+              </a:spcAft>
+              <a:buClr>
+                <a:schemeClr val="accent1"/>
+              </a:buClr>
+              <a:buFont typeface="Wingdings 3" charset="2"/>
+              <a:buChar char=""/>
+              <a:defRPr sz="1200" kern="1200">
+                <a:solidFill>
+                  <a:schemeClr val="tx1">
+                    <a:lumMod val="75000"/>
+                    <a:lumOff val="25000"/>
+                  </a:schemeClr>
+                </a:solidFill>
+                <a:latin typeface="+mn-lt"/>
+                <a:ea typeface="+mn-ea"/>
+                <a:cs typeface="+mn-cs"/>
+              </a:defRPr>
+            </a:lvl8pPr>
+            <a:lvl9pPr marL="3886200" indent="-228600" algn="l" defTabSz="457200" rtl="0" eaLnBrk="1" latinLnBrk="0" hangingPunct="1">
+              <a:spcBef>
+                <a:spcPts val="1000"/>
+              </a:spcBef>
+              <a:spcAft>
+                <a:spcPts val="0"/>
+              </a:spcAft>
+              <a:buClr>
+                <a:schemeClr val="accent1"/>
+              </a:buClr>
+              <a:buFont typeface="Wingdings 3" charset="2"/>
+              <a:buChar char=""/>
+              <a:defRPr sz="1200" kern="1200">
+                <a:solidFill>
+                  <a:schemeClr val="tx1">
+                    <a:lumMod val="75000"/>
+                    <a:lumOff val="25000"/>
+                  </a:schemeClr>
+                </a:solidFill>
+                <a:latin typeface="+mn-lt"/>
+                <a:ea typeface="+mn-ea"/>
+                <a:cs typeface="+mn-cs"/>
+              </a:defRPr>
+            </a:lvl9pPr>
+          </a:lstStyle>
+          <a:p>
+            <a:pPr marL="0" indent="0">
+              <a:buNone/>
+            </a:pPr>
+            <a:r>
+              <a:rPr lang="en-US" b="1" dirty="0">
+                <a:solidFill>
+                  <a:schemeClr val="bg1"/>
+                </a:solidFill>
+              </a:rPr>
+              <a:t>✅ Enhanced Weight Generalization</a:t>
+            </a:r>
+          </a:p>
+          <a:p>
+            <a:pPr marL="0" indent="0">
+              <a:buNone/>
+            </a:pPr>
+            <a:r>
+              <a:rPr lang="en-US" b="1" dirty="0">
+                <a:solidFill>
+                  <a:schemeClr val="bg1"/>
+                </a:solidFill>
+              </a:rPr>
+              <a:t>❌ 2x the memory usage</a:t>
+            </a:r>
           </a:p>
         </p:txBody>
       </p:sp>
@@ -12374,6 +14084,1031 @@
 </file>
 
 <file path=ppt/slides/slide6.xml><?xml version="1.0" encoding="utf-8"?>
+<p:sld xmlns:a="http://schemas.openxmlformats.org/drawingml/2006/main" xmlns:r="http://schemas.openxmlformats.org/officeDocument/2006/relationships" xmlns:p="http://schemas.openxmlformats.org/presentationml/2006/main">
+  <p:cSld>
+    <p:spTree>
+      <p:nvGrpSpPr>
+        <p:cNvPr id="1" name="">
+          <a:extLst>
+            <a:ext uri="{FF2B5EF4-FFF2-40B4-BE49-F238E27FC236}">
+              <a16:creationId xmlns:a16="http://schemas.microsoft.com/office/drawing/2014/main" id="{C1E36B0F-D414-AFE6-4D20-0558757F9503}"/>
+            </a:ext>
+          </a:extLst>
+        </p:cNvPr>
+        <p:cNvGrpSpPr/>
+        <p:nvPr/>
+      </p:nvGrpSpPr>
+      <p:grpSpPr>
+        <a:xfrm>
+          <a:off x="0" y="0"/>
+          <a:ext cx="0" cy="0"/>
+          <a:chOff x="0" y="0"/>
+          <a:chExt cx="0" cy="0"/>
+        </a:xfrm>
+      </p:grpSpPr>
+      <p:sp>
+        <p:nvSpPr>
+          <p:cNvPr id="2" name="Title 1">
+            <a:extLst>
+              <a:ext uri="{FF2B5EF4-FFF2-40B4-BE49-F238E27FC236}">
+                <a16:creationId xmlns:a16="http://schemas.microsoft.com/office/drawing/2014/main" id="{36D387D6-0963-2CEF-1BBD-0D0BAD003771}"/>
+              </a:ext>
+            </a:extLst>
+          </p:cNvPr>
+          <p:cNvSpPr>
+            <a:spLocks noGrp="1"/>
+          </p:cNvSpPr>
+          <p:nvPr>
+            <p:ph type="title"/>
+          </p:nvPr>
+        </p:nvSpPr>
+        <p:spPr/>
+        <p:txBody>
+          <a:bodyPr/>
+          <a:lstStyle/>
+          <a:p>
+            <a:r>
+              <a:rPr lang="en-US" dirty="0"/>
+              <a:t>Common Parameters</a:t>
+            </a:r>
+          </a:p>
+        </p:txBody>
+      </p:sp>
+      <p:sp>
+        <p:nvSpPr>
+          <p:cNvPr id="3" name="Content Placeholder 2">
+            <a:extLst>
+              <a:ext uri="{FF2B5EF4-FFF2-40B4-BE49-F238E27FC236}">
+                <a16:creationId xmlns:a16="http://schemas.microsoft.com/office/drawing/2014/main" id="{E976CDC9-D0BC-B38D-9875-88B554373427}"/>
+              </a:ext>
+            </a:extLst>
+          </p:cNvPr>
+          <p:cNvSpPr>
+            <a:spLocks noGrp="1"/>
+          </p:cNvSpPr>
+          <p:nvPr>
+            <p:ph idx="1"/>
+          </p:nvPr>
+        </p:nvSpPr>
+        <p:spPr>
+          <a:xfrm>
+            <a:off x="930302" y="1504335"/>
+            <a:ext cx="10574310" cy="5240594"/>
+          </a:xfrm>
+        </p:spPr>
+        <p:txBody>
+          <a:bodyPr>
+            <a:normAutofit/>
+          </a:bodyPr>
+          <a:lstStyle/>
+          <a:p>
+            <a:r>
+              <a:rPr lang="en-US" sz="2400" b="1" dirty="0"/>
+              <a:t>Learning Rate </a:t>
+            </a:r>
+            <a:r>
+              <a:rPr lang="en-US" sz="2400" b="1" i="1" dirty="0"/>
+              <a:t>(</a:t>
+            </a:r>
+            <a:r>
+              <a:rPr lang="en-US" sz="2400" b="1" i="1" dirty="0" err="1"/>
+              <a:t>lr</a:t>
+            </a:r>
+            <a:r>
+              <a:rPr lang="en-US" sz="2400" b="1" i="1" dirty="0"/>
+              <a:t>)</a:t>
+            </a:r>
+          </a:p>
+          <a:p>
+            <a:pPr lvl="1"/>
+            <a:r>
+              <a:rPr lang="en-US" sz="2400" dirty="0"/>
+              <a:t> </a:t>
+            </a:r>
+            <a:r>
+              <a:rPr lang="en-US" sz="2200" dirty="0"/>
+              <a:t>Model Learning Rate</a:t>
+            </a:r>
+          </a:p>
+          <a:p>
+            <a:r>
+              <a:rPr lang="en-US" sz="2400" b="1" dirty="0"/>
+              <a:t>Decay Rate (</a:t>
+            </a:r>
+            <a:r>
+              <a:rPr lang="en-US" sz="2400" b="1" i="1" dirty="0"/>
+              <a:t>Alpha (</a:t>
+            </a:r>
+            <a:r>
+              <a:rPr lang="el-GR" sz="2400" b="1" i="1" dirty="0"/>
+              <a:t>α</a:t>
+            </a:r>
+            <a:r>
+              <a:rPr lang="en-US" sz="2400" b="1" i="1" dirty="0"/>
+              <a:t>), Betas (β2))</a:t>
+            </a:r>
+          </a:p>
+          <a:p>
+            <a:pPr lvl="1"/>
+            <a:r>
+              <a:rPr lang="en-US" sz="2400" dirty="0"/>
+              <a:t> </a:t>
+            </a:r>
+            <a:r>
+              <a:rPr lang="en-US" sz="2200" dirty="0"/>
+              <a:t>Historic Gradient scaling rate</a:t>
+            </a:r>
+          </a:p>
+          <a:p>
+            <a:r>
+              <a:rPr lang="en-US" sz="2400" b="1" dirty="0"/>
+              <a:t>Momentum (</a:t>
+            </a:r>
+            <a:r>
+              <a:rPr lang="en-US" sz="2400" b="1" i="1" dirty="0"/>
+              <a:t>momentum, Betas (β1))</a:t>
+            </a:r>
+          </a:p>
+          <a:p>
+            <a:pPr lvl="1"/>
+            <a:r>
+              <a:rPr lang="en-US" sz="2400" b="1" dirty="0"/>
+              <a:t> </a:t>
+            </a:r>
+            <a:r>
+              <a:rPr lang="en-US" sz="2200" dirty="0"/>
+              <a:t>Historic Gradient adjustment rate</a:t>
+            </a:r>
+            <a:endParaRPr lang="en-US" sz="2200" b="1" dirty="0"/>
+          </a:p>
+          <a:p>
+            <a:r>
+              <a:rPr lang="en-US" sz="2400" b="1" dirty="0"/>
+              <a:t>Epsilon (</a:t>
+            </a:r>
+            <a:r>
+              <a:rPr lang="en-US" sz="2400" b="1" i="1" dirty="0"/>
+              <a:t>eps, ε)</a:t>
+            </a:r>
+          </a:p>
+          <a:p>
+            <a:pPr lvl="1"/>
+            <a:r>
+              <a:rPr lang="en-US" sz="2400" b="1" i="1" dirty="0"/>
+              <a:t> </a:t>
+            </a:r>
+            <a:r>
+              <a:rPr lang="en-US" sz="2200" dirty="0"/>
+              <a:t>Prevents zero division during gradient calculation</a:t>
+            </a:r>
+          </a:p>
+          <a:p>
+            <a:r>
+              <a:rPr lang="en-US" sz="2400" b="1" dirty="0"/>
+              <a:t>Weight Decay </a:t>
+            </a:r>
+            <a:r>
+              <a:rPr lang="en-US" sz="2400" b="1" i="1" dirty="0"/>
+              <a:t>(</a:t>
+            </a:r>
+            <a:r>
+              <a:rPr lang="en-US" sz="2400" b="1" i="1" dirty="0" err="1"/>
+              <a:t>weight_decay</a:t>
+            </a:r>
+            <a:r>
+              <a:rPr lang="en-US" sz="2400" b="1" i="1" dirty="0"/>
+              <a:t>)</a:t>
+            </a:r>
+          </a:p>
+          <a:p>
+            <a:pPr lvl="1"/>
+            <a:r>
+              <a:rPr lang="en-US" sz="2200" dirty="0"/>
+              <a:t>Weight adjustment penalization </a:t>
+            </a:r>
+            <a:endParaRPr lang="en-US" sz="2200" b="1" dirty="0"/>
+          </a:p>
+          <a:p>
+            <a:endParaRPr lang="en-US" sz="2400" b="1" dirty="0"/>
+          </a:p>
+        </p:txBody>
+      </p:sp>
+    </p:spTree>
+    <p:extLst>
+      <p:ext uri="{BB962C8B-B14F-4D97-AF65-F5344CB8AC3E}">
+        <p14:creationId xmlns:p14="http://schemas.microsoft.com/office/powerpoint/2010/main" val="2682204246"/>
+      </p:ext>
+    </p:extLst>
+  </p:cSld>
+  <p:clrMapOvr>
+    <a:masterClrMapping/>
+  </p:clrMapOvr>
+</p:sld>
+</file>
+
+<file path=ppt/slides/slide7.xml><?xml version="1.0" encoding="utf-8"?>
+<p:sld xmlns:a="http://schemas.openxmlformats.org/drawingml/2006/main" xmlns:r="http://schemas.openxmlformats.org/officeDocument/2006/relationships" xmlns:p="http://schemas.openxmlformats.org/presentationml/2006/main">
+  <p:cSld>
+    <p:spTree>
+      <p:nvGrpSpPr>
+        <p:cNvPr id="1" name=""/>
+        <p:cNvGrpSpPr/>
+        <p:nvPr/>
+      </p:nvGrpSpPr>
+      <p:grpSpPr>
+        <a:xfrm>
+          <a:off x="0" y="0"/>
+          <a:ext cx="0" cy="0"/>
+          <a:chOff x="0" y="0"/>
+          <a:chExt cx="0" cy="0"/>
+        </a:xfrm>
+      </p:grpSpPr>
+      <p:sp>
+        <p:nvSpPr>
+          <p:cNvPr id="2" name="Title 1">
+            <a:extLst>
+              <a:ext uri="{FF2B5EF4-FFF2-40B4-BE49-F238E27FC236}">
+                <a16:creationId xmlns:a16="http://schemas.microsoft.com/office/drawing/2014/main" id="{DE35B9BB-0377-D509-77D0-26C2B5905242}"/>
+              </a:ext>
+            </a:extLst>
+          </p:cNvPr>
+          <p:cNvSpPr>
+            <a:spLocks noGrp="1"/>
+          </p:cNvSpPr>
+          <p:nvPr>
+            <p:ph type="title"/>
+          </p:nvPr>
+        </p:nvSpPr>
+        <p:spPr>
+          <a:xfrm>
+            <a:off x="2592925" y="624110"/>
+            <a:ext cx="8911687" cy="722909"/>
+          </a:xfrm>
+        </p:spPr>
+        <p:txBody>
+          <a:bodyPr/>
+          <a:lstStyle/>
+          <a:p>
+            <a:r>
+              <a:rPr lang="en-US" dirty="0"/>
+              <a:t>Algorithm-specific Parameters</a:t>
+            </a:r>
+          </a:p>
+        </p:txBody>
+      </p:sp>
+      <p:sp>
+        <p:nvSpPr>
+          <p:cNvPr id="4" name="Content Placeholder 2">
+            <a:extLst>
+              <a:ext uri="{FF2B5EF4-FFF2-40B4-BE49-F238E27FC236}">
+                <a16:creationId xmlns:a16="http://schemas.microsoft.com/office/drawing/2014/main" id="{640B6E96-6D1F-F164-13E2-AF2305F2F1FA}"/>
+              </a:ext>
+            </a:extLst>
+          </p:cNvPr>
+          <p:cNvSpPr>
+            <a:spLocks noGrp="1"/>
+          </p:cNvSpPr>
+          <p:nvPr>
+            <p:ph idx="1"/>
+          </p:nvPr>
+        </p:nvSpPr>
+        <p:spPr>
+          <a:xfrm>
+            <a:off x="930303" y="1632155"/>
+            <a:ext cx="3169750" cy="4817806"/>
+          </a:xfrm>
+        </p:spPr>
+        <p:txBody>
+          <a:bodyPr>
+            <a:normAutofit/>
+          </a:bodyPr>
+          <a:lstStyle/>
+          <a:p>
+            <a:pPr marL="0" indent="0">
+              <a:buNone/>
+            </a:pPr>
+            <a:r>
+              <a:rPr lang="en-US" sz="2800" b="1" dirty="0"/>
+              <a:t>RMSProp</a:t>
+            </a:r>
+          </a:p>
+          <a:p>
+            <a:pPr marL="0" indent="0">
+              <a:buNone/>
+            </a:pPr>
+            <a:endParaRPr lang="en-US" b="1" dirty="0"/>
+          </a:p>
+          <a:p>
+            <a:pPr marL="0" indent="0">
+              <a:buNone/>
+            </a:pPr>
+            <a:r>
+              <a:rPr lang="en-US" b="1" dirty="0"/>
+              <a:t>Centered </a:t>
+            </a:r>
+            <a:r>
+              <a:rPr lang="en-US" b="1" i="1" dirty="0"/>
+              <a:t>(centered) </a:t>
+            </a:r>
+          </a:p>
+          <a:p>
+            <a:r>
+              <a:rPr lang="en-US" i="1" dirty="0"/>
+              <a:t>Applies a normalization to the gradients using variance estimation</a:t>
+            </a:r>
+          </a:p>
+          <a:p>
+            <a:r>
+              <a:rPr lang="en-US" i="1" dirty="0"/>
+              <a:t>Extra gradient calculation = more stable updates but more training time</a:t>
+            </a:r>
+          </a:p>
+          <a:p>
+            <a:endParaRPr lang="en-US" dirty="0"/>
+          </a:p>
+          <a:p>
+            <a:endParaRPr lang="en-US" b="1" dirty="0"/>
+          </a:p>
+        </p:txBody>
+      </p:sp>
+      <p:sp>
+        <p:nvSpPr>
+          <p:cNvPr id="5" name="Content Placeholder 2">
+            <a:extLst>
+              <a:ext uri="{FF2B5EF4-FFF2-40B4-BE49-F238E27FC236}">
+                <a16:creationId xmlns:a16="http://schemas.microsoft.com/office/drawing/2014/main" id="{FD824A2D-44AA-9155-2DF3-72BD7333D313}"/>
+              </a:ext>
+            </a:extLst>
+          </p:cNvPr>
+          <p:cNvSpPr txBox="1">
+            <a:spLocks/>
+          </p:cNvSpPr>
+          <p:nvPr/>
+        </p:nvSpPr>
+        <p:spPr>
+          <a:xfrm>
+            <a:off x="4211677" y="1632155"/>
+            <a:ext cx="3545398" cy="4817806"/>
+          </a:xfrm>
+          <a:prstGeom prst="rect">
+            <a:avLst/>
+          </a:prstGeom>
+        </p:spPr>
+        <p:txBody>
+          <a:bodyPr vert="horz" lIns="91440" tIns="45720" rIns="91440" bIns="45720" rtlCol="0">
+            <a:normAutofit/>
+          </a:bodyPr>
+          <a:lstStyle>
+            <a:lvl1pPr marL="342900" indent="-342900" algn="l" defTabSz="457200" rtl="0" eaLnBrk="1" latinLnBrk="0" hangingPunct="1">
+              <a:spcBef>
+                <a:spcPts val="1000"/>
+              </a:spcBef>
+              <a:spcAft>
+                <a:spcPts val="0"/>
+              </a:spcAft>
+              <a:buClr>
+                <a:schemeClr val="accent1"/>
+              </a:buClr>
+              <a:buFont typeface="Wingdings 3" charset="2"/>
+              <a:buChar char=""/>
+              <a:defRPr sz="1800" kern="1200">
+                <a:solidFill>
+                  <a:schemeClr val="tx1">
+                    <a:lumMod val="75000"/>
+                    <a:lumOff val="25000"/>
+                  </a:schemeClr>
+                </a:solidFill>
+                <a:latin typeface="+mn-lt"/>
+                <a:ea typeface="+mn-ea"/>
+                <a:cs typeface="+mn-cs"/>
+              </a:defRPr>
+            </a:lvl1pPr>
+            <a:lvl2pPr marL="742950" indent="-285750" algn="l" defTabSz="457200" rtl="0" eaLnBrk="1" latinLnBrk="0" hangingPunct="1">
+              <a:spcBef>
+                <a:spcPts val="1000"/>
+              </a:spcBef>
+              <a:spcAft>
+                <a:spcPts val="0"/>
+              </a:spcAft>
+              <a:buClr>
+                <a:schemeClr val="accent1"/>
+              </a:buClr>
+              <a:buFont typeface="Wingdings 3" charset="2"/>
+              <a:buChar char=""/>
+              <a:defRPr sz="1600" kern="1200">
+                <a:solidFill>
+                  <a:schemeClr val="tx1">
+                    <a:lumMod val="75000"/>
+                    <a:lumOff val="25000"/>
+                  </a:schemeClr>
+                </a:solidFill>
+                <a:latin typeface="+mn-lt"/>
+                <a:ea typeface="+mn-ea"/>
+                <a:cs typeface="+mn-cs"/>
+              </a:defRPr>
+            </a:lvl2pPr>
+            <a:lvl3pPr marL="1143000" indent="-228600" algn="l" defTabSz="457200" rtl="0" eaLnBrk="1" latinLnBrk="0" hangingPunct="1">
+              <a:spcBef>
+                <a:spcPts val="1000"/>
+              </a:spcBef>
+              <a:spcAft>
+                <a:spcPts val="0"/>
+              </a:spcAft>
+              <a:buClr>
+                <a:schemeClr val="accent1"/>
+              </a:buClr>
+              <a:buFont typeface="Wingdings 3" charset="2"/>
+              <a:buChar char=""/>
+              <a:defRPr sz="1400" kern="1200">
+                <a:solidFill>
+                  <a:schemeClr val="tx1">
+                    <a:lumMod val="75000"/>
+                    <a:lumOff val="25000"/>
+                  </a:schemeClr>
+                </a:solidFill>
+                <a:latin typeface="+mn-lt"/>
+                <a:ea typeface="+mn-ea"/>
+                <a:cs typeface="+mn-cs"/>
+              </a:defRPr>
+            </a:lvl3pPr>
+            <a:lvl4pPr marL="1600200" indent="-228600" algn="l" defTabSz="457200" rtl="0" eaLnBrk="1" latinLnBrk="0" hangingPunct="1">
+              <a:spcBef>
+                <a:spcPts val="1000"/>
+              </a:spcBef>
+              <a:spcAft>
+                <a:spcPts val="0"/>
+              </a:spcAft>
+              <a:buClr>
+                <a:schemeClr val="accent1"/>
+              </a:buClr>
+              <a:buFont typeface="Wingdings 3" charset="2"/>
+              <a:buChar char=""/>
+              <a:defRPr sz="1200" kern="1200">
+                <a:solidFill>
+                  <a:schemeClr val="tx1">
+                    <a:lumMod val="75000"/>
+                    <a:lumOff val="25000"/>
+                  </a:schemeClr>
+                </a:solidFill>
+                <a:latin typeface="+mn-lt"/>
+                <a:ea typeface="+mn-ea"/>
+                <a:cs typeface="+mn-cs"/>
+              </a:defRPr>
+            </a:lvl4pPr>
+            <a:lvl5pPr marL="2057400" indent="-228600" algn="l" defTabSz="457200" rtl="0" eaLnBrk="1" latinLnBrk="0" hangingPunct="1">
+              <a:spcBef>
+                <a:spcPts val="1000"/>
+              </a:spcBef>
+              <a:spcAft>
+                <a:spcPts val="0"/>
+              </a:spcAft>
+              <a:buClr>
+                <a:schemeClr val="accent1"/>
+              </a:buClr>
+              <a:buFont typeface="Wingdings 3" charset="2"/>
+              <a:buChar char=""/>
+              <a:defRPr sz="1200" kern="1200">
+                <a:solidFill>
+                  <a:schemeClr val="tx1">
+                    <a:lumMod val="75000"/>
+                    <a:lumOff val="25000"/>
+                  </a:schemeClr>
+                </a:solidFill>
+                <a:latin typeface="+mn-lt"/>
+                <a:ea typeface="+mn-ea"/>
+                <a:cs typeface="+mn-cs"/>
+              </a:defRPr>
+            </a:lvl5pPr>
+            <a:lvl6pPr marL="2514600" indent="-228600" algn="l" defTabSz="457200" rtl="0" eaLnBrk="1" latinLnBrk="0" hangingPunct="1">
+              <a:spcBef>
+                <a:spcPts val="1000"/>
+              </a:spcBef>
+              <a:spcAft>
+                <a:spcPts val="0"/>
+              </a:spcAft>
+              <a:buClr>
+                <a:schemeClr val="accent1"/>
+              </a:buClr>
+              <a:buFont typeface="Wingdings 3" charset="2"/>
+              <a:buChar char=""/>
+              <a:defRPr sz="1200" kern="1200">
+                <a:solidFill>
+                  <a:schemeClr val="tx1">
+                    <a:lumMod val="75000"/>
+                    <a:lumOff val="25000"/>
+                  </a:schemeClr>
+                </a:solidFill>
+                <a:latin typeface="+mn-lt"/>
+                <a:ea typeface="+mn-ea"/>
+                <a:cs typeface="+mn-cs"/>
+              </a:defRPr>
+            </a:lvl6pPr>
+            <a:lvl7pPr marL="2971800" indent="-228600" algn="l" defTabSz="457200" rtl="0" eaLnBrk="1" latinLnBrk="0" hangingPunct="1">
+              <a:spcBef>
+                <a:spcPts val="1000"/>
+              </a:spcBef>
+              <a:spcAft>
+                <a:spcPts val="0"/>
+              </a:spcAft>
+              <a:buClr>
+                <a:schemeClr val="accent1"/>
+              </a:buClr>
+              <a:buFont typeface="Wingdings 3" charset="2"/>
+              <a:buChar char=""/>
+              <a:defRPr sz="1200" kern="1200">
+                <a:solidFill>
+                  <a:schemeClr val="tx1">
+                    <a:lumMod val="75000"/>
+                    <a:lumOff val="25000"/>
+                  </a:schemeClr>
+                </a:solidFill>
+                <a:latin typeface="+mn-lt"/>
+                <a:ea typeface="+mn-ea"/>
+                <a:cs typeface="+mn-cs"/>
+              </a:defRPr>
+            </a:lvl7pPr>
+            <a:lvl8pPr marL="3429000" indent="-228600" algn="l" defTabSz="457200" rtl="0" eaLnBrk="1" latinLnBrk="0" hangingPunct="1">
+              <a:spcBef>
+                <a:spcPts val="1000"/>
+              </a:spcBef>
+              <a:spcAft>
+                <a:spcPts val="0"/>
+              </a:spcAft>
+              <a:buClr>
+                <a:schemeClr val="accent1"/>
+              </a:buClr>
+              <a:buFont typeface="Wingdings 3" charset="2"/>
+              <a:buChar char=""/>
+              <a:defRPr sz="1200" kern="1200">
+                <a:solidFill>
+                  <a:schemeClr val="tx1">
+                    <a:lumMod val="75000"/>
+                    <a:lumOff val="25000"/>
+                  </a:schemeClr>
+                </a:solidFill>
+                <a:latin typeface="+mn-lt"/>
+                <a:ea typeface="+mn-ea"/>
+                <a:cs typeface="+mn-cs"/>
+              </a:defRPr>
+            </a:lvl8pPr>
+            <a:lvl9pPr marL="3886200" indent="-228600" algn="l" defTabSz="457200" rtl="0" eaLnBrk="1" latinLnBrk="0" hangingPunct="1">
+              <a:spcBef>
+                <a:spcPts val="1000"/>
+              </a:spcBef>
+              <a:spcAft>
+                <a:spcPts val="0"/>
+              </a:spcAft>
+              <a:buClr>
+                <a:schemeClr val="accent1"/>
+              </a:buClr>
+              <a:buFont typeface="Wingdings 3" charset="2"/>
+              <a:buChar char=""/>
+              <a:defRPr sz="1200" kern="1200">
+                <a:solidFill>
+                  <a:schemeClr val="tx1">
+                    <a:lumMod val="75000"/>
+                    <a:lumOff val="25000"/>
+                  </a:schemeClr>
+                </a:solidFill>
+                <a:latin typeface="+mn-lt"/>
+                <a:ea typeface="+mn-ea"/>
+                <a:cs typeface="+mn-cs"/>
+              </a:defRPr>
+            </a:lvl9pPr>
+          </a:lstStyle>
+          <a:p>
+            <a:pPr marL="0" indent="0">
+              <a:buNone/>
+            </a:pPr>
+            <a:r>
+              <a:rPr lang="en-US" sz="2800" b="1" dirty="0"/>
+              <a:t>Adam</a:t>
+            </a:r>
+          </a:p>
+          <a:p>
+            <a:pPr marL="0" indent="0">
+              <a:buNone/>
+            </a:pPr>
+            <a:endParaRPr lang="en-US" b="1" dirty="0"/>
+          </a:p>
+          <a:p>
+            <a:pPr marL="0" indent="0">
+              <a:buNone/>
+            </a:pPr>
+            <a:r>
+              <a:rPr lang="en-US" sz="1600" b="1" dirty="0"/>
+              <a:t>Decoupled Weight Decay</a:t>
+            </a:r>
+            <a:br>
+              <a:rPr lang="en-US" sz="1600" b="1" dirty="0"/>
+            </a:br>
+            <a:r>
+              <a:rPr lang="en-US" sz="1600" b="1" dirty="0"/>
+              <a:t>(</a:t>
+            </a:r>
+            <a:r>
+              <a:rPr lang="en-US" sz="1600" b="1" dirty="0" err="1"/>
+              <a:t>decoupled_weight_decay</a:t>
+            </a:r>
+            <a:r>
+              <a:rPr lang="en-US" sz="1600" b="1" dirty="0"/>
+              <a:t>)</a:t>
+            </a:r>
+          </a:p>
+          <a:p>
+            <a:r>
+              <a:rPr lang="en-US" i="1" dirty="0"/>
+              <a:t>Uses the exact decoupled weight decay mechanism </a:t>
+            </a:r>
+            <a:r>
+              <a:rPr lang="en-US" i="1" dirty="0" err="1"/>
+              <a:t>AdamW</a:t>
+            </a:r>
+            <a:r>
+              <a:rPr lang="en-US" i="1" dirty="0"/>
+              <a:t> does</a:t>
+            </a:r>
+          </a:p>
+          <a:p>
+            <a:r>
+              <a:rPr lang="en-US" i="1" dirty="0"/>
+              <a:t>Added as an update 2019 onward after </a:t>
+            </a:r>
+            <a:r>
+              <a:rPr lang="en-US" i="1" dirty="0" err="1"/>
+              <a:t>AdamW</a:t>
+            </a:r>
+            <a:r>
+              <a:rPr lang="en-US" i="1" dirty="0"/>
+              <a:t> was established for backward compatibility</a:t>
+            </a:r>
+          </a:p>
+          <a:p>
+            <a:pPr marL="0" indent="0">
+              <a:buNone/>
+            </a:pPr>
+            <a:endParaRPr lang="en-US" dirty="0"/>
+          </a:p>
+        </p:txBody>
+      </p:sp>
+      <p:sp>
+        <p:nvSpPr>
+          <p:cNvPr id="6" name="Content Placeholder 2">
+            <a:extLst>
+              <a:ext uri="{FF2B5EF4-FFF2-40B4-BE49-F238E27FC236}">
+                <a16:creationId xmlns:a16="http://schemas.microsoft.com/office/drawing/2014/main" id="{1E2D1CCE-1C95-0635-15CC-F0BC3B5538F1}"/>
+              </a:ext>
+            </a:extLst>
+          </p:cNvPr>
+          <p:cNvSpPr txBox="1">
+            <a:spLocks/>
+          </p:cNvSpPr>
+          <p:nvPr/>
+        </p:nvSpPr>
+        <p:spPr>
+          <a:xfrm>
+            <a:off x="7868699" y="1632154"/>
+            <a:ext cx="3635913" cy="4965291"/>
+          </a:xfrm>
+          <a:prstGeom prst="rect">
+            <a:avLst/>
+          </a:prstGeom>
+        </p:spPr>
+        <p:txBody>
+          <a:bodyPr vert="horz" lIns="91440" tIns="45720" rIns="91440" bIns="45720" rtlCol="0">
+            <a:normAutofit/>
+          </a:bodyPr>
+          <a:lstStyle>
+            <a:lvl1pPr marL="342900" indent="-342900" algn="l" defTabSz="457200" rtl="0" eaLnBrk="1" latinLnBrk="0" hangingPunct="1">
+              <a:spcBef>
+                <a:spcPts val="1000"/>
+              </a:spcBef>
+              <a:spcAft>
+                <a:spcPts val="0"/>
+              </a:spcAft>
+              <a:buClr>
+                <a:schemeClr val="accent1"/>
+              </a:buClr>
+              <a:buFont typeface="Wingdings 3" charset="2"/>
+              <a:buChar char=""/>
+              <a:defRPr sz="1800" kern="1200">
+                <a:solidFill>
+                  <a:schemeClr val="tx1">
+                    <a:lumMod val="75000"/>
+                    <a:lumOff val="25000"/>
+                  </a:schemeClr>
+                </a:solidFill>
+                <a:latin typeface="+mn-lt"/>
+                <a:ea typeface="+mn-ea"/>
+                <a:cs typeface="+mn-cs"/>
+              </a:defRPr>
+            </a:lvl1pPr>
+            <a:lvl2pPr marL="742950" indent="-285750" algn="l" defTabSz="457200" rtl="0" eaLnBrk="1" latinLnBrk="0" hangingPunct="1">
+              <a:spcBef>
+                <a:spcPts val="1000"/>
+              </a:spcBef>
+              <a:spcAft>
+                <a:spcPts val="0"/>
+              </a:spcAft>
+              <a:buClr>
+                <a:schemeClr val="accent1"/>
+              </a:buClr>
+              <a:buFont typeface="Wingdings 3" charset="2"/>
+              <a:buChar char=""/>
+              <a:defRPr sz="1600" kern="1200">
+                <a:solidFill>
+                  <a:schemeClr val="tx1">
+                    <a:lumMod val="75000"/>
+                    <a:lumOff val="25000"/>
+                  </a:schemeClr>
+                </a:solidFill>
+                <a:latin typeface="+mn-lt"/>
+                <a:ea typeface="+mn-ea"/>
+                <a:cs typeface="+mn-cs"/>
+              </a:defRPr>
+            </a:lvl2pPr>
+            <a:lvl3pPr marL="1143000" indent="-228600" algn="l" defTabSz="457200" rtl="0" eaLnBrk="1" latinLnBrk="0" hangingPunct="1">
+              <a:spcBef>
+                <a:spcPts val="1000"/>
+              </a:spcBef>
+              <a:spcAft>
+                <a:spcPts val="0"/>
+              </a:spcAft>
+              <a:buClr>
+                <a:schemeClr val="accent1"/>
+              </a:buClr>
+              <a:buFont typeface="Wingdings 3" charset="2"/>
+              <a:buChar char=""/>
+              <a:defRPr sz="1400" kern="1200">
+                <a:solidFill>
+                  <a:schemeClr val="tx1">
+                    <a:lumMod val="75000"/>
+                    <a:lumOff val="25000"/>
+                  </a:schemeClr>
+                </a:solidFill>
+                <a:latin typeface="+mn-lt"/>
+                <a:ea typeface="+mn-ea"/>
+                <a:cs typeface="+mn-cs"/>
+              </a:defRPr>
+            </a:lvl3pPr>
+            <a:lvl4pPr marL="1600200" indent="-228600" algn="l" defTabSz="457200" rtl="0" eaLnBrk="1" latinLnBrk="0" hangingPunct="1">
+              <a:spcBef>
+                <a:spcPts val="1000"/>
+              </a:spcBef>
+              <a:spcAft>
+                <a:spcPts val="0"/>
+              </a:spcAft>
+              <a:buClr>
+                <a:schemeClr val="accent1"/>
+              </a:buClr>
+              <a:buFont typeface="Wingdings 3" charset="2"/>
+              <a:buChar char=""/>
+              <a:defRPr sz="1200" kern="1200">
+                <a:solidFill>
+                  <a:schemeClr val="tx1">
+                    <a:lumMod val="75000"/>
+                    <a:lumOff val="25000"/>
+                  </a:schemeClr>
+                </a:solidFill>
+                <a:latin typeface="+mn-lt"/>
+                <a:ea typeface="+mn-ea"/>
+                <a:cs typeface="+mn-cs"/>
+              </a:defRPr>
+            </a:lvl4pPr>
+            <a:lvl5pPr marL="2057400" indent="-228600" algn="l" defTabSz="457200" rtl="0" eaLnBrk="1" latinLnBrk="0" hangingPunct="1">
+              <a:spcBef>
+                <a:spcPts val="1000"/>
+              </a:spcBef>
+              <a:spcAft>
+                <a:spcPts val="0"/>
+              </a:spcAft>
+              <a:buClr>
+                <a:schemeClr val="accent1"/>
+              </a:buClr>
+              <a:buFont typeface="Wingdings 3" charset="2"/>
+              <a:buChar char=""/>
+              <a:defRPr sz="1200" kern="1200">
+                <a:solidFill>
+                  <a:schemeClr val="tx1">
+                    <a:lumMod val="75000"/>
+                    <a:lumOff val="25000"/>
+                  </a:schemeClr>
+                </a:solidFill>
+                <a:latin typeface="+mn-lt"/>
+                <a:ea typeface="+mn-ea"/>
+                <a:cs typeface="+mn-cs"/>
+              </a:defRPr>
+            </a:lvl5pPr>
+            <a:lvl6pPr marL="2514600" indent="-228600" algn="l" defTabSz="457200" rtl="0" eaLnBrk="1" latinLnBrk="0" hangingPunct="1">
+              <a:spcBef>
+                <a:spcPts val="1000"/>
+              </a:spcBef>
+              <a:spcAft>
+                <a:spcPts val="0"/>
+              </a:spcAft>
+              <a:buClr>
+                <a:schemeClr val="accent1"/>
+              </a:buClr>
+              <a:buFont typeface="Wingdings 3" charset="2"/>
+              <a:buChar char=""/>
+              <a:defRPr sz="1200" kern="1200">
+                <a:solidFill>
+                  <a:schemeClr val="tx1">
+                    <a:lumMod val="75000"/>
+                    <a:lumOff val="25000"/>
+                  </a:schemeClr>
+                </a:solidFill>
+                <a:latin typeface="+mn-lt"/>
+                <a:ea typeface="+mn-ea"/>
+                <a:cs typeface="+mn-cs"/>
+              </a:defRPr>
+            </a:lvl6pPr>
+            <a:lvl7pPr marL="2971800" indent="-228600" algn="l" defTabSz="457200" rtl="0" eaLnBrk="1" latinLnBrk="0" hangingPunct="1">
+              <a:spcBef>
+                <a:spcPts val="1000"/>
+              </a:spcBef>
+              <a:spcAft>
+                <a:spcPts val="0"/>
+              </a:spcAft>
+              <a:buClr>
+                <a:schemeClr val="accent1"/>
+              </a:buClr>
+              <a:buFont typeface="Wingdings 3" charset="2"/>
+              <a:buChar char=""/>
+              <a:defRPr sz="1200" kern="1200">
+                <a:solidFill>
+                  <a:schemeClr val="tx1">
+                    <a:lumMod val="75000"/>
+                    <a:lumOff val="25000"/>
+                  </a:schemeClr>
+                </a:solidFill>
+                <a:latin typeface="+mn-lt"/>
+                <a:ea typeface="+mn-ea"/>
+                <a:cs typeface="+mn-cs"/>
+              </a:defRPr>
+            </a:lvl7pPr>
+            <a:lvl8pPr marL="3429000" indent="-228600" algn="l" defTabSz="457200" rtl="0" eaLnBrk="1" latinLnBrk="0" hangingPunct="1">
+              <a:spcBef>
+                <a:spcPts val="1000"/>
+              </a:spcBef>
+              <a:spcAft>
+                <a:spcPts val="0"/>
+              </a:spcAft>
+              <a:buClr>
+                <a:schemeClr val="accent1"/>
+              </a:buClr>
+              <a:buFont typeface="Wingdings 3" charset="2"/>
+              <a:buChar char=""/>
+              <a:defRPr sz="1200" kern="1200">
+                <a:solidFill>
+                  <a:schemeClr val="tx1">
+                    <a:lumMod val="75000"/>
+                    <a:lumOff val="25000"/>
+                  </a:schemeClr>
+                </a:solidFill>
+                <a:latin typeface="+mn-lt"/>
+                <a:ea typeface="+mn-ea"/>
+                <a:cs typeface="+mn-cs"/>
+              </a:defRPr>
+            </a:lvl8pPr>
+            <a:lvl9pPr marL="3886200" indent="-228600" algn="l" defTabSz="457200" rtl="0" eaLnBrk="1" latinLnBrk="0" hangingPunct="1">
+              <a:spcBef>
+                <a:spcPts val="1000"/>
+              </a:spcBef>
+              <a:spcAft>
+                <a:spcPts val="0"/>
+              </a:spcAft>
+              <a:buClr>
+                <a:schemeClr val="accent1"/>
+              </a:buClr>
+              <a:buFont typeface="Wingdings 3" charset="2"/>
+              <a:buChar char=""/>
+              <a:defRPr sz="1200" kern="1200">
+                <a:solidFill>
+                  <a:schemeClr val="tx1">
+                    <a:lumMod val="75000"/>
+                    <a:lumOff val="25000"/>
+                  </a:schemeClr>
+                </a:solidFill>
+                <a:latin typeface="+mn-lt"/>
+                <a:ea typeface="+mn-ea"/>
+                <a:cs typeface="+mn-cs"/>
+              </a:defRPr>
+            </a:lvl9pPr>
+          </a:lstStyle>
+          <a:p>
+            <a:pPr marL="0" indent="0">
+              <a:buNone/>
+            </a:pPr>
+            <a:r>
+              <a:rPr lang="en-US" sz="3000" b="1" dirty="0" err="1"/>
+              <a:t>AdamW</a:t>
+            </a:r>
+            <a:endParaRPr lang="en-US" sz="1600" b="1" dirty="0"/>
+          </a:p>
+          <a:p>
+            <a:pPr marL="0" indent="0">
+              <a:buNone/>
+            </a:pPr>
+            <a:endParaRPr lang="en-US" b="1" dirty="0"/>
+          </a:p>
+          <a:p>
+            <a:pPr marL="0" indent="0">
+              <a:buNone/>
+            </a:pPr>
+            <a:r>
+              <a:rPr lang="en-US" b="1" dirty="0"/>
+              <a:t>Maximize (maximize)</a:t>
+            </a:r>
+          </a:p>
+          <a:p>
+            <a:r>
+              <a:rPr lang="en-US" i="1" dirty="0"/>
+              <a:t>Maximizes the losses instead of minimizing it (edge case</a:t>
+            </a:r>
+            <a:r>
+              <a:rPr lang="en-US" dirty="0"/>
+              <a:t>)</a:t>
+            </a:r>
+            <a:endParaRPr lang="en-US" b="1" dirty="0"/>
+          </a:p>
+          <a:p>
+            <a:pPr marL="0" indent="0">
+              <a:buNone/>
+            </a:pPr>
+            <a:r>
+              <a:rPr lang="en-US" sz="1600" b="1" dirty="0"/>
+              <a:t>Differentiable (differentiable)</a:t>
+            </a:r>
+          </a:p>
+          <a:p>
+            <a:r>
+              <a:rPr lang="en-US" i="1" dirty="0"/>
+              <a:t>Enables or disables </a:t>
+            </a:r>
+            <a:r>
+              <a:rPr lang="en-US" i="1" dirty="0" err="1"/>
+              <a:t>autograd</a:t>
+            </a:r>
+            <a:r>
+              <a:rPr lang="en-US" i="1" dirty="0"/>
+              <a:t> during training</a:t>
+            </a:r>
+          </a:p>
+          <a:p>
+            <a:r>
+              <a:rPr lang="en-US" i="1" dirty="0"/>
+              <a:t>Backpropagates  the optimizer math (</a:t>
+            </a:r>
+            <a:r>
+              <a:rPr lang="en-US" i="1" dirty="0" err="1"/>
+              <a:t>autograd</a:t>
+            </a:r>
+            <a:r>
+              <a:rPr lang="en-US" i="1" dirty="0"/>
+              <a:t>)</a:t>
+            </a:r>
+          </a:p>
+          <a:p>
+            <a:pPr marL="0" indent="0">
+              <a:buNone/>
+            </a:pPr>
+            <a:r>
+              <a:rPr lang="en-US" b="1" dirty="0"/>
+              <a:t>Capturable (capturable)</a:t>
+            </a:r>
+          </a:p>
+          <a:p>
+            <a:r>
+              <a:rPr lang="en-US" i="1" dirty="0"/>
+              <a:t>Moves the tracking values operations into the GPU</a:t>
+            </a:r>
+          </a:p>
+          <a:p>
+            <a:pPr marL="0" indent="0">
+              <a:buNone/>
+            </a:pPr>
+            <a:endParaRPr lang="en-US" sz="2800" b="1" dirty="0"/>
+          </a:p>
+          <a:p>
+            <a:endParaRPr lang="en-US" sz="2800" b="1" dirty="0"/>
+          </a:p>
+        </p:txBody>
+      </p:sp>
+    </p:spTree>
+    <p:extLst>
+      <p:ext uri="{BB962C8B-B14F-4D97-AF65-F5344CB8AC3E}">
+        <p14:creationId xmlns:p14="http://schemas.microsoft.com/office/powerpoint/2010/main" val="64746629"/>
+      </p:ext>
+    </p:extLst>
+  </p:cSld>
+  <p:clrMapOvr>
+    <a:masterClrMapping/>
+  </p:clrMapOvr>
+</p:sld>
+</file>
+
+<file path=ppt/slides/slide8.xml><?xml version="1.0" encoding="utf-8"?>
 <p:sld xmlns:a="http://schemas.openxmlformats.org/drawingml/2006/main" xmlns:r="http://schemas.openxmlformats.org/officeDocument/2006/relationships" xmlns:p="http://schemas.openxmlformats.org/presentationml/2006/main">
   <p:cSld>
     <p:spTree>
@@ -12456,7 +15191,7 @@
 </p:sld>
 </file>
 
-<file path=ppt/slides/slide7.xml><?xml version="1.0" encoding="utf-8"?>
+<file path=ppt/slides/slide9.xml><?xml version="1.0" encoding="utf-8"?>
 <p:sld xmlns:a="http://schemas.openxmlformats.org/drawingml/2006/main" xmlns:r="http://schemas.openxmlformats.org/officeDocument/2006/relationships" xmlns:p="http://schemas.openxmlformats.org/presentationml/2006/main">
   <p:cSld>
     <p:spTree>
@@ -12530,172 +15265,6 @@
     <p:extLst>
       <p:ext uri="{BB962C8B-B14F-4D97-AF65-F5344CB8AC3E}">
         <p14:creationId xmlns:p14="http://schemas.microsoft.com/office/powerpoint/2010/main" val="1895289661"/>
-      </p:ext>
-    </p:extLst>
-  </p:cSld>
-  <p:clrMapOvr>
-    <a:masterClrMapping/>
-  </p:clrMapOvr>
-</p:sld>
-</file>
-
-<file path=ppt/slides/slide8.xml><?xml version="1.0" encoding="utf-8"?>
-<p:sld xmlns:a="http://schemas.openxmlformats.org/drawingml/2006/main" xmlns:r="http://schemas.openxmlformats.org/officeDocument/2006/relationships" xmlns:p="http://schemas.openxmlformats.org/presentationml/2006/main">
-  <p:cSld>
-    <p:spTree>
-      <p:nvGrpSpPr>
-        <p:cNvPr id="1" name=""/>
-        <p:cNvGrpSpPr/>
-        <p:nvPr/>
-      </p:nvGrpSpPr>
-      <p:grpSpPr>
-        <a:xfrm>
-          <a:off x="0" y="0"/>
-          <a:ext cx="0" cy="0"/>
-          <a:chOff x="0" y="0"/>
-          <a:chExt cx="0" cy="0"/>
-        </a:xfrm>
-      </p:grpSpPr>
-      <p:sp>
-        <p:nvSpPr>
-          <p:cNvPr id="2" name="Title 1">
-            <a:extLst>
-              <a:ext uri="{FF2B5EF4-FFF2-40B4-BE49-F238E27FC236}">
-                <a16:creationId xmlns:a16="http://schemas.microsoft.com/office/drawing/2014/main" id="{C37705B1-C463-054E-8429-BD4A7B419E2F}"/>
-              </a:ext>
-            </a:extLst>
-          </p:cNvPr>
-          <p:cNvSpPr>
-            <a:spLocks noGrp="1"/>
-          </p:cNvSpPr>
-          <p:nvPr>
-            <p:ph type="title"/>
-          </p:nvPr>
-        </p:nvSpPr>
-        <p:spPr/>
-        <p:txBody>
-          <a:bodyPr/>
-          <a:lstStyle/>
-          <a:p>
-            <a:r>
-              <a:rPr lang="en-US" dirty="0"/>
-              <a:t>Interpretation &amp; Discussion</a:t>
-            </a:r>
-          </a:p>
-        </p:txBody>
-      </p:sp>
-      <p:sp>
-        <p:nvSpPr>
-          <p:cNvPr id="3" name="Content Placeholder 2">
-            <a:extLst>
-              <a:ext uri="{FF2B5EF4-FFF2-40B4-BE49-F238E27FC236}">
-                <a16:creationId xmlns:a16="http://schemas.microsoft.com/office/drawing/2014/main" id="{E842A3CE-0D11-5335-8C0A-EE11A2A2E2AF}"/>
-              </a:ext>
-            </a:extLst>
-          </p:cNvPr>
-          <p:cNvSpPr>
-            <a:spLocks noGrp="1"/>
-          </p:cNvSpPr>
-          <p:nvPr>
-            <p:ph idx="1"/>
-          </p:nvPr>
-        </p:nvSpPr>
-        <p:spPr/>
-        <p:txBody>
-          <a:bodyPr/>
-          <a:lstStyle/>
-          <a:p>
-            <a:endParaRPr lang="en-US"/>
-          </a:p>
-        </p:txBody>
-      </p:sp>
-    </p:spTree>
-    <p:extLst>
-      <p:ext uri="{BB962C8B-B14F-4D97-AF65-F5344CB8AC3E}">
-        <p14:creationId xmlns:p14="http://schemas.microsoft.com/office/powerpoint/2010/main" val="914363862"/>
-      </p:ext>
-    </p:extLst>
-  </p:cSld>
-  <p:clrMapOvr>
-    <a:masterClrMapping/>
-  </p:clrMapOvr>
-</p:sld>
-</file>
-
-<file path=ppt/slides/slide9.xml><?xml version="1.0" encoding="utf-8"?>
-<p:sld xmlns:a="http://schemas.openxmlformats.org/drawingml/2006/main" xmlns:r="http://schemas.openxmlformats.org/officeDocument/2006/relationships" xmlns:p="http://schemas.openxmlformats.org/presentationml/2006/main">
-  <p:cSld>
-    <p:spTree>
-      <p:nvGrpSpPr>
-        <p:cNvPr id="1" name=""/>
-        <p:cNvGrpSpPr/>
-        <p:nvPr/>
-      </p:nvGrpSpPr>
-      <p:grpSpPr>
-        <a:xfrm>
-          <a:off x="0" y="0"/>
-          <a:ext cx="0" cy="0"/>
-          <a:chOff x="0" y="0"/>
-          <a:chExt cx="0" cy="0"/>
-        </a:xfrm>
-      </p:grpSpPr>
-      <p:sp>
-        <p:nvSpPr>
-          <p:cNvPr id="2" name="Title 1">
-            <a:extLst>
-              <a:ext uri="{FF2B5EF4-FFF2-40B4-BE49-F238E27FC236}">
-                <a16:creationId xmlns:a16="http://schemas.microsoft.com/office/drawing/2014/main" id="{169F9636-CCA1-BB83-C04D-21A3B9DE4D4B}"/>
-              </a:ext>
-            </a:extLst>
-          </p:cNvPr>
-          <p:cNvSpPr>
-            <a:spLocks noGrp="1"/>
-          </p:cNvSpPr>
-          <p:nvPr>
-            <p:ph type="title"/>
-          </p:nvPr>
-        </p:nvSpPr>
-        <p:spPr/>
-        <p:txBody>
-          <a:bodyPr/>
-          <a:lstStyle/>
-          <a:p>
-            <a:r>
-              <a:rPr lang="en-US" dirty="0"/>
-              <a:t>Conclusion</a:t>
-            </a:r>
-          </a:p>
-        </p:txBody>
-      </p:sp>
-      <p:sp>
-        <p:nvSpPr>
-          <p:cNvPr id="3" name="Content Placeholder 2">
-            <a:extLst>
-              <a:ext uri="{FF2B5EF4-FFF2-40B4-BE49-F238E27FC236}">
-                <a16:creationId xmlns:a16="http://schemas.microsoft.com/office/drawing/2014/main" id="{5620016E-DDD4-A19E-076E-8BB3344CD165}"/>
-              </a:ext>
-            </a:extLst>
-          </p:cNvPr>
-          <p:cNvSpPr>
-            <a:spLocks noGrp="1"/>
-          </p:cNvSpPr>
-          <p:nvPr>
-            <p:ph idx="1"/>
-          </p:nvPr>
-        </p:nvSpPr>
-        <p:spPr/>
-        <p:txBody>
-          <a:bodyPr/>
-          <a:lstStyle/>
-          <a:p>
-            <a:endParaRPr lang="en-US"/>
-          </a:p>
-        </p:txBody>
-      </p:sp>
-    </p:spTree>
-    <p:extLst>
-      <p:ext uri="{BB962C8B-B14F-4D97-AF65-F5344CB8AC3E}">
-        <p14:creationId xmlns:p14="http://schemas.microsoft.com/office/powerpoint/2010/main" val="1800426027"/>
       </p:ext>
     </p:extLst>
   </p:cSld>

</xml_diff>

<commit_message>
Added slide for Summary Table
</commit_message>
<xml_diff>
--- a/slides/midterm-slides.pptx
+++ b/slides/midterm-slides.pptx
@@ -15,14 +15,15 @@
     <p:sldId id="269" r:id="rId9"/>
     <p:sldId id="270" r:id="rId10"/>
     <p:sldId id="271" r:id="rId11"/>
-    <p:sldId id="262" r:id="rId12"/>
-    <p:sldId id="275" r:id="rId13"/>
-    <p:sldId id="274" r:id="rId14"/>
-    <p:sldId id="272" r:id="rId15"/>
-    <p:sldId id="266" r:id="rId16"/>
-    <p:sldId id="273" r:id="rId17"/>
-    <p:sldId id="265" r:id="rId18"/>
-    <p:sldId id="267" r:id="rId19"/>
+    <p:sldId id="277" r:id="rId12"/>
+    <p:sldId id="262" r:id="rId13"/>
+    <p:sldId id="275" r:id="rId14"/>
+    <p:sldId id="274" r:id="rId15"/>
+    <p:sldId id="272" r:id="rId16"/>
+    <p:sldId id="266" r:id="rId17"/>
+    <p:sldId id="273" r:id="rId18"/>
+    <p:sldId id="265" r:id="rId19"/>
+    <p:sldId id="267" r:id="rId20"/>
   </p:sldIdLst>
   <p:sldSz cx="12192000" cy="6858000"/>
   <p:notesSz cx="6858000" cy="9144000"/>
@@ -26750,6 +26751,2440 @@
   <p:cSld>
     <p:spTree>
       <p:nvGrpSpPr>
+        <p:cNvPr id="1" name="">
+          <a:extLst>
+            <a:ext uri="{FF2B5EF4-FFF2-40B4-BE49-F238E27FC236}">
+              <a16:creationId xmlns:a16="http://schemas.microsoft.com/office/drawing/2014/main" id="{709FA221-2FB0-7CBD-4246-D5F8B82BD2C1}"/>
+            </a:ext>
+          </a:extLst>
+        </p:cNvPr>
+        <p:cNvGrpSpPr/>
+        <p:nvPr/>
+      </p:nvGrpSpPr>
+      <p:grpSpPr>
+        <a:xfrm>
+          <a:off x="0" y="0"/>
+          <a:ext cx="0" cy="0"/>
+          <a:chOff x="0" y="0"/>
+          <a:chExt cx="0" cy="0"/>
+        </a:xfrm>
+      </p:grpSpPr>
+      <p:sp>
+        <p:nvSpPr>
+          <p:cNvPr id="2" name="Title 1">
+            <a:extLst>
+              <a:ext uri="{FF2B5EF4-FFF2-40B4-BE49-F238E27FC236}">
+                <a16:creationId xmlns:a16="http://schemas.microsoft.com/office/drawing/2014/main" id="{0E0FDDFF-0CB3-2C55-39CA-BCB94020131A}"/>
+              </a:ext>
+            </a:extLst>
+          </p:cNvPr>
+          <p:cNvSpPr>
+            <a:spLocks noGrp="1"/>
+          </p:cNvSpPr>
+          <p:nvPr>
+            <p:ph type="title"/>
+          </p:nvPr>
+        </p:nvSpPr>
+        <p:spPr/>
+        <p:txBody>
+          <a:bodyPr/>
+          <a:lstStyle/>
+          <a:p>
+            <a:r>
+              <a:rPr lang="en-US" dirty="0"/>
+              <a:t>Results</a:t>
+            </a:r>
+          </a:p>
+        </p:txBody>
+      </p:sp>
+      <p:graphicFrame>
+        <p:nvGraphicFramePr>
+          <p:cNvPr id="6" name="Table 5">
+            <a:extLst>
+              <a:ext uri="{FF2B5EF4-FFF2-40B4-BE49-F238E27FC236}">
+                <a16:creationId xmlns:a16="http://schemas.microsoft.com/office/drawing/2014/main" id="{123697B7-5851-547F-3660-8F5FF6F6F6A4}"/>
+              </a:ext>
+            </a:extLst>
+          </p:cNvPr>
+          <p:cNvGraphicFramePr>
+            <a:graphicFrameLocks noGrp="1"/>
+          </p:cNvGraphicFramePr>
+          <p:nvPr>
+            <p:extLst>
+              <p:ext uri="{D42A27DB-BD31-4B8C-83A1-F6EECF244321}">
+                <p14:modId xmlns:p14="http://schemas.microsoft.com/office/powerpoint/2010/main" val="3119721821"/>
+              </p:ext>
+            </p:extLst>
+          </p:nvPr>
+        </p:nvGraphicFramePr>
+        <p:xfrm>
+          <a:off x="2402958" y="1669311"/>
+          <a:ext cx="7666074" cy="3795823"/>
+        </p:xfrm>
+        <a:graphic>
+          <a:graphicData uri="http://schemas.openxmlformats.org/drawingml/2006/table">
+            <a:tbl>
+              <a:tblPr/>
+              <a:tblGrid>
+                <a:gridCol w="898271">
+                  <a:extLst>
+                    <a:ext uri="{9D8B030D-6E8A-4147-A177-3AD203B41FA5}">
+                      <a16:colId xmlns:a16="http://schemas.microsoft.com/office/drawing/2014/main" val="4061796045"/>
+                    </a:ext>
+                  </a:extLst>
+                </a:gridCol>
+                <a:gridCol w="873663">
+                  <a:extLst>
+                    <a:ext uri="{9D8B030D-6E8A-4147-A177-3AD203B41FA5}">
+                      <a16:colId xmlns:a16="http://schemas.microsoft.com/office/drawing/2014/main" val="442892495"/>
+                    </a:ext>
+                  </a:extLst>
+                </a:gridCol>
+                <a:gridCol w="812137">
+                  <a:extLst>
+                    <a:ext uri="{9D8B030D-6E8A-4147-A177-3AD203B41FA5}">
+                      <a16:colId xmlns:a16="http://schemas.microsoft.com/office/drawing/2014/main" val="2208243603"/>
+                    </a:ext>
+                  </a:extLst>
+                </a:gridCol>
+                <a:gridCol w="738305">
+                  <a:extLst>
+                    <a:ext uri="{9D8B030D-6E8A-4147-A177-3AD203B41FA5}">
+                      <a16:colId xmlns:a16="http://schemas.microsoft.com/office/drawing/2014/main" val="3460151697"/>
+                    </a:ext>
+                  </a:extLst>
+                </a:gridCol>
+                <a:gridCol w="799831">
+                  <a:extLst>
+                    <a:ext uri="{9D8B030D-6E8A-4147-A177-3AD203B41FA5}">
+                      <a16:colId xmlns:a16="http://schemas.microsoft.com/office/drawing/2014/main" val="1440924015"/>
+                    </a:ext>
+                  </a:extLst>
+                </a:gridCol>
+                <a:gridCol w="947492">
+                  <a:extLst>
+                    <a:ext uri="{9D8B030D-6E8A-4147-A177-3AD203B41FA5}">
+                      <a16:colId xmlns:a16="http://schemas.microsoft.com/office/drawing/2014/main" val="601417017"/>
+                    </a:ext>
+                  </a:extLst>
+                </a:gridCol>
+                <a:gridCol w="836747">
+                  <a:extLst>
+                    <a:ext uri="{9D8B030D-6E8A-4147-A177-3AD203B41FA5}">
+                      <a16:colId xmlns:a16="http://schemas.microsoft.com/office/drawing/2014/main" val="1843427509"/>
+                    </a:ext>
+                  </a:extLst>
+                </a:gridCol>
+                <a:gridCol w="1070543">
+                  <a:extLst>
+                    <a:ext uri="{9D8B030D-6E8A-4147-A177-3AD203B41FA5}">
+                      <a16:colId xmlns:a16="http://schemas.microsoft.com/office/drawing/2014/main" val="265229388"/>
+                    </a:ext>
+                  </a:extLst>
+                </a:gridCol>
+                <a:gridCol w="689085">
+                  <a:extLst>
+                    <a:ext uri="{9D8B030D-6E8A-4147-A177-3AD203B41FA5}">
+                      <a16:colId xmlns:a16="http://schemas.microsoft.com/office/drawing/2014/main" val="4031257647"/>
+                    </a:ext>
+                  </a:extLst>
+                </a:gridCol>
+              </a:tblGrid>
+              <a:tr h="935920">
+                <a:tc>
+                  <a:txBody>
+                    <a:bodyPr/>
+                    <a:lstStyle/>
+                    <a:p>
+                      <a:pPr algn="ctr" rtl="0" fontAlgn="t">
+                        <a:buNone/>
+                      </a:pPr>
+                      <a:r>
+                        <a:rPr lang="en-CA" sz="1000" b="0" i="0" u="none" strike="noStrike">
+                          <a:solidFill>
+                            <a:srgbClr val="000000"/>
+                          </a:solidFill>
+                          <a:effectLst/>
+                          <a:latin typeface="Cambria" panose="02040503050406030204" pitchFamily="18" charset="0"/>
+                        </a:rPr>
+                        <a:t>Optimizer</a:t>
+                      </a:r>
+                      <a:endParaRPr lang="en-CA">
+                        <a:effectLst/>
+                      </a:endParaRPr>
+                    </a:p>
+                  </a:txBody>
+                  <a:tcPr marL="68580" marR="68580">
+                    <a:lnL w="6350" cap="flat" cmpd="sng" algn="ctr">
+                      <a:solidFill>
+                        <a:srgbClr val="000000"/>
+                      </a:solidFill>
+                      <a:prstDash val="solid"/>
+                      <a:round/>
+                      <a:headEnd type="none" w="med" len="med"/>
+                      <a:tailEnd type="none" w="med" len="med"/>
+                    </a:lnL>
+                    <a:lnR w="6350" cap="flat" cmpd="sng" algn="ctr">
+                      <a:solidFill>
+                        <a:srgbClr val="000000"/>
+                      </a:solidFill>
+                      <a:prstDash val="solid"/>
+                      <a:round/>
+                      <a:headEnd type="none" w="med" len="med"/>
+                      <a:tailEnd type="none" w="med" len="med"/>
+                    </a:lnR>
+                    <a:lnT>
+                      <a:noFill/>
+                    </a:lnT>
+                    <a:lnB w="6350" cap="flat" cmpd="sng" algn="ctr">
+                      <a:solidFill>
+                        <a:srgbClr val="000000"/>
+                      </a:solidFill>
+                      <a:prstDash val="solid"/>
+                      <a:round/>
+                      <a:headEnd type="none" w="med" len="med"/>
+                      <a:tailEnd type="none" w="med" len="med"/>
+                    </a:lnB>
+                    <a:solidFill>
+                      <a:srgbClr val="95B3D7"/>
+                    </a:solidFill>
+                  </a:tcPr>
+                </a:tc>
+                <a:tc>
+                  <a:txBody>
+                    <a:bodyPr/>
+                    <a:lstStyle/>
+                    <a:p>
+                      <a:pPr algn="ctr" rtl="0" fontAlgn="t">
+                        <a:buNone/>
+                      </a:pPr>
+                      <a:r>
+                        <a:rPr lang="en-CA" sz="1000" b="0" i="0" u="none" strike="noStrike">
+                          <a:solidFill>
+                            <a:srgbClr val="000000"/>
+                          </a:solidFill>
+                          <a:effectLst/>
+                          <a:latin typeface="Cambria" panose="02040503050406030204" pitchFamily="18" charset="0"/>
+                        </a:rPr>
+                        <a:t>Train Acc</a:t>
+                      </a:r>
+                      <a:endParaRPr lang="en-CA">
+                        <a:effectLst/>
+                      </a:endParaRPr>
+                    </a:p>
+                  </a:txBody>
+                  <a:tcPr marL="68580" marR="68580">
+                    <a:lnL w="6350" cap="flat" cmpd="sng" algn="ctr">
+                      <a:solidFill>
+                        <a:srgbClr val="000000"/>
+                      </a:solidFill>
+                      <a:prstDash val="solid"/>
+                      <a:round/>
+                      <a:headEnd type="none" w="med" len="med"/>
+                      <a:tailEnd type="none" w="med" len="med"/>
+                    </a:lnL>
+                    <a:lnR w="6350" cap="flat" cmpd="sng" algn="ctr">
+                      <a:solidFill>
+                        <a:srgbClr val="000000"/>
+                      </a:solidFill>
+                      <a:prstDash val="solid"/>
+                      <a:round/>
+                      <a:headEnd type="none" w="med" len="med"/>
+                      <a:tailEnd type="none" w="med" len="med"/>
+                    </a:lnR>
+                    <a:lnT>
+                      <a:noFill/>
+                    </a:lnT>
+                    <a:lnB w="6350" cap="flat" cmpd="sng" algn="ctr">
+                      <a:solidFill>
+                        <a:srgbClr val="000000"/>
+                      </a:solidFill>
+                      <a:prstDash val="solid"/>
+                      <a:round/>
+                      <a:headEnd type="none" w="med" len="med"/>
+                      <a:tailEnd type="none" w="med" len="med"/>
+                    </a:lnB>
+                    <a:solidFill>
+                      <a:srgbClr val="95B3D7"/>
+                    </a:solidFill>
+                  </a:tcPr>
+                </a:tc>
+                <a:tc>
+                  <a:txBody>
+                    <a:bodyPr/>
+                    <a:lstStyle/>
+                    <a:p>
+                      <a:pPr algn="ctr" rtl="0" fontAlgn="t">
+                        <a:buNone/>
+                      </a:pPr>
+                      <a:r>
+                        <a:rPr lang="en-CA" sz="1000" b="0" i="0" u="none" strike="noStrike">
+                          <a:solidFill>
+                            <a:srgbClr val="000000"/>
+                          </a:solidFill>
+                          <a:effectLst/>
+                          <a:latin typeface="Cambria" panose="02040503050406030204" pitchFamily="18" charset="0"/>
+                        </a:rPr>
+                        <a:t>CV Mean</a:t>
+                      </a:r>
+                      <a:endParaRPr lang="en-CA">
+                        <a:effectLst/>
+                      </a:endParaRPr>
+                    </a:p>
+                  </a:txBody>
+                  <a:tcPr marL="68580" marR="68580">
+                    <a:lnL w="6350" cap="flat" cmpd="sng" algn="ctr">
+                      <a:solidFill>
+                        <a:srgbClr val="000000"/>
+                      </a:solidFill>
+                      <a:prstDash val="solid"/>
+                      <a:round/>
+                      <a:headEnd type="none" w="med" len="med"/>
+                      <a:tailEnd type="none" w="med" len="med"/>
+                    </a:lnL>
+                    <a:lnR w="6350" cap="flat" cmpd="sng" algn="ctr">
+                      <a:solidFill>
+                        <a:srgbClr val="000000"/>
+                      </a:solidFill>
+                      <a:prstDash val="solid"/>
+                      <a:round/>
+                      <a:headEnd type="none" w="med" len="med"/>
+                      <a:tailEnd type="none" w="med" len="med"/>
+                    </a:lnR>
+                    <a:lnT>
+                      <a:noFill/>
+                    </a:lnT>
+                    <a:lnB w="6350" cap="flat" cmpd="sng" algn="ctr">
+                      <a:solidFill>
+                        <a:srgbClr val="000000"/>
+                      </a:solidFill>
+                      <a:prstDash val="solid"/>
+                      <a:round/>
+                      <a:headEnd type="none" w="med" len="med"/>
+                      <a:tailEnd type="none" w="med" len="med"/>
+                    </a:lnB>
+                    <a:solidFill>
+                      <a:srgbClr val="95B3D7"/>
+                    </a:solidFill>
+                  </a:tcPr>
+                </a:tc>
+                <a:tc>
+                  <a:txBody>
+                    <a:bodyPr/>
+                    <a:lstStyle/>
+                    <a:p>
+                      <a:pPr algn="ctr" rtl="0" fontAlgn="t">
+                        <a:buNone/>
+                      </a:pPr>
+                      <a:r>
+                        <a:rPr lang="en-CA" sz="1000" b="0" i="0" u="none" strike="noStrike">
+                          <a:solidFill>
+                            <a:srgbClr val="000000"/>
+                          </a:solidFill>
+                          <a:effectLst/>
+                          <a:latin typeface="Cambria" panose="02040503050406030204" pitchFamily="18" charset="0"/>
+                        </a:rPr>
+                        <a:t>CV STD</a:t>
+                      </a:r>
+                      <a:endParaRPr lang="en-CA">
+                        <a:effectLst/>
+                      </a:endParaRPr>
+                    </a:p>
+                  </a:txBody>
+                  <a:tcPr marL="68580" marR="68580">
+                    <a:lnL w="6350" cap="flat" cmpd="sng" algn="ctr">
+                      <a:solidFill>
+                        <a:srgbClr val="000000"/>
+                      </a:solidFill>
+                      <a:prstDash val="solid"/>
+                      <a:round/>
+                      <a:headEnd type="none" w="med" len="med"/>
+                      <a:tailEnd type="none" w="med" len="med"/>
+                    </a:lnL>
+                    <a:lnR w="6350" cap="flat" cmpd="sng" algn="ctr">
+                      <a:solidFill>
+                        <a:srgbClr val="000000"/>
+                      </a:solidFill>
+                      <a:prstDash val="solid"/>
+                      <a:round/>
+                      <a:headEnd type="none" w="med" len="med"/>
+                      <a:tailEnd type="none" w="med" len="med"/>
+                    </a:lnR>
+                    <a:lnT>
+                      <a:noFill/>
+                    </a:lnT>
+                    <a:lnB w="6350" cap="flat" cmpd="sng" algn="ctr">
+                      <a:solidFill>
+                        <a:srgbClr val="000000"/>
+                      </a:solidFill>
+                      <a:prstDash val="solid"/>
+                      <a:round/>
+                      <a:headEnd type="none" w="med" len="med"/>
+                      <a:tailEnd type="none" w="med" len="med"/>
+                    </a:lnB>
+                    <a:solidFill>
+                      <a:srgbClr val="95B3D7"/>
+                    </a:solidFill>
+                  </a:tcPr>
+                </a:tc>
+                <a:tc>
+                  <a:txBody>
+                    <a:bodyPr/>
+                    <a:lstStyle/>
+                    <a:p>
+                      <a:pPr algn="ctr" rtl="0" fontAlgn="t">
+                        <a:buNone/>
+                      </a:pPr>
+                      <a:r>
+                        <a:rPr lang="en-CA" sz="1000" b="0" i="0" u="none" strike="noStrike">
+                          <a:solidFill>
+                            <a:srgbClr val="000000"/>
+                          </a:solidFill>
+                          <a:effectLst/>
+                          <a:latin typeface="Cambria" panose="02040503050406030204" pitchFamily="18" charset="0"/>
+                        </a:rPr>
+                        <a:t>Test Acc</a:t>
+                      </a:r>
+                      <a:endParaRPr lang="en-CA">
+                        <a:effectLst/>
+                      </a:endParaRPr>
+                    </a:p>
+                  </a:txBody>
+                  <a:tcPr marL="68580" marR="68580">
+                    <a:lnL w="6350" cap="flat" cmpd="sng" algn="ctr">
+                      <a:solidFill>
+                        <a:srgbClr val="000000"/>
+                      </a:solidFill>
+                      <a:prstDash val="solid"/>
+                      <a:round/>
+                      <a:headEnd type="none" w="med" len="med"/>
+                      <a:tailEnd type="none" w="med" len="med"/>
+                    </a:lnL>
+                    <a:lnR w="6350" cap="flat" cmpd="sng" algn="ctr">
+                      <a:solidFill>
+                        <a:srgbClr val="000000"/>
+                      </a:solidFill>
+                      <a:prstDash val="solid"/>
+                      <a:round/>
+                      <a:headEnd type="none" w="med" len="med"/>
+                      <a:tailEnd type="none" w="med" len="med"/>
+                    </a:lnR>
+                    <a:lnT>
+                      <a:noFill/>
+                    </a:lnT>
+                    <a:lnB w="6350" cap="flat" cmpd="sng" algn="ctr">
+                      <a:solidFill>
+                        <a:srgbClr val="000000"/>
+                      </a:solidFill>
+                      <a:prstDash val="solid"/>
+                      <a:round/>
+                      <a:headEnd type="none" w="med" len="med"/>
+                      <a:tailEnd type="none" w="med" len="med"/>
+                    </a:lnB>
+                    <a:solidFill>
+                      <a:srgbClr val="95B3D7"/>
+                    </a:solidFill>
+                  </a:tcPr>
+                </a:tc>
+                <a:tc>
+                  <a:txBody>
+                    <a:bodyPr/>
+                    <a:lstStyle/>
+                    <a:p>
+                      <a:pPr algn="ctr" rtl="0" fontAlgn="t">
+                        <a:buNone/>
+                      </a:pPr>
+                      <a:r>
+                        <a:rPr lang="en-CA" sz="1000" b="0" i="0" u="none" strike="noStrike" dirty="0">
+                          <a:solidFill>
+                            <a:srgbClr val="000000"/>
+                          </a:solidFill>
+                          <a:effectLst/>
+                          <a:latin typeface="Cambria" panose="02040503050406030204" pitchFamily="18" charset="0"/>
+                        </a:rPr>
+                        <a:t>Train Loss</a:t>
+                      </a:r>
+                      <a:endParaRPr lang="en-CA" dirty="0">
+                        <a:effectLst/>
+                      </a:endParaRPr>
+                    </a:p>
+                  </a:txBody>
+                  <a:tcPr marL="68580" marR="68580">
+                    <a:lnL w="6350" cap="flat" cmpd="sng" algn="ctr">
+                      <a:solidFill>
+                        <a:srgbClr val="000000"/>
+                      </a:solidFill>
+                      <a:prstDash val="solid"/>
+                      <a:round/>
+                      <a:headEnd type="none" w="med" len="med"/>
+                      <a:tailEnd type="none" w="med" len="med"/>
+                    </a:lnL>
+                    <a:lnR w="6350" cap="flat" cmpd="sng" algn="ctr">
+                      <a:solidFill>
+                        <a:srgbClr val="000000"/>
+                      </a:solidFill>
+                      <a:prstDash val="solid"/>
+                      <a:round/>
+                      <a:headEnd type="none" w="med" len="med"/>
+                      <a:tailEnd type="none" w="med" len="med"/>
+                    </a:lnR>
+                    <a:lnT>
+                      <a:noFill/>
+                    </a:lnT>
+                    <a:lnB w="6350" cap="flat" cmpd="sng" algn="ctr">
+                      <a:solidFill>
+                        <a:srgbClr val="000000"/>
+                      </a:solidFill>
+                      <a:prstDash val="solid"/>
+                      <a:round/>
+                      <a:headEnd type="none" w="med" len="med"/>
+                      <a:tailEnd type="none" w="med" len="med"/>
+                    </a:lnB>
+                    <a:solidFill>
+                      <a:srgbClr val="95B3D7"/>
+                    </a:solidFill>
+                  </a:tcPr>
+                </a:tc>
+                <a:tc>
+                  <a:txBody>
+                    <a:bodyPr/>
+                    <a:lstStyle/>
+                    <a:p>
+                      <a:pPr algn="ctr" rtl="0" fontAlgn="t">
+                        <a:buNone/>
+                      </a:pPr>
+                      <a:r>
+                        <a:rPr lang="en-CA" sz="1000" b="0" i="0" u="none" strike="noStrike">
+                          <a:solidFill>
+                            <a:srgbClr val="000000"/>
+                          </a:solidFill>
+                          <a:effectLst/>
+                          <a:latin typeface="Cambria" panose="02040503050406030204" pitchFamily="18" charset="0"/>
+                        </a:rPr>
+                        <a:t>Test Loss</a:t>
+                      </a:r>
+                      <a:endParaRPr lang="en-CA">
+                        <a:effectLst/>
+                      </a:endParaRPr>
+                    </a:p>
+                  </a:txBody>
+                  <a:tcPr marL="68580" marR="68580">
+                    <a:lnL w="6350" cap="flat" cmpd="sng" algn="ctr">
+                      <a:solidFill>
+                        <a:srgbClr val="000000"/>
+                      </a:solidFill>
+                      <a:prstDash val="solid"/>
+                      <a:round/>
+                      <a:headEnd type="none" w="med" len="med"/>
+                      <a:tailEnd type="none" w="med" len="med"/>
+                    </a:lnL>
+                    <a:lnR w="6350" cap="flat" cmpd="sng" algn="ctr">
+                      <a:solidFill>
+                        <a:srgbClr val="000000"/>
+                      </a:solidFill>
+                      <a:prstDash val="solid"/>
+                      <a:round/>
+                      <a:headEnd type="none" w="med" len="med"/>
+                      <a:tailEnd type="none" w="med" len="med"/>
+                    </a:lnR>
+                    <a:lnT>
+                      <a:noFill/>
+                    </a:lnT>
+                    <a:lnB w="6350" cap="flat" cmpd="sng" algn="ctr">
+                      <a:solidFill>
+                        <a:srgbClr val="000000"/>
+                      </a:solidFill>
+                      <a:prstDash val="solid"/>
+                      <a:round/>
+                      <a:headEnd type="none" w="med" len="med"/>
+                      <a:tailEnd type="none" w="med" len="med"/>
+                    </a:lnB>
+                    <a:solidFill>
+                      <a:srgbClr val="95B3D7"/>
+                    </a:solidFill>
+                  </a:tcPr>
+                </a:tc>
+                <a:tc>
+                  <a:txBody>
+                    <a:bodyPr/>
+                    <a:lstStyle/>
+                    <a:p>
+                      <a:pPr algn="ctr" rtl="0" fontAlgn="t">
+                        <a:buNone/>
+                      </a:pPr>
+                      <a:r>
+                        <a:rPr lang="en-CA" sz="1000" b="0" i="0" u="none" strike="noStrike">
+                          <a:solidFill>
+                            <a:srgbClr val="000000"/>
+                          </a:solidFill>
+                          <a:effectLst/>
+                          <a:latin typeface="Cambria" panose="02040503050406030204" pitchFamily="18" charset="0"/>
+                        </a:rPr>
+                        <a:t>Convergence</a:t>
+                      </a:r>
+                      <a:endParaRPr lang="en-CA">
+                        <a:effectLst/>
+                      </a:endParaRPr>
+                    </a:p>
+                  </a:txBody>
+                  <a:tcPr marL="68580" marR="68580">
+                    <a:lnL w="6350" cap="flat" cmpd="sng" algn="ctr">
+                      <a:solidFill>
+                        <a:srgbClr val="000000"/>
+                      </a:solidFill>
+                      <a:prstDash val="solid"/>
+                      <a:round/>
+                      <a:headEnd type="none" w="med" len="med"/>
+                      <a:tailEnd type="none" w="med" len="med"/>
+                    </a:lnL>
+                    <a:lnR w="6350" cap="flat" cmpd="sng" algn="ctr">
+                      <a:solidFill>
+                        <a:srgbClr val="000000"/>
+                      </a:solidFill>
+                      <a:prstDash val="solid"/>
+                      <a:round/>
+                      <a:headEnd type="none" w="med" len="med"/>
+                      <a:tailEnd type="none" w="med" len="med"/>
+                    </a:lnR>
+                    <a:lnT>
+                      <a:noFill/>
+                    </a:lnT>
+                    <a:lnB w="6350" cap="flat" cmpd="sng" algn="ctr">
+                      <a:solidFill>
+                        <a:srgbClr val="000000"/>
+                      </a:solidFill>
+                      <a:prstDash val="solid"/>
+                      <a:round/>
+                      <a:headEnd type="none" w="med" len="med"/>
+                      <a:tailEnd type="none" w="med" len="med"/>
+                    </a:lnB>
+                    <a:solidFill>
+                      <a:srgbClr val="95B3D7"/>
+                    </a:solidFill>
+                  </a:tcPr>
+                </a:tc>
+                <a:tc>
+                  <a:txBody>
+                    <a:bodyPr/>
+                    <a:lstStyle/>
+                    <a:p>
+                      <a:pPr algn="ctr" rtl="0" fontAlgn="t">
+                        <a:buNone/>
+                      </a:pPr>
+                      <a:r>
+                        <a:rPr lang="en-CA" sz="1000" b="0" i="0" u="none" strike="noStrike">
+                          <a:solidFill>
+                            <a:srgbClr val="000000"/>
+                          </a:solidFill>
+                          <a:effectLst/>
+                          <a:latin typeface="Cambria" panose="02040503050406030204" pitchFamily="18" charset="0"/>
+                        </a:rPr>
+                        <a:t>Time(s)</a:t>
+                      </a:r>
+                      <a:endParaRPr lang="en-CA">
+                        <a:effectLst/>
+                      </a:endParaRPr>
+                    </a:p>
+                  </a:txBody>
+                  <a:tcPr marL="68580" marR="68580">
+                    <a:lnL w="6350" cap="flat" cmpd="sng" algn="ctr">
+                      <a:solidFill>
+                        <a:srgbClr val="000000"/>
+                      </a:solidFill>
+                      <a:prstDash val="solid"/>
+                      <a:round/>
+                      <a:headEnd type="none" w="med" len="med"/>
+                      <a:tailEnd type="none" w="med" len="med"/>
+                    </a:lnL>
+                    <a:lnR w="6350" cap="flat" cmpd="sng" algn="ctr">
+                      <a:solidFill>
+                        <a:srgbClr val="000000"/>
+                      </a:solidFill>
+                      <a:prstDash val="solid"/>
+                      <a:round/>
+                      <a:headEnd type="none" w="med" len="med"/>
+                      <a:tailEnd type="none" w="med" len="med"/>
+                    </a:lnR>
+                    <a:lnT>
+                      <a:noFill/>
+                    </a:lnT>
+                    <a:lnB w="6350" cap="flat" cmpd="sng" algn="ctr">
+                      <a:solidFill>
+                        <a:srgbClr val="000000"/>
+                      </a:solidFill>
+                      <a:prstDash val="solid"/>
+                      <a:round/>
+                      <a:headEnd type="none" w="med" len="med"/>
+                      <a:tailEnd type="none" w="med" len="med"/>
+                    </a:lnB>
+                    <a:solidFill>
+                      <a:srgbClr val="95B3D7"/>
+                    </a:solidFill>
+                  </a:tcPr>
+                </a:tc>
+                <a:extLst>
+                  <a:ext uri="{0D108BD9-81ED-4DB2-BD59-A6C34878D82A}">
+                    <a16:rowId xmlns:a16="http://schemas.microsoft.com/office/drawing/2014/main" val="3113272472"/>
+                  </a:ext>
+                </a:extLst>
+              </a:tr>
+              <a:tr h="988063">
+                <a:tc>
+                  <a:txBody>
+                    <a:bodyPr/>
+                    <a:lstStyle/>
+                    <a:p>
+                      <a:pPr algn="ctr" rtl="0" fontAlgn="t">
+                        <a:buNone/>
+                      </a:pPr>
+                      <a:r>
+                        <a:rPr lang="en-CA" sz="1000" b="0" i="0" u="none" strike="noStrike">
+                          <a:solidFill>
+                            <a:srgbClr val="000000"/>
+                          </a:solidFill>
+                          <a:effectLst/>
+                          <a:latin typeface="Cambria" panose="02040503050406030204" pitchFamily="18" charset="0"/>
+                        </a:rPr>
+                        <a:t>RMSprop (best)</a:t>
+                      </a:r>
+                      <a:endParaRPr lang="en-CA">
+                        <a:effectLst/>
+                      </a:endParaRPr>
+                    </a:p>
+                  </a:txBody>
+                  <a:tcPr marL="68580" marR="68580">
+                    <a:lnL w="6350" cap="flat" cmpd="sng" algn="ctr">
+                      <a:solidFill>
+                        <a:srgbClr val="000000"/>
+                      </a:solidFill>
+                      <a:prstDash val="solid"/>
+                      <a:round/>
+                      <a:headEnd type="none" w="med" len="med"/>
+                      <a:tailEnd type="none" w="med" len="med"/>
+                    </a:lnL>
+                    <a:lnR w="6350" cap="flat" cmpd="sng" algn="ctr">
+                      <a:solidFill>
+                        <a:srgbClr val="000000"/>
+                      </a:solidFill>
+                      <a:prstDash val="solid"/>
+                      <a:round/>
+                      <a:headEnd type="none" w="med" len="med"/>
+                      <a:tailEnd type="none" w="med" len="med"/>
+                    </a:lnR>
+                    <a:lnT w="6350" cap="flat" cmpd="sng" algn="ctr">
+                      <a:solidFill>
+                        <a:srgbClr val="000000"/>
+                      </a:solidFill>
+                      <a:prstDash val="solid"/>
+                      <a:round/>
+                      <a:headEnd type="none" w="med" len="med"/>
+                      <a:tailEnd type="none" w="med" len="med"/>
+                    </a:lnT>
+                    <a:lnB w="6350" cap="flat" cmpd="sng" algn="ctr">
+                      <a:solidFill>
+                        <a:srgbClr val="000000"/>
+                      </a:solidFill>
+                      <a:prstDash val="solid"/>
+                      <a:round/>
+                      <a:headEnd type="none" w="med" len="med"/>
+                      <a:tailEnd type="none" w="med" len="med"/>
+                    </a:lnB>
+                    <a:noFill/>
+                  </a:tcPr>
+                </a:tc>
+                <a:tc>
+                  <a:txBody>
+                    <a:bodyPr/>
+                    <a:lstStyle/>
+                    <a:p>
+                      <a:pPr algn="ctr" rtl="0" fontAlgn="t">
+                        <a:buNone/>
+                      </a:pPr>
+                      <a:r>
+                        <a:rPr lang="en-CA" sz="1000" b="0" i="0" u="none" strike="noStrike">
+                          <a:solidFill>
+                            <a:srgbClr val="000000"/>
+                          </a:solidFill>
+                          <a:effectLst/>
+                          <a:latin typeface="Cambria" panose="02040503050406030204" pitchFamily="18" charset="0"/>
+                        </a:rPr>
+                        <a:t>95.32</a:t>
+                      </a:r>
+                      <a:endParaRPr lang="en-CA">
+                        <a:effectLst/>
+                      </a:endParaRPr>
+                    </a:p>
+                  </a:txBody>
+                  <a:tcPr marL="68580" marR="68580">
+                    <a:lnL w="6350" cap="flat" cmpd="sng" algn="ctr">
+                      <a:solidFill>
+                        <a:srgbClr val="000000"/>
+                      </a:solidFill>
+                      <a:prstDash val="solid"/>
+                      <a:round/>
+                      <a:headEnd type="none" w="med" len="med"/>
+                      <a:tailEnd type="none" w="med" len="med"/>
+                    </a:lnL>
+                    <a:lnR w="6350" cap="flat" cmpd="sng" algn="ctr">
+                      <a:solidFill>
+                        <a:srgbClr val="000000"/>
+                      </a:solidFill>
+                      <a:prstDash val="solid"/>
+                      <a:round/>
+                      <a:headEnd type="none" w="med" len="med"/>
+                      <a:tailEnd type="none" w="med" len="med"/>
+                    </a:lnR>
+                    <a:lnT w="6350" cap="flat" cmpd="sng" algn="ctr">
+                      <a:solidFill>
+                        <a:srgbClr val="000000"/>
+                      </a:solidFill>
+                      <a:prstDash val="solid"/>
+                      <a:round/>
+                      <a:headEnd type="none" w="med" len="med"/>
+                      <a:tailEnd type="none" w="med" len="med"/>
+                    </a:lnT>
+                    <a:lnB w="6350" cap="flat" cmpd="sng" algn="ctr">
+                      <a:solidFill>
+                        <a:srgbClr val="000000"/>
+                      </a:solidFill>
+                      <a:prstDash val="solid"/>
+                      <a:round/>
+                      <a:headEnd type="none" w="med" len="med"/>
+                      <a:tailEnd type="none" w="med" len="med"/>
+                    </a:lnB>
+                    <a:noFill/>
+                  </a:tcPr>
+                </a:tc>
+                <a:tc>
+                  <a:txBody>
+                    <a:bodyPr/>
+                    <a:lstStyle/>
+                    <a:p>
+                      <a:pPr algn="ctr" rtl="0" fontAlgn="t">
+                        <a:buNone/>
+                      </a:pPr>
+                      <a:r>
+                        <a:rPr lang="en-CA" sz="1000" b="0" i="0" u="none" strike="noStrike">
+                          <a:solidFill>
+                            <a:srgbClr val="000000"/>
+                          </a:solidFill>
+                          <a:effectLst/>
+                          <a:latin typeface="Cambria" panose="02040503050406030204" pitchFamily="18" charset="0"/>
+                        </a:rPr>
+                        <a:t>0.9575</a:t>
+                      </a:r>
+                      <a:endParaRPr lang="en-CA">
+                        <a:effectLst/>
+                      </a:endParaRPr>
+                    </a:p>
+                  </a:txBody>
+                  <a:tcPr marL="68580" marR="68580">
+                    <a:lnL w="6350" cap="flat" cmpd="sng" algn="ctr">
+                      <a:solidFill>
+                        <a:srgbClr val="000000"/>
+                      </a:solidFill>
+                      <a:prstDash val="solid"/>
+                      <a:round/>
+                      <a:headEnd type="none" w="med" len="med"/>
+                      <a:tailEnd type="none" w="med" len="med"/>
+                    </a:lnL>
+                    <a:lnR w="6350" cap="flat" cmpd="sng" algn="ctr">
+                      <a:solidFill>
+                        <a:srgbClr val="000000"/>
+                      </a:solidFill>
+                      <a:prstDash val="solid"/>
+                      <a:round/>
+                      <a:headEnd type="none" w="med" len="med"/>
+                      <a:tailEnd type="none" w="med" len="med"/>
+                    </a:lnR>
+                    <a:lnT w="6350" cap="flat" cmpd="sng" algn="ctr">
+                      <a:solidFill>
+                        <a:srgbClr val="000000"/>
+                      </a:solidFill>
+                      <a:prstDash val="solid"/>
+                      <a:round/>
+                      <a:headEnd type="none" w="med" len="med"/>
+                      <a:tailEnd type="none" w="med" len="med"/>
+                    </a:lnT>
+                    <a:lnB w="6350" cap="flat" cmpd="sng" algn="ctr">
+                      <a:solidFill>
+                        <a:srgbClr val="000000"/>
+                      </a:solidFill>
+                      <a:prstDash val="solid"/>
+                      <a:round/>
+                      <a:headEnd type="none" w="med" len="med"/>
+                      <a:tailEnd type="none" w="med" len="med"/>
+                    </a:lnB>
+                    <a:noFill/>
+                  </a:tcPr>
+                </a:tc>
+                <a:tc>
+                  <a:txBody>
+                    <a:bodyPr/>
+                    <a:lstStyle/>
+                    <a:p>
+                      <a:pPr algn="ctr" rtl="0" fontAlgn="t">
+                        <a:buNone/>
+                      </a:pPr>
+                      <a:r>
+                        <a:rPr lang="en-CA" sz="1000" b="0" i="0" u="none" strike="noStrike">
+                          <a:solidFill>
+                            <a:srgbClr val="000000"/>
+                          </a:solidFill>
+                          <a:effectLst/>
+                          <a:latin typeface="Cambria" panose="02040503050406030204" pitchFamily="18" charset="0"/>
+                        </a:rPr>
+                        <a:t>0.0016</a:t>
+                      </a:r>
+                      <a:endParaRPr lang="en-CA">
+                        <a:effectLst/>
+                      </a:endParaRPr>
+                    </a:p>
+                  </a:txBody>
+                  <a:tcPr marL="68580" marR="68580">
+                    <a:lnL w="6350" cap="flat" cmpd="sng" algn="ctr">
+                      <a:solidFill>
+                        <a:srgbClr val="000000"/>
+                      </a:solidFill>
+                      <a:prstDash val="solid"/>
+                      <a:round/>
+                      <a:headEnd type="none" w="med" len="med"/>
+                      <a:tailEnd type="none" w="med" len="med"/>
+                    </a:lnL>
+                    <a:lnR w="6350" cap="flat" cmpd="sng" algn="ctr">
+                      <a:solidFill>
+                        <a:srgbClr val="000000"/>
+                      </a:solidFill>
+                      <a:prstDash val="solid"/>
+                      <a:round/>
+                      <a:headEnd type="none" w="med" len="med"/>
+                      <a:tailEnd type="none" w="med" len="med"/>
+                    </a:lnR>
+                    <a:lnT w="6350" cap="flat" cmpd="sng" algn="ctr">
+                      <a:solidFill>
+                        <a:srgbClr val="000000"/>
+                      </a:solidFill>
+                      <a:prstDash val="solid"/>
+                      <a:round/>
+                      <a:headEnd type="none" w="med" len="med"/>
+                      <a:tailEnd type="none" w="med" len="med"/>
+                    </a:lnT>
+                    <a:lnB w="6350" cap="flat" cmpd="sng" algn="ctr">
+                      <a:solidFill>
+                        <a:srgbClr val="000000"/>
+                      </a:solidFill>
+                      <a:prstDash val="solid"/>
+                      <a:round/>
+                      <a:headEnd type="none" w="med" len="med"/>
+                      <a:tailEnd type="none" w="med" len="med"/>
+                    </a:lnB>
+                    <a:noFill/>
+                  </a:tcPr>
+                </a:tc>
+                <a:tc>
+                  <a:txBody>
+                    <a:bodyPr/>
+                    <a:lstStyle/>
+                    <a:p>
+                      <a:pPr algn="ctr" rtl="0" fontAlgn="t">
+                        <a:buNone/>
+                      </a:pPr>
+                      <a:r>
+                        <a:rPr lang="en-CA" sz="1000" b="0" i="0" u="none" strike="noStrike" dirty="0">
+                          <a:solidFill>
+                            <a:srgbClr val="000000"/>
+                          </a:solidFill>
+                          <a:effectLst/>
+                          <a:latin typeface="Cambria" panose="02040503050406030204" pitchFamily="18" charset="0"/>
+                        </a:rPr>
+                        <a:t>89.53</a:t>
+                      </a:r>
+                      <a:endParaRPr lang="en-CA" dirty="0">
+                        <a:effectLst/>
+                      </a:endParaRPr>
+                    </a:p>
+                  </a:txBody>
+                  <a:tcPr marL="68580" marR="68580">
+                    <a:lnL w="6350" cap="flat" cmpd="sng" algn="ctr">
+                      <a:solidFill>
+                        <a:srgbClr val="000000"/>
+                      </a:solidFill>
+                      <a:prstDash val="solid"/>
+                      <a:round/>
+                      <a:headEnd type="none" w="med" len="med"/>
+                      <a:tailEnd type="none" w="med" len="med"/>
+                    </a:lnL>
+                    <a:lnR w="6350" cap="flat" cmpd="sng" algn="ctr">
+                      <a:solidFill>
+                        <a:srgbClr val="000000"/>
+                      </a:solidFill>
+                      <a:prstDash val="solid"/>
+                      <a:round/>
+                      <a:headEnd type="none" w="med" len="med"/>
+                      <a:tailEnd type="none" w="med" len="med"/>
+                    </a:lnR>
+                    <a:lnT w="6350" cap="flat" cmpd="sng" algn="ctr">
+                      <a:solidFill>
+                        <a:srgbClr val="000000"/>
+                      </a:solidFill>
+                      <a:prstDash val="solid"/>
+                      <a:round/>
+                      <a:headEnd type="none" w="med" len="med"/>
+                      <a:tailEnd type="none" w="med" len="med"/>
+                    </a:lnT>
+                    <a:lnB w="6350" cap="flat" cmpd="sng" algn="ctr">
+                      <a:solidFill>
+                        <a:srgbClr val="000000"/>
+                      </a:solidFill>
+                      <a:prstDash val="solid"/>
+                      <a:round/>
+                      <a:headEnd type="none" w="med" len="med"/>
+                      <a:tailEnd type="none" w="med" len="med"/>
+                    </a:lnB>
+                    <a:noFill/>
+                  </a:tcPr>
+                </a:tc>
+                <a:tc>
+                  <a:txBody>
+                    <a:bodyPr/>
+                    <a:lstStyle/>
+                    <a:p>
+                      <a:pPr algn="ctr" rtl="0" fontAlgn="t">
+                        <a:buNone/>
+                      </a:pPr>
+                      <a:r>
+                        <a:rPr lang="en-CA" sz="1000" b="0" i="0" u="none" strike="noStrike">
+                          <a:solidFill>
+                            <a:srgbClr val="000000"/>
+                          </a:solidFill>
+                          <a:effectLst/>
+                          <a:latin typeface="Cambria" panose="02040503050406030204" pitchFamily="18" charset="0"/>
+                        </a:rPr>
+                        <a:t>0.1456</a:t>
+                      </a:r>
+                      <a:endParaRPr lang="en-CA">
+                        <a:effectLst/>
+                      </a:endParaRPr>
+                    </a:p>
+                  </a:txBody>
+                  <a:tcPr marL="68580" marR="68580">
+                    <a:lnL w="6350" cap="flat" cmpd="sng" algn="ctr">
+                      <a:solidFill>
+                        <a:srgbClr val="000000"/>
+                      </a:solidFill>
+                      <a:prstDash val="solid"/>
+                      <a:round/>
+                      <a:headEnd type="none" w="med" len="med"/>
+                      <a:tailEnd type="none" w="med" len="med"/>
+                    </a:lnL>
+                    <a:lnR w="6350" cap="flat" cmpd="sng" algn="ctr">
+                      <a:solidFill>
+                        <a:srgbClr val="000000"/>
+                      </a:solidFill>
+                      <a:prstDash val="solid"/>
+                      <a:round/>
+                      <a:headEnd type="none" w="med" len="med"/>
+                      <a:tailEnd type="none" w="med" len="med"/>
+                    </a:lnR>
+                    <a:lnT w="6350" cap="flat" cmpd="sng" algn="ctr">
+                      <a:solidFill>
+                        <a:srgbClr val="000000"/>
+                      </a:solidFill>
+                      <a:prstDash val="solid"/>
+                      <a:round/>
+                      <a:headEnd type="none" w="med" len="med"/>
+                      <a:tailEnd type="none" w="med" len="med"/>
+                    </a:lnT>
+                    <a:lnB w="6350" cap="flat" cmpd="sng" algn="ctr">
+                      <a:solidFill>
+                        <a:srgbClr val="000000"/>
+                      </a:solidFill>
+                      <a:prstDash val="solid"/>
+                      <a:round/>
+                      <a:headEnd type="none" w="med" len="med"/>
+                      <a:tailEnd type="none" w="med" len="med"/>
+                    </a:lnB>
+                    <a:noFill/>
+                  </a:tcPr>
+                </a:tc>
+                <a:tc>
+                  <a:txBody>
+                    <a:bodyPr/>
+                    <a:lstStyle/>
+                    <a:p>
+                      <a:pPr algn="ctr" rtl="0" fontAlgn="t">
+                        <a:buNone/>
+                      </a:pPr>
+                      <a:r>
+                        <a:rPr lang="en-CA" sz="1000" b="0" i="0" u="none" strike="noStrike">
+                          <a:solidFill>
+                            <a:srgbClr val="000000"/>
+                          </a:solidFill>
+                          <a:effectLst/>
+                          <a:latin typeface="Cambria" panose="02040503050406030204" pitchFamily="18" charset="0"/>
+                        </a:rPr>
+                        <a:t>0.3977</a:t>
+                      </a:r>
+                      <a:endParaRPr lang="en-CA">
+                        <a:effectLst/>
+                      </a:endParaRPr>
+                    </a:p>
+                  </a:txBody>
+                  <a:tcPr marL="68580" marR="68580">
+                    <a:lnL w="6350" cap="flat" cmpd="sng" algn="ctr">
+                      <a:solidFill>
+                        <a:srgbClr val="000000"/>
+                      </a:solidFill>
+                      <a:prstDash val="solid"/>
+                      <a:round/>
+                      <a:headEnd type="none" w="med" len="med"/>
+                      <a:tailEnd type="none" w="med" len="med"/>
+                    </a:lnL>
+                    <a:lnR w="6350" cap="flat" cmpd="sng" algn="ctr">
+                      <a:solidFill>
+                        <a:srgbClr val="000000"/>
+                      </a:solidFill>
+                      <a:prstDash val="solid"/>
+                      <a:round/>
+                      <a:headEnd type="none" w="med" len="med"/>
+                      <a:tailEnd type="none" w="med" len="med"/>
+                    </a:lnR>
+                    <a:lnT w="6350" cap="flat" cmpd="sng" algn="ctr">
+                      <a:solidFill>
+                        <a:srgbClr val="000000"/>
+                      </a:solidFill>
+                      <a:prstDash val="solid"/>
+                      <a:round/>
+                      <a:headEnd type="none" w="med" len="med"/>
+                      <a:tailEnd type="none" w="med" len="med"/>
+                    </a:lnT>
+                    <a:lnB w="6350" cap="flat" cmpd="sng" algn="ctr">
+                      <a:solidFill>
+                        <a:srgbClr val="000000"/>
+                      </a:solidFill>
+                      <a:prstDash val="solid"/>
+                      <a:round/>
+                      <a:headEnd type="none" w="med" len="med"/>
+                      <a:tailEnd type="none" w="med" len="med"/>
+                    </a:lnB>
+                    <a:noFill/>
+                  </a:tcPr>
+                </a:tc>
+                <a:tc>
+                  <a:txBody>
+                    <a:bodyPr/>
+                    <a:lstStyle/>
+                    <a:p>
+                      <a:pPr algn="ctr" rtl="0" fontAlgn="t">
+                        <a:buNone/>
+                      </a:pPr>
+                      <a:r>
+                        <a:rPr lang="en-CA" sz="1000" b="0" i="0" u="none" strike="noStrike">
+                          <a:solidFill>
+                            <a:srgbClr val="000000"/>
+                          </a:solidFill>
+                          <a:effectLst/>
+                          <a:latin typeface="Cambria" panose="02040503050406030204" pitchFamily="18" charset="0"/>
+                        </a:rPr>
+                        <a:t>1</a:t>
+                      </a:r>
+                      <a:endParaRPr lang="en-CA">
+                        <a:effectLst/>
+                      </a:endParaRPr>
+                    </a:p>
+                  </a:txBody>
+                  <a:tcPr marL="68580" marR="68580">
+                    <a:lnL w="6350" cap="flat" cmpd="sng" algn="ctr">
+                      <a:solidFill>
+                        <a:srgbClr val="000000"/>
+                      </a:solidFill>
+                      <a:prstDash val="solid"/>
+                      <a:round/>
+                      <a:headEnd type="none" w="med" len="med"/>
+                      <a:tailEnd type="none" w="med" len="med"/>
+                    </a:lnL>
+                    <a:lnR w="6350" cap="flat" cmpd="sng" algn="ctr">
+                      <a:solidFill>
+                        <a:srgbClr val="000000"/>
+                      </a:solidFill>
+                      <a:prstDash val="solid"/>
+                      <a:round/>
+                      <a:headEnd type="none" w="med" len="med"/>
+                      <a:tailEnd type="none" w="med" len="med"/>
+                    </a:lnR>
+                    <a:lnT w="6350" cap="flat" cmpd="sng" algn="ctr">
+                      <a:solidFill>
+                        <a:srgbClr val="000000"/>
+                      </a:solidFill>
+                      <a:prstDash val="solid"/>
+                      <a:round/>
+                      <a:headEnd type="none" w="med" len="med"/>
+                      <a:tailEnd type="none" w="med" len="med"/>
+                    </a:lnT>
+                    <a:lnB w="6350" cap="flat" cmpd="sng" algn="ctr">
+                      <a:solidFill>
+                        <a:srgbClr val="000000"/>
+                      </a:solidFill>
+                      <a:prstDash val="solid"/>
+                      <a:round/>
+                      <a:headEnd type="none" w="med" len="med"/>
+                      <a:tailEnd type="none" w="med" len="med"/>
+                    </a:lnB>
+                    <a:noFill/>
+                  </a:tcPr>
+                </a:tc>
+                <a:tc>
+                  <a:txBody>
+                    <a:bodyPr/>
+                    <a:lstStyle/>
+                    <a:p>
+                      <a:pPr algn="ctr" rtl="0" fontAlgn="t">
+                        <a:buNone/>
+                      </a:pPr>
+                      <a:r>
+                        <a:rPr lang="en-CA" sz="1000" b="0" i="0" u="none" strike="noStrike">
+                          <a:solidFill>
+                            <a:srgbClr val="000000"/>
+                          </a:solidFill>
+                          <a:effectLst/>
+                          <a:latin typeface="Cambria" panose="02040503050406030204" pitchFamily="18" charset="0"/>
+                        </a:rPr>
+                        <a:t>241</a:t>
+                      </a:r>
+                      <a:endParaRPr lang="en-CA">
+                        <a:effectLst/>
+                      </a:endParaRPr>
+                    </a:p>
+                    <a:p>
+                      <a:pPr fontAlgn="t">
+                        <a:buNone/>
+                      </a:pPr>
+                      <a:br>
+                        <a:rPr lang="en-CA">
+                          <a:effectLst/>
+                        </a:rPr>
+                      </a:br>
+                      <a:endParaRPr lang="en-CA">
+                        <a:effectLst/>
+                      </a:endParaRPr>
+                    </a:p>
+                  </a:txBody>
+                  <a:tcPr marL="68580" marR="68580">
+                    <a:lnL w="6350" cap="flat" cmpd="sng" algn="ctr">
+                      <a:solidFill>
+                        <a:srgbClr val="000000"/>
+                      </a:solidFill>
+                      <a:prstDash val="solid"/>
+                      <a:round/>
+                      <a:headEnd type="none" w="med" len="med"/>
+                      <a:tailEnd type="none" w="med" len="med"/>
+                    </a:lnL>
+                    <a:lnR w="6350" cap="flat" cmpd="sng" algn="ctr">
+                      <a:solidFill>
+                        <a:srgbClr val="000000"/>
+                      </a:solidFill>
+                      <a:prstDash val="solid"/>
+                      <a:round/>
+                      <a:headEnd type="none" w="med" len="med"/>
+                      <a:tailEnd type="none" w="med" len="med"/>
+                    </a:lnR>
+                    <a:lnT w="6350" cap="flat" cmpd="sng" algn="ctr">
+                      <a:solidFill>
+                        <a:srgbClr val="000000"/>
+                      </a:solidFill>
+                      <a:prstDash val="solid"/>
+                      <a:round/>
+                      <a:headEnd type="none" w="med" len="med"/>
+                      <a:tailEnd type="none" w="med" len="med"/>
+                    </a:lnT>
+                    <a:lnB w="6350" cap="flat" cmpd="sng" algn="ctr">
+                      <a:solidFill>
+                        <a:srgbClr val="000000"/>
+                      </a:solidFill>
+                      <a:prstDash val="solid"/>
+                      <a:round/>
+                      <a:headEnd type="none" w="med" len="med"/>
+                      <a:tailEnd type="none" w="med" len="med"/>
+                    </a:lnB>
+                    <a:noFill/>
+                  </a:tcPr>
+                </a:tc>
+                <a:extLst>
+                  <a:ext uri="{0D108BD9-81ED-4DB2-BD59-A6C34878D82A}">
+                    <a16:rowId xmlns:a16="http://schemas.microsoft.com/office/drawing/2014/main" val="1875701421"/>
+                  </a:ext>
+                </a:extLst>
+              </a:tr>
+              <a:tr h="935920">
+                <a:tc>
+                  <a:txBody>
+                    <a:bodyPr/>
+                    <a:lstStyle/>
+                    <a:p>
+                      <a:pPr algn="ctr" rtl="0" fontAlgn="t">
+                        <a:buNone/>
+                      </a:pPr>
+                      <a:r>
+                        <a:rPr lang="en-CA" sz="1000" b="0" i="0" u="none" strike="noStrike">
+                          <a:solidFill>
+                            <a:srgbClr val="000000"/>
+                          </a:solidFill>
+                          <a:effectLst/>
+                          <a:latin typeface="Cambria" panose="02040503050406030204" pitchFamily="18" charset="0"/>
+                        </a:rPr>
+                        <a:t>Adam (best)</a:t>
+                      </a:r>
+                      <a:endParaRPr lang="en-CA">
+                        <a:effectLst/>
+                      </a:endParaRPr>
+                    </a:p>
+                  </a:txBody>
+                  <a:tcPr marL="68580" marR="68580">
+                    <a:lnL w="6350" cap="flat" cmpd="sng" algn="ctr">
+                      <a:solidFill>
+                        <a:srgbClr val="000000"/>
+                      </a:solidFill>
+                      <a:prstDash val="solid"/>
+                      <a:round/>
+                      <a:headEnd type="none" w="med" len="med"/>
+                      <a:tailEnd type="none" w="med" len="med"/>
+                    </a:lnL>
+                    <a:lnR w="6350" cap="flat" cmpd="sng" algn="ctr">
+                      <a:solidFill>
+                        <a:srgbClr val="000000"/>
+                      </a:solidFill>
+                      <a:prstDash val="solid"/>
+                      <a:round/>
+                      <a:headEnd type="none" w="med" len="med"/>
+                      <a:tailEnd type="none" w="med" len="med"/>
+                    </a:lnR>
+                    <a:lnT w="6350" cap="flat" cmpd="sng" algn="ctr">
+                      <a:solidFill>
+                        <a:srgbClr val="000000"/>
+                      </a:solidFill>
+                      <a:prstDash val="solid"/>
+                      <a:round/>
+                      <a:headEnd type="none" w="med" len="med"/>
+                      <a:tailEnd type="none" w="med" len="med"/>
+                    </a:lnT>
+                    <a:lnB w="6350" cap="flat" cmpd="sng" algn="ctr">
+                      <a:solidFill>
+                        <a:srgbClr val="000000"/>
+                      </a:solidFill>
+                      <a:prstDash val="solid"/>
+                      <a:round/>
+                      <a:headEnd type="none" w="med" len="med"/>
+                      <a:tailEnd type="none" w="med" len="med"/>
+                    </a:lnB>
+                    <a:noFill/>
+                  </a:tcPr>
+                </a:tc>
+                <a:tc>
+                  <a:txBody>
+                    <a:bodyPr/>
+                    <a:lstStyle/>
+                    <a:p>
+                      <a:pPr algn="ctr" rtl="0" fontAlgn="t">
+                        <a:buNone/>
+                      </a:pPr>
+                      <a:r>
+                        <a:rPr lang="en-CA" sz="1000" b="0" i="0" u="none" strike="noStrike">
+                          <a:solidFill>
+                            <a:srgbClr val="000000"/>
+                          </a:solidFill>
+                          <a:effectLst/>
+                          <a:latin typeface="Cambria" panose="02040503050406030204" pitchFamily="18" charset="0"/>
+                        </a:rPr>
+                        <a:t>95.27</a:t>
+                      </a:r>
+                      <a:endParaRPr lang="en-CA">
+                        <a:effectLst/>
+                      </a:endParaRPr>
+                    </a:p>
+                  </a:txBody>
+                  <a:tcPr marL="68580" marR="68580">
+                    <a:lnL w="6350" cap="flat" cmpd="sng" algn="ctr">
+                      <a:solidFill>
+                        <a:srgbClr val="000000"/>
+                      </a:solidFill>
+                      <a:prstDash val="solid"/>
+                      <a:round/>
+                      <a:headEnd type="none" w="med" len="med"/>
+                      <a:tailEnd type="none" w="med" len="med"/>
+                    </a:lnL>
+                    <a:lnR w="6350" cap="flat" cmpd="sng" algn="ctr">
+                      <a:solidFill>
+                        <a:srgbClr val="000000"/>
+                      </a:solidFill>
+                      <a:prstDash val="solid"/>
+                      <a:round/>
+                      <a:headEnd type="none" w="med" len="med"/>
+                      <a:tailEnd type="none" w="med" len="med"/>
+                    </a:lnR>
+                    <a:lnT w="6350" cap="flat" cmpd="sng" algn="ctr">
+                      <a:solidFill>
+                        <a:srgbClr val="000000"/>
+                      </a:solidFill>
+                      <a:prstDash val="solid"/>
+                      <a:round/>
+                      <a:headEnd type="none" w="med" len="med"/>
+                      <a:tailEnd type="none" w="med" len="med"/>
+                    </a:lnT>
+                    <a:lnB w="6350" cap="flat" cmpd="sng" algn="ctr">
+                      <a:solidFill>
+                        <a:srgbClr val="000000"/>
+                      </a:solidFill>
+                      <a:prstDash val="solid"/>
+                      <a:round/>
+                      <a:headEnd type="none" w="med" len="med"/>
+                      <a:tailEnd type="none" w="med" len="med"/>
+                    </a:lnB>
+                    <a:noFill/>
+                  </a:tcPr>
+                </a:tc>
+                <a:tc>
+                  <a:txBody>
+                    <a:bodyPr/>
+                    <a:lstStyle/>
+                    <a:p>
+                      <a:pPr algn="ctr" rtl="0" fontAlgn="t">
+                        <a:buNone/>
+                      </a:pPr>
+                      <a:r>
+                        <a:rPr lang="en-CA" sz="1000" b="0" i="0" u="none" strike="noStrike">
+                          <a:solidFill>
+                            <a:srgbClr val="000000"/>
+                          </a:solidFill>
+                          <a:effectLst/>
+                          <a:latin typeface="Cambria" panose="02040503050406030204" pitchFamily="18" charset="0"/>
+                        </a:rPr>
+                        <a:t>0.956</a:t>
+                      </a:r>
+                      <a:endParaRPr lang="en-CA">
+                        <a:effectLst/>
+                      </a:endParaRPr>
+                    </a:p>
+                  </a:txBody>
+                  <a:tcPr marL="68580" marR="68580">
+                    <a:lnL w="6350" cap="flat" cmpd="sng" algn="ctr">
+                      <a:solidFill>
+                        <a:srgbClr val="000000"/>
+                      </a:solidFill>
+                      <a:prstDash val="solid"/>
+                      <a:round/>
+                      <a:headEnd type="none" w="med" len="med"/>
+                      <a:tailEnd type="none" w="med" len="med"/>
+                    </a:lnL>
+                    <a:lnR w="6350" cap="flat" cmpd="sng" algn="ctr">
+                      <a:solidFill>
+                        <a:srgbClr val="000000"/>
+                      </a:solidFill>
+                      <a:prstDash val="solid"/>
+                      <a:round/>
+                      <a:headEnd type="none" w="med" len="med"/>
+                      <a:tailEnd type="none" w="med" len="med"/>
+                    </a:lnR>
+                    <a:lnT w="6350" cap="flat" cmpd="sng" algn="ctr">
+                      <a:solidFill>
+                        <a:srgbClr val="000000"/>
+                      </a:solidFill>
+                      <a:prstDash val="solid"/>
+                      <a:round/>
+                      <a:headEnd type="none" w="med" len="med"/>
+                      <a:tailEnd type="none" w="med" len="med"/>
+                    </a:lnT>
+                    <a:lnB w="6350" cap="flat" cmpd="sng" algn="ctr">
+                      <a:solidFill>
+                        <a:srgbClr val="000000"/>
+                      </a:solidFill>
+                      <a:prstDash val="solid"/>
+                      <a:round/>
+                      <a:headEnd type="none" w="med" len="med"/>
+                      <a:tailEnd type="none" w="med" len="med"/>
+                    </a:lnB>
+                    <a:noFill/>
+                  </a:tcPr>
+                </a:tc>
+                <a:tc>
+                  <a:txBody>
+                    <a:bodyPr/>
+                    <a:lstStyle/>
+                    <a:p>
+                      <a:pPr algn="ctr" rtl="0" fontAlgn="t">
+                        <a:buNone/>
+                      </a:pPr>
+                      <a:r>
+                        <a:rPr lang="en-CA" sz="1000" b="0" i="0" u="none" strike="noStrike">
+                          <a:solidFill>
+                            <a:srgbClr val="000000"/>
+                          </a:solidFill>
+                          <a:effectLst/>
+                          <a:latin typeface="Cambria" panose="02040503050406030204" pitchFamily="18" charset="0"/>
+                        </a:rPr>
+                        <a:t>0.0016</a:t>
+                      </a:r>
+                      <a:endParaRPr lang="en-CA">
+                        <a:effectLst/>
+                      </a:endParaRPr>
+                    </a:p>
+                  </a:txBody>
+                  <a:tcPr marL="68580" marR="68580">
+                    <a:lnL w="6350" cap="flat" cmpd="sng" algn="ctr">
+                      <a:solidFill>
+                        <a:srgbClr val="000000"/>
+                      </a:solidFill>
+                      <a:prstDash val="solid"/>
+                      <a:round/>
+                      <a:headEnd type="none" w="med" len="med"/>
+                      <a:tailEnd type="none" w="med" len="med"/>
+                    </a:lnL>
+                    <a:lnR w="6350" cap="flat" cmpd="sng" algn="ctr">
+                      <a:solidFill>
+                        <a:srgbClr val="000000"/>
+                      </a:solidFill>
+                      <a:prstDash val="solid"/>
+                      <a:round/>
+                      <a:headEnd type="none" w="med" len="med"/>
+                      <a:tailEnd type="none" w="med" len="med"/>
+                    </a:lnR>
+                    <a:lnT w="6350" cap="flat" cmpd="sng" algn="ctr">
+                      <a:solidFill>
+                        <a:srgbClr val="000000"/>
+                      </a:solidFill>
+                      <a:prstDash val="solid"/>
+                      <a:round/>
+                      <a:headEnd type="none" w="med" len="med"/>
+                      <a:tailEnd type="none" w="med" len="med"/>
+                    </a:lnT>
+                    <a:lnB w="6350" cap="flat" cmpd="sng" algn="ctr">
+                      <a:solidFill>
+                        <a:srgbClr val="000000"/>
+                      </a:solidFill>
+                      <a:prstDash val="solid"/>
+                      <a:round/>
+                      <a:headEnd type="none" w="med" len="med"/>
+                      <a:tailEnd type="none" w="med" len="med"/>
+                    </a:lnB>
+                    <a:noFill/>
+                  </a:tcPr>
+                </a:tc>
+                <a:tc>
+                  <a:txBody>
+                    <a:bodyPr/>
+                    <a:lstStyle/>
+                    <a:p>
+                      <a:pPr algn="ctr" rtl="0" fontAlgn="t">
+                        <a:buNone/>
+                      </a:pPr>
+                      <a:r>
+                        <a:rPr lang="en-CA" sz="1000" b="0" i="0" u="none" strike="noStrike">
+                          <a:solidFill>
+                            <a:srgbClr val="000000"/>
+                          </a:solidFill>
+                          <a:effectLst/>
+                          <a:latin typeface="Cambria" panose="02040503050406030204" pitchFamily="18" charset="0"/>
+                        </a:rPr>
+                        <a:t>89.69</a:t>
+                      </a:r>
+                      <a:endParaRPr lang="en-CA">
+                        <a:effectLst/>
+                      </a:endParaRPr>
+                    </a:p>
+                  </a:txBody>
+                  <a:tcPr marL="68580" marR="68580">
+                    <a:lnL w="6350" cap="flat" cmpd="sng" algn="ctr">
+                      <a:solidFill>
+                        <a:srgbClr val="000000"/>
+                      </a:solidFill>
+                      <a:prstDash val="solid"/>
+                      <a:round/>
+                      <a:headEnd type="none" w="med" len="med"/>
+                      <a:tailEnd type="none" w="med" len="med"/>
+                    </a:lnL>
+                    <a:lnR w="6350" cap="flat" cmpd="sng" algn="ctr">
+                      <a:solidFill>
+                        <a:srgbClr val="000000"/>
+                      </a:solidFill>
+                      <a:prstDash val="solid"/>
+                      <a:round/>
+                      <a:headEnd type="none" w="med" len="med"/>
+                      <a:tailEnd type="none" w="med" len="med"/>
+                    </a:lnR>
+                    <a:lnT w="6350" cap="flat" cmpd="sng" algn="ctr">
+                      <a:solidFill>
+                        <a:srgbClr val="000000"/>
+                      </a:solidFill>
+                      <a:prstDash val="solid"/>
+                      <a:round/>
+                      <a:headEnd type="none" w="med" len="med"/>
+                      <a:tailEnd type="none" w="med" len="med"/>
+                    </a:lnT>
+                    <a:lnB w="6350" cap="flat" cmpd="sng" algn="ctr">
+                      <a:solidFill>
+                        <a:srgbClr val="000000"/>
+                      </a:solidFill>
+                      <a:prstDash val="solid"/>
+                      <a:round/>
+                      <a:headEnd type="none" w="med" len="med"/>
+                      <a:tailEnd type="none" w="med" len="med"/>
+                    </a:lnB>
+                    <a:noFill/>
+                  </a:tcPr>
+                </a:tc>
+                <a:tc>
+                  <a:txBody>
+                    <a:bodyPr/>
+                    <a:lstStyle/>
+                    <a:p>
+                      <a:pPr algn="ctr" rtl="0" fontAlgn="t">
+                        <a:buNone/>
+                      </a:pPr>
+                      <a:r>
+                        <a:rPr lang="en-CA" sz="1000" b="0" i="0" u="none" strike="noStrike">
+                          <a:solidFill>
+                            <a:srgbClr val="000000"/>
+                          </a:solidFill>
+                          <a:effectLst/>
+                          <a:latin typeface="Cambria" panose="02040503050406030204" pitchFamily="18" charset="0"/>
+                        </a:rPr>
+                        <a:t>0.1461</a:t>
+                      </a:r>
+                      <a:endParaRPr lang="en-CA">
+                        <a:effectLst/>
+                      </a:endParaRPr>
+                    </a:p>
+                  </a:txBody>
+                  <a:tcPr marL="68580" marR="68580">
+                    <a:lnL w="6350" cap="flat" cmpd="sng" algn="ctr">
+                      <a:solidFill>
+                        <a:srgbClr val="000000"/>
+                      </a:solidFill>
+                      <a:prstDash val="solid"/>
+                      <a:round/>
+                      <a:headEnd type="none" w="med" len="med"/>
+                      <a:tailEnd type="none" w="med" len="med"/>
+                    </a:lnL>
+                    <a:lnR w="6350" cap="flat" cmpd="sng" algn="ctr">
+                      <a:solidFill>
+                        <a:srgbClr val="000000"/>
+                      </a:solidFill>
+                      <a:prstDash val="solid"/>
+                      <a:round/>
+                      <a:headEnd type="none" w="med" len="med"/>
+                      <a:tailEnd type="none" w="med" len="med"/>
+                    </a:lnR>
+                    <a:lnT w="6350" cap="flat" cmpd="sng" algn="ctr">
+                      <a:solidFill>
+                        <a:srgbClr val="000000"/>
+                      </a:solidFill>
+                      <a:prstDash val="solid"/>
+                      <a:round/>
+                      <a:headEnd type="none" w="med" len="med"/>
+                      <a:tailEnd type="none" w="med" len="med"/>
+                    </a:lnT>
+                    <a:lnB w="6350" cap="flat" cmpd="sng" algn="ctr">
+                      <a:solidFill>
+                        <a:srgbClr val="000000"/>
+                      </a:solidFill>
+                      <a:prstDash val="solid"/>
+                      <a:round/>
+                      <a:headEnd type="none" w="med" len="med"/>
+                      <a:tailEnd type="none" w="med" len="med"/>
+                    </a:lnB>
+                    <a:noFill/>
+                  </a:tcPr>
+                </a:tc>
+                <a:tc>
+                  <a:txBody>
+                    <a:bodyPr/>
+                    <a:lstStyle/>
+                    <a:p>
+                      <a:pPr algn="ctr" rtl="0" fontAlgn="t">
+                        <a:buNone/>
+                      </a:pPr>
+                      <a:r>
+                        <a:rPr lang="en-CA" sz="1000" b="0" i="0" u="none" strike="noStrike">
+                          <a:solidFill>
+                            <a:srgbClr val="000000"/>
+                          </a:solidFill>
+                          <a:effectLst/>
+                          <a:latin typeface="Cambria" panose="02040503050406030204" pitchFamily="18" charset="0"/>
+                        </a:rPr>
+                        <a:t>0.3702</a:t>
+                      </a:r>
+                      <a:endParaRPr lang="en-CA">
+                        <a:effectLst/>
+                      </a:endParaRPr>
+                    </a:p>
+                  </a:txBody>
+                  <a:tcPr marL="68580" marR="68580">
+                    <a:lnL w="6350" cap="flat" cmpd="sng" algn="ctr">
+                      <a:solidFill>
+                        <a:srgbClr val="000000"/>
+                      </a:solidFill>
+                      <a:prstDash val="solid"/>
+                      <a:round/>
+                      <a:headEnd type="none" w="med" len="med"/>
+                      <a:tailEnd type="none" w="med" len="med"/>
+                    </a:lnL>
+                    <a:lnR w="6350" cap="flat" cmpd="sng" algn="ctr">
+                      <a:solidFill>
+                        <a:srgbClr val="000000"/>
+                      </a:solidFill>
+                      <a:prstDash val="solid"/>
+                      <a:round/>
+                      <a:headEnd type="none" w="med" len="med"/>
+                      <a:tailEnd type="none" w="med" len="med"/>
+                    </a:lnR>
+                    <a:lnT w="6350" cap="flat" cmpd="sng" algn="ctr">
+                      <a:solidFill>
+                        <a:srgbClr val="000000"/>
+                      </a:solidFill>
+                      <a:prstDash val="solid"/>
+                      <a:round/>
+                      <a:headEnd type="none" w="med" len="med"/>
+                      <a:tailEnd type="none" w="med" len="med"/>
+                    </a:lnT>
+                    <a:lnB w="6350" cap="flat" cmpd="sng" algn="ctr">
+                      <a:solidFill>
+                        <a:srgbClr val="000000"/>
+                      </a:solidFill>
+                      <a:prstDash val="solid"/>
+                      <a:round/>
+                      <a:headEnd type="none" w="med" len="med"/>
+                      <a:tailEnd type="none" w="med" len="med"/>
+                    </a:lnB>
+                    <a:noFill/>
+                  </a:tcPr>
+                </a:tc>
+                <a:tc>
+                  <a:txBody>
+                    <a:bodyPr/>
+                    <a:lstStyle/>
+                    <a:p>
+                      <a:pPr algn="ctr" rtl="0" fontAlgn="t">
+                        <a:buNone/>
+                      </a:pPr>
+                      <a:r>
+                        <a:rPr lang="en-CA" sz="1000" b="0" i="0" u="none" strike="noStrike">
+                          <a:solidFill>
+                            <a:srgbClr val="000000"/>
+                          </a:solidFill>
+                          <a:effectLst/>
+                          <a:latin typeface="Cambria" panose="02040503050406030204" pitchFamily="18" charset="0"/>
+                        </a:rPr>
+                        <a:t>1</a:t>
+                      </a:r>
+                      <a:endParaRPr lang="en-CA">
+                        <a:effectLst/>
+                      </a:endParaRPr>
+                    </a:p>
+                  </a:txBody>
+                  <a:tcPr marL="68580" marR="68580">
+                    <a:lnL w="6350" cap="flat" cmpd="sng" algn="ctr">
+                      <a:solidFill>
+                        <a:srgbClr val="000000"/>
+                      </a:solidFill>
+                      <a:prstDash val="solid"/>
+                      <a:round/>
+                      <a:headEnd type="none" w="med" len="med"/>
+                      <a:tailEnd type="none" w="med" len="med"/>
+                    </a:lnL>
+                    <a:lnR w="6350" cap="flat" cmpd="sng" algn="ctr">
+                      <a:solidFill>
+                        <a:srgbClr val="000000"/>
+                      </a:solidFill>
+                      <a:prstDash val="solid"/>
+                      <a:round/>
+                      <a:headEnd type="none" w="med" len="med"/>
+                      <a:tailEnd type="none" w="med" len="med"/>
+                    </a:lnR>
+                    <a:lnT w="6350" cap="flat" cmpd="sng" algn="ctr">
+                      <a:solidFill>
+                        <a:srgbClr val="000000"/>
+                      </a:solidFill>
+                      <a:prstDash val="solid"/>
+                      <a:round/>
+                      <a:headEnd type="none" w="med" len="med"/>
+                      <a:tailEnd type="none" w="med" len="med"/>
+                    </a:lnT>
+                    <a:lnB w="6350" cap="flat" cmpd="sng" algn="ctr">
+                      <a:solidFill>
+                        <a:srgbClr val="000000"/>
+                      </a:solidFill>
+                      <a:prstDash val="solid"/>
+                      <a:round/>
+                      <a:headEnd type="none" w="med" len="med"/>
+                      <a:tailEnd type="none" w="med" len="med"/>
+                    </a:lnB>
+                    <a:noFill/>
+                  </a:tcPr>
+                </a:tc>
+                <a:tc>
+                  <a:txBody>
+                    <a:bodyPr/>
+                    <a:lstStyle/>
+                    <a:p>
+                      <a:pPr algn="ctr" rtl="0" fontAlgn="t">
+                        <a:buNone/>
+                      </a:pPr>
+                      <a:r>
+                        <a:rPr lang="en-CA" sz="1000" b="0" i="0" u="none" strike="noStrike">
+                          <a:solidFill>
+                            <a:srgbClr val="000000"/>
+                          </a:solidFill>
+                          <a:effectLst/>
+                          <a:latin typeface="Cambria" panose="02040503050406030204" pitchFamily="18" charset="0"/>
+                        </a:rPr>
+                        <a:t>247</a:t>
+                      </a:r>
+                      <a:endParaRPr lang="en-CA">
+                        <a:effectLst/>
+                      </a:endParaRPr>
+                    </a:p>
+                  </a:txBody>
+                  <a:tcPr marL="68580" marR="68580">
+                    <a:lnL w="6350" cap="flat" cmpd="sng" algn="ctr">
+                      <a:solidFill>
+                        <a:srgbClr val="000000"/>
+                      </a:solidFill>
+                      <a:prstDash val="solid"/>
+                      <a:round/>
+                      <a:headEnd type="none" w="med" len="med"/>
+                      <a:tailEnd type="none" w="med" len="med"/>
+                    </a:lnL>
+                    <a:lnR w="6350" cap="flat" cmpd="sng" algn="ctr">
+                      <a:solidFill>
+                        <a:srgbClr val="000000"/>
+                      </a:solidFill>
+                      <a:prstDash val="solid"/>
+                      <a:round/>
+                      <a:headEnd type="none" w="med" len="med"/>
+                      <a:tailEnd type="none" w="med" len="med"/>
+                    </a:lnR>
+                    <a:lnT w="6350" cap="flat" cmpd="sng" algn="ctr">
+                      <a:solidFill>
+                        <a:srgbClr val="000000"/>
+                      </a:solidFill>
+                      <a:prstDash val="solid"/>
+                      <a:round/>
+                      <a:headEnd type="none" w="med" len="med"/>
+                      <a:tailEnd type="none" w="med" len="med"/>
+                    </a:lnT>
+                    <a:lnB w="6350" cap="flat" cmpd="sng" algn="ctr">
+                      <a:solidFill>
+                        <a:srgbClr val="000000"/>
+                      </a:solidFill>
+                      <a:prstDash val="solid"/>
+                      <a:round/>
+                      <a:headEnd type="none" w="med" len="med"/>
+                      <a:tailEnd type="none" w="med" len="med"/>
+                    </a:lnB>
+                    <a:noFill/>
+                  </a:tcPr>
+                </a:tc>
+                <a:extLst>
+                  <a:ext uri="{0D108BD9-81ED-4DB2-BD59-A6C34878D82A}">
+                    <a16:rowId xmlns:a16="http://schemas.microsoft.com/office/drawing/2014/main" val="2668230351"/>
+                  </a:ext>
+                </a:extLst>
+              </a:tr>
+              <a:tr h="935920">
+                <a:tc>
+                  <a:txBody>
+                    <a:bodyPr/>
+                    <a:lstStyle/>
+                    <a:p>
+                      <a:pPr algn="ctr" rtl="0" fontAlgn="t">
+                        <a:buNone/>
+                      </a:pPr>
+                      <a:r>
+                        <a:rPr lang="en-CA" sz="1000" b="0" i="0" u="none" strike="noStrike">
+                          <a:solidFill>
+                            <a:srgbClr val="000000"/>
+                          </a:solidFill>
+                          <a:effectLst/>
+                          <a:latin typeface="Cambria" panose="02040503050406030204" pitchFamily="18" charset="0"/>
+                        </a:rPr>
+                        <a:t>AdamW (best)</a:t>
+                      </a:r>
+                      <a:endParaRPr lang="en-CA">
+                        <a:effectLst/>
+                      </a:endParaRPr>
+                    </a:p>
+                  </a:txBody>
+                  <a:tcPr marL="68580" marR="68580">
+                    <a:lnL w="6350" cap="flat" cmpd="sng" algn="ctr">
+                      <a:solidFill>
+                        <a:srgbClr val="000000"/>
+                      </a:solidFill>
+                      <a:prstDash val="solid"/>
+                      <a:round/>
+                      <a:headEnd type="none" w="med" len="med"/>
+                      <a:tailEnd type="none" w="med" len="med"/>
+                    </a:lnL>
+                    <a:lnR w="6350" cap="flat" cmpd="sng" algn="ctr">
+                      <a:solidFill>
+                        <a:srgbClr val="000000"/>
+                      </a:solidFill>
+                      <a:prstDash val="solid"/>
+                      <a:round/>
+                      <a:headEnd type="none" w="med" len="med"/>
+                      <a:tailEnd type="none" w="med" len="med"/>
+                    </a:lnR>
+                    <a:lnT w="6350" cap="flat" cmpd="sng" algn="ctr">
+                      <a:solidFill>
+                        <a:srgbClr val="000000"/>
+                      </a:solidFill>
+                      <a:prstDash val="solid"/>
+                      <a:round/>
+                      <a:headEnd type="none" w="med" len="med"/>
+                      <a:tailEnd type="none" w="med" len="med"/>
+                    </a:lnT>
+                    <a:lnB w="6350" cap="flat" cmpd="sng" algn="ctr">
+                      <a:solidFill>
+                        <a:srgbClr val="000000"/>
+                      </a:solidFill>
+                      <a:prstDash val="solid"/>
+                      <a:round/>
+                      <a:headEnd type="none" w="med" len="med"/>
+                      <a:tailEnd type="none" w="med" len="med"/>
+                    </a:lnB>
+                    <a:noFill/>
+                  </a:tcPr>
+                </a:tc>
+                <a:tc>
+                  <a:txBody>
+                    <a:bodyPr/>
+                    <a:lstStyle/>
+                    <a:p>
+                      <a:pPr algn="ctr" rtl="0" fontAlgn="t">
+                        <a:buNone/>
+                      </a:pPr>
+                      <a:r>
+                        <a:rPr lang="en-CA" sz="1000" b="0" i="0" u="none" strike="noStrike">
+                          <a:solidFill>
+                            <a:srgbClr val="000000"/>
+                          </a:solidFill>
+                          <a:effectLst/>
+                          <a:latin typeface="Cambria" panose="02040503050406030204" pitchFamily="18" charset="0"/>
+                        </a:rPr>
+                        <a:t>95.78</a:t>
+                      </a:r>
+                      <a:endParaRPr lang="en-CA">
+                        <a:effectLst/>
+                      </a:endParaRPr>
+                    </a:p>
+                  </a:txBody>
+                  <a:tcPr marL="68580" marR="68580">
+                    <a:lnL w="6350" cap="flat" cmpd="sng" algn="ctr">
+                      <a:solidFill>
+                        <a:srgbClr val="000000"/>
+                      </a:solidFill>
+                      <a:prstDash val="solid"/>
+                      <a:round/>
+                      <a:headEnd type="none" w="med" len="med"/>
+                      <a:tailEnd type="none" w="med" len="med"/>
+                    </a:lnL>
+                    <a:lnR w="6350" cap="flat" cmpd="sng" algn="ctr">
+                      <a:solidFill>
+                        <a:srgbClr val="000000"/>
+                      </a:solidFill>
+                      <a:prstDash val="solid"/>
+                      <a:round/>
+                      <a:headEnd type="none" w="med" len="med"/>
+                      <a:tailEnd type="none" w="med" len="med"/>
+                    </a:lnR>
+                    <a:lnT w="6350" cap="flat" cmpd="sng" algn="ctr">
+                      <a:solidFill>
+                        <a:srgbClr val="000000"/>
+                      </a:solidFill>
+                      <a:prstDash val="solid"/>
+                      <a:round/>
+                      <a:headEnd type="none" w="med" len="med"/>
+                      <a:tailEnd type="none" w="med" len="med"/>
+                    </a:lnT>
+                    <a:lnB w="6350" cap="flat" cmpd="sng" algn="ctr">
+                      <a:solidFill>
+                        <a:srgbClr val="000000"/>
+                      </a:solidFill>
+                      <a:prstDash val="solid"/>
+                      <a:round/>
+                      <a:headEnd type="none" w="med" len="med"/>
+                      <a:tailEnd type="none" w="med" len="med"/>
+                    </a:lnB>
+                    <a:noFill/>
+                  </a:tcPr>
+                </a:tc>
+                <a:tc>
+                  <a:txBody>
+                    <a:bodyPr/>
+                    <a:lstStyle/>
+                    <a:p>
+                      <a:pPr algn="ctr" rtl="0" fontAlgn="t">
+                        <a:buNone/>
+                      </a:pPr>
+                      <a:r>
+                        <a:rPr lang="en-CA" sz="1000" b="0" i="0" u="none" strike="noStrike">
+                          <a:solidFill>
+                            <a:srgbClr val="000000"/>
+                          </a:solidFill>
+                          <a:effectLst/>
+                          <a:latin typeface="Cambria" panose="02040503050406030204" pitchFamily="18" charset="0"/>
+                        </a:rPr>
+                        <a:t>0.9564</a:t>
+                      </a:r>
+                      <a:endParaRPr lang="en-CA">
+                        <a:effectLst/>
+                      </a:endParaRPr>
+                    </a:p>
+                  </a:txBody>
+                  <a:tcPr marL="68580" marR="68580">
+                    <a:lnL w="6350" cap="flat" cmpd="sng" algn="ctr">
+                      <a:solidFill>
+                        <a:srgbClr val="000000"/>
+                      </a:solidFill>
+                      <a:prstDash val="solid"/>
+                      <a:round/>
+                      <a:headEnd type="none" w="med" len="med"/>
+                      <a:tailEnd type="none" w="med" len="med"/>
+                    </a:lnL>
+                    <a:lnR w="6350" cap="flat" cmpd="sng" algn="ctr">
+                      <a:solidFill>
+                        <a:srgbClr val="000000"/>
+                      </a:solidFill>
+                      <a:prstDash val="solid"/>
+                      <a:round/>
+                      <a:headEnd type="none" w="med" len="med"/>
+                      <a:tailEnd type="none" w="med" len="med"/>
+                    </a:lnR>
+                    <a:lnT w="6350" cap="flat" cmpd="sng" algn="ctr">
+                      <a:solidFill>
+                        <a:srgbClr val="000000"/>
+                      </a:solidFill>
+                      <a:prstDash val="solid"/>
+                      <a:round/>
+                      <a:headEnd type="none" w="med" len="med"/>
+                      <a:tailEnd type="none" w="med" len="med"/>
+                    </a:lnT>
+                    <a:lnB w="6350" cap="flat" cmpd="sng" algn="ctr">
+                      <a:solidFill>
+                        <a:srgbClr val="000000"/>
+                      </a:solidFill>
+                      <a:prstDash val="solid"/>
+                      <a:round/>
+                      <a:headEnd type="none" w="med" len="med"/>
+                      <a:tailEnd type="none" w="med" len="med"/>
+                    </a:lnB>
+                    <a:noFill/>
+                  </a:tcPr>
+                </a:tc>
+                <a:tc>
+                  <a:txBody>
+                    <a:bodyPr/>
+                    <a:lstStyle/>
+                    <a:p>
+                      <a:pPr algn="ctr" rtl="0" fontAlgn="t">
+                        <a:buNone/>
+                      </a:pPr>
+                      <a:r>
+                        <a:rPr lang="en-CA" sz="1000" b="0" i="0" u="none" strike="noStrike">
+                          <a:solidFill>
+                            <a:srgbClr val="000000"/>
+                          </a:solidFill>
+                          <a:effectLst/>
+                          <a:latin typeface="Cambria" panose="02040503050406030204" pitchFamily="18" charset="0"/>
+                        </a:rPr>
+                        <a:t>0.0015</a:t>
+                      </a:r>
+                      <a:endParaRPr lang="en-CA">
+                        <a:effectLst/>
+                      </a:endParaRPr>
+                    </a:p>
+                  </a:txBody>
+                  <a:tcPr marL="68580" marR="68580">
+                    <a:lnL w="6350" cap="flat" cmpd="sng" algn="ctr">
+                      <a:solidFill>
+                        <a:srgbClr val="000000"/>
+                      </a:solidFill>
+                      <a:prstDash val="solid"/>
+                      <a:round/>
+                      <a:headEnd type="none" w="med" len="med"/>
+                      <a:tailEnd type="none" w="med" len="med"/>
+                    </a:lnL>
+                    <a:lnR w="6350" cap="flat" cmpd="sng" algn="ctr">
+                      <a:solidFill>
+                        <a:srgbClr val="000000"/>
+                      </a:solidFill>
+                      <a:prstDash val="solid"/>
+                      <a:round/>
+                      <a:headEnd type="none" w="med" len="med"/>
+                      <a:tailEnd type="none" w="med" len="med"/>
+                    </a:lnR>
+                    <a:lnT w="6350" cap="flat" cmpd="sng" algn="ctr">
+                      <a:solidFill>
+                        <a:srgbClr val="000000"/>
+                      </a:solidFill>
+                      <a:prstDash val="solid"/>
+                      <a:round/>
+                      <a:headEnd type="none" w="med" len="med"/>
+                      <a:tailEnd type="none" w="med" len="med"/>
+                    </a:lnT>
+                    <a:lnB w="6350" cap="flat" cmpd="sng" algn="ctr">
+                      <a:solidFill>
+                        <a:srgbClr val="000000"/>
+                      </a:solidFill>
+                      <a:prstDash val="solid"/>
+                      <a:round/>
+                      <a:headEnd type="none" w="med" len="med"/>
+                      <a:tailEnd type="none" w="med" len="med"/>
+                    </a:lnB>
+                    <a:noFill/>
+                  </a:tcPr>
+                </a:tc>
+                <a:tc>
+                  <a:txBody>
+                    <a:bodyPr/>
+                    <a:lstStyle/>
+                    <a:p>
+                      <a:pPr algn="ctr" rtl="0" fontAlgn="t">
+                        <a:buNone/>
+                      </a:pPr>
+                      <a:r>
+                        <a:rPr lang="en-CA" sz="1000" b="0" i="0" u="none" strike="noStrike">
+                          <a:solidFill>
+                            <a:srgbClr val="000000"/>
+                          </a:solidFill>
+                          <a:effectLst/>
+                          <a:latin typeface="Cambria" panose="02040503050406030204" pitchFamily="18" charset="0"/>
+                        </a:rPr>
+                        <a:t>89.67</a:t>
+                      </a:r>
+                      <a:endParaRPr lang="en-CA">
+                        <a:effectLst/>
+                      </a:endParaRPr>
+                    </a:p>
+                  </a:txBody>
+                  <a:tcPr marL="68580" marR="68580">
+                    <a:lnL w="6350" cap="flat" cmpd="sng" algn="ctr">
+                      <a:solidFill>
+                        <a:srgbClr val="000000"/>
+                      </a:solidFill>
+                      <a:prstDash val="solid"/>
+                      <a:round/>
+                      <a:headEnd type="none" w="med" len="med"/>
+                      <a:tailEnd type="none" w="med" len="med"/>
+                    </a:lnL>
+                    <a:lnR w="6350" cap="flat" cmpd="sng" algn="ctr">
+                      <a:solidFill>
+                        <a:srgbClr val="000000"/>
+                      </a:solidFill>
+                      <a:prstDash val="solid"/>
+                      <a:round/>
+                      <a:headEnd type="none" w="med" len="med"/>
+                      <a:tailEnd type="none" w="med" len="med"/>
+                    </a:lnR>
+                    <a:lnT w="6350" cap="flat" cmpd="sng" algn="ctr">
+                      <a:solidFill>
+                        <a:srgbClr val="000000"/>
+                      </a:solidFill>
+                      <a:prstDash val="solid"/>
+                      <a:round/>
+                      <a:headEnd type="none" w="med" len="med"/>
+                      <a:tailEnd type="none" w="med" len="med"/>
+                    </a:lnT>
+                    <a:lnB w="6350" cap="flat" cmpd="sng" algn="ctr">
+                      <a:solidFill>
+                        <a:srgbClr val="000000"/>
+                      </a:solidFill>
+                      <a:prstDash val="solid"/>
+                      <a:round/>
+                      <a:headEnd type="none" w="med" len="med"/>
+                      <a:tailEnd type="none" w="med" len="med"/>
+                    </a:lnB>
+                    <a:noFill/>
+                  </a:tcPr>
+                </a:tc>
+                <a:tc>
+                  <a:txBody>
+                    <a:bodyPr/>
+                    <a:lstStyle/>
+                    <a:p>
+                      <a:pPr algn="ctr" rtl="0" fontAlgn="t">
+                        <a:buNone/>
+                      </a:pPr>
+                      <a:r>
+                        <a:rPr lang="en-CA" sz="1000" b="0" i="0" u="none" strike="noStrike">
+                          <a:solidFill>
+                            <a:srgbClr val="000000"/>
+                          </a:solidFill>
+                          <a:effectLst/>
+                          <a:latin typeface="Cambria" panose="02040503050406030204" pitchFamily="18" charset="0"/>
+                        </a:rPr>
+                        <a:t>0.1302</a:t>
+                      </a:r>
+                      <a:endParaRPr lang="en-CA">
+                        <a:effectLst/>
+                      </a:endParaRPr>
+                    </a:p>
+                  </a:txBody>
+                  <a:tcPr marL="68580" marR="68580">
+                    <a:lnL w="6350" cap="flat" cmpd="sng" algn="ctr">
+                      <a:solidFill>
+                        <a:srgbClr val="000000"/>
+                      </a:solidFill>
+                      <a:prstDash val="solid"/>
+                      <a:round/>
+                      <a:headEnd type="none" w="med" len="med"/>
+                      <a:tailEnd type="none" w="med" len="med"/>
+                    </a:lnL>
+                    <a:lnR w="6350" cap="flat" cmpd="sng" algn="ctr">
+                      <a:solidFill>
+                        <a:srgbClr val="000000"/>
+                      </a:solidFill>
+                      <a:prstDash val="solid"/>
+                      <a:round/>
+                      <a:headEnd type="none" w="med" len="med"/>
+                      <a:tailEnd type="none" w="med" len="med"/>
+                    </a:lnR>
+                    <a:lnT w="6350" cap="flat" cmpd="sng" algn="ctr">
+                      <a:solidFill>
+                        <a:srgbClr val="000000"/>
+                      </a:solidFill>
+                      <a:prstDash val="solid"/>
+                      <a:round/>
+                      <a:headEnd type="none" w="med" len="med"/>
+                      <a:tailEnd type="none" w="med" len="med"/>
+                    </a:lnT>
+                    <a:lnB w="6350" cap="flat" cmpd="sng" algn="ctr">
+                      <a:solidFill>
+                        <a:srgbClr val="000000"/>
+                      </a:solidFill>
+                      <a:prstDash val="solid"/>
+                      <a:round/>
+                      <a:headEnd type="none" w="med" len="med"/>
+                      <a:tailEnd type="none" w="med" len="med"/>
+                    </a:lnB>
+                    <a:noFill/>
+                  </a:tcPr>
+                </a:tc>
+                <a:tc>
+                  <a:txBody>
+                    <a:bodyPr/>
+                    <a:lstStyle/>
+                    <a:p>
+                      <a:pPr algn="ctr" rtl="0" fontAlgn="t">
+                        <a:buNone/>
+                      </a:pPr>
+                      <a:r>
+                        <a:rPr lang="en-CA" sz="1000" b="0" i="0" u="none" strike="noStrike">
+                          <a:solidFill>
+                            <a:srgbClr val="000000"/>
+                          </a:solidFill>
+                          <a:effectLst/>
+                          <a:latin typeface="Cambria" panose="02040503050406030204" pitchFamily="18" charset="0"/>
+                        </a:rPr>
+                        <a:t>0.3768</a:t>
+                      </a:r>
+                      <a:endParaRPr lang="en-CA">
+                        <a:effectLst/>
+                      </a:endParaRPr>
+                    </a:p>
+                  </a:txBody>
+                  <a:tcPr marL="68580" marR="68580">
+                    <a:lnL w="6350" cap="flat" cmpd="sng" algn="ctr">
+                      <a:solidFill>
+                        <a:srgbClr val="000000"/>
+                      </a:solidFill>
+                      <a:prstDash val="solid"/>
+                      <a:round/>
+                      <a:headEnd type="none" w="med" len="med"/>
+                      <a:tailEnd type="none" w="med" len="med"/>
+                    </a:lnL>
+                    <a:lnR w="6350" cap="flat" cmpd="sng" algn="ctr">
+                      <a:solidFill>
+                        <a:srgbClr val="000000"/>
+                      </a:solidFill>
+                      <a:prstDash val="solid"/>
+                      <a:round/>
+                      <a:headEnd type="none" w="med" len="med"/>
+                      <a:tailEnd type="none" w="med" len="med"/>
+                    </a:lnR>
+                    <a:lnT w="6350" cap="flat" cmpd="sng" algn="ctr">
+                      <a:solidFill>
+                        <a:srgbClr val="000000"/>
+                      </a:solidFill>
+                      <a:prstDash val="solid"/>
+                      <a:round/>
+                      <a:headEnd type="none" w="med" len="med"/>
+                      <a:tailEnd type="none" w="med" len="med"/>
+                    </a:lnT>
+                    <a:lnB w="6350" cap="flat" cmpd="sng" algn="ctr">
+                      <a:solidFill>
+                        <a:srgbClr val="000000"/>
+                      </a:solidFill>
+                      <a:prstDash val="solid"/>
+                      <a:round/>
+                      <a:headEnd type="none" w="med" len="med"/>
+                      <a:tailEnd type="none" w="med" len="med"/>
+                    </a:lnB>
+                    <a:noFill/>
+                  </a:tcPr>
+                </a:tc>
+                <a:tc>
+                  <a:txBody>
+                    <a:bodyPr/>
+                    <a:lstStyle/>
+                    <a:p>
+                      <a:pPr algn="ctr" rtl="0" fontAlgn="t">
+                        <a:buNone/>
+                      </a:pPr>
+                      <a:r>
+                        <a:rPr lang="en-CA" sz="1000" b="0" i="0" u="none" strike="noStrike">
+                          <a:solidFill>
+                            <a:srgbClr val="000000"/>
+                          </a:solidFill>
+                          <a:effectLst/>
+                          <a:latin typeface="Cambria" panose="02040503050406030204" pitchFamily="18" charset="0"/>
+                        </a:rPr>
+                        <a:t>1</a:t>
+                      </a:r>
+                      <a:endParaRPr lang="en-CA">
+                        <a:effectLst/>
+                      </a:endParaRPr>
+                    </a:p>
+                  </a:txBody>
+                  <a:tcPr marL="68580" marR="68580">
+                    <a:lnL w="6350" cap="flat" cmpd="sng" algn="ctr">
+                      <a:solidFill>
+                        <a:srgbClr val="000000"/>
+                      </a:solidFill>
+                      <a:prstDash val="solid"/>
+                      <a:round/>
+                      <a:headEnd type="none" w="med" len="med"/>
+                      <a:tailEnd type="none" w="med" len="med"/>
+                    </a:lnL>
+                    <a:lnR w="6350" cap="flat" cmpd="sng" algn="ctr">
+                      <a:solidFill>
+                        <a:srgbClr val="000000"/>
+                      </a:solidFill>
+                      <a:prstDash val="solid"/>
+                      <a:round/>
+                      <a:headEnd type="none" w="med" len="med"/>
+                      <a:tailEnd type="none" w="med" len="med"/>
+                    </a:lnR>
+                    <a:lnT w="6350" cap="flat" cmpd="sng" algn="ctr">
+                      <a:solidFill>
+                        <a:srgbClr val="000000"/>
+                      </a:solidFill>
+                      <a:prstDash val="solid"/>
+                      <a:round/>
+                      <a:headEnd type="none" w="med" len="med"/>
+                      <a:tailEnd type="none" w="med" len="med"/>
+                    </a:lnT>
+                    <a:lnB w="6350" cap="flat" cmpd="sng" algn="ctr">
+                      <a:solidFill>
+                        <a:srgbClr val="000000"/>
+                      </a:solidFill>
+                      <a:prstDash val="solid"/>
+                      <a:round/>
+                      <a:headEnd type="none" w="med" len="med"/>
+                      <a:tailEnd type="none" w="med" len="med"/>
+                    </a:lnB>
+                    <a:noFill/>
+                  </a:tcPr>
+                </a:tc>
+                <a:tc>
+                  <a:txBody>
+                    <a:bodyPr/>
+                    <a:lstStyle/>
+                    <a:p>
+                      <a:pPr algn="ctr" rtl="0" fontAlgn="t">
+                        <a:buNone/>
+                      </a:pPr>
+                      <a:r>
+                        <a:rPr lang="en-CA" sz="1000" b="0" i="0" u="none" strike="noStrike" dirty="0">
+                          <a:solidFill>
+                            <a:srgbClr val="000000"/>
+                          </a:solidFill>
+                          <a:effectLst/>
+                          <a:latin typeface="Cambria" panose="02040503050406030204" pitchFamily="18" charset="0"/>
+                        </a:rPr>
+                        <a:t>243</a:t>
+                      </a:r>
+                      <a:endParaRPr lang="en-CA" dirty="0">
+                        <a:effectLst/>
+                      </a:endParaRPr>
+                    </a:p>
+                  </a:txBody>
+                  <a:tcPr marL="68580" marR="68580">
+                    <a:lnL w="6350" cap="flat" cmpd="sng" algn="ctr">
+                      <a:solidFill>
+                        <a:srgbClr val="000000"/>
+                      </a:solidFill>
+                      <a:prstDash val="solid"/>
+                      <a:round/>
+                      <a:headEnd type="none" w="med" len="med"/>
+                      <a:tailEnd type="none" w="med" len="med"/>
+                    </a:lnL>
+                    <a:lnR w="6350" cap="flat" cmpd="sng" algn="ctr">
+                      <a:solidFill>
+                        <a:srgbClr val="000000"/>
+                      </a:solidFill>
+                      <a:prstDash val="solid"/>
+                      <a:round/>
+                      <a:headEnd type="none" w="med" len="med"/>
+                      <a:tailEnd type="none" w="med" len="med"/>
+                    </a:lnR>
+                    <a:lnT w="6350" cap="flat" cmpd="sng" algn="ctr">
+                      <a:solidFill>
+                        <a:srgbClr val="000000"/>
+                      </a:solidFill>
+                      <a:prstDash val="solid"/>
+                      <a:round/>
+                      <a:headEnd type="none" w="med" len="med"/>
+                      <a:tailEnd type="none" w="med" len="med"/>
+                    </a:lnT>
+                    <a:lnB w="6350" cap="flat" cmpd="sng" algn="ctr">
+                      <a:solidFill>
+                        <a:srgbClr val="000000"/>
+                      </a:solidFill>
+                      <a:prstDash val="solid"/>
+                      <a:round/>
+                      <a:headEnd type="none" w="med" len="med"/>
+                      <a:tailEnd type="none" w="med" len="med"/>
+                    </a:lnB>
+                    <a:noFill/>
+                  </a:tcPr>
+                </a:tc>
+                <a:extLst>
+                  <a:ext uri="{0D108BD9-81ED-4DB2-BD59-A6C34878D82A}">
+                    <a16:rowId xmlns:a16="http://schemas.microsoft.com/office/drawing/2014/main" val="112828375"/>
+                  </a:ext>
+                </a:extLst>
+              </a:tr>
+            </a:tbl>
+          </a:graphicData>
+        </a:graphic>
+      </p:graphicFrame>
+    </p:spTree>
+    <p:extLst>
+      <p:ext uri="{BB962C8B-B14F-4D97-AF65-F5344CB8AC3E}">
+        <p14:creationId xmlns:p14="http://schemas.microsoft.com/office/powerpoint/2010/main" val="721947250"/>
+      </p:ext>
+    </p:extLst>
+  </p:cSld>
+  <p:clrMapOvr>
+    <a:masterClrMapping/>
+  </p:clrMapOvr>
+</p:sld>
+</file>
+
+<file path=ppt/slides/slide11.xml><?xml version="1.0" encoding="utf-8"?>
+<p:sld xmlns:a="http://schemas.openxmlformats.org/drawingml/2006/main" xmlns:r="http://schemas.openxmlformats.org/officeDocument/2006/relationships" xmlns:p="http://schemas.openxmlformats.org/presentationml/2006/main">
+  <p:cSld>
+    <p:spTree>
+      <p:nvGrpSpPr>
         <p:cNvPr id="1" name=""/>
         <p:cNvGrpSpPr/>
         <p:nvPr/>
@@ -26835,7 +29270,7 @@
 </p:sld>
 </file>
 
-<file path=ppt/slides/slide11.xml><?xml version="1.0" encoding="utf-8"?>
+<file path=ppt/slides/slide12.xml><?xml version="1.0" encoding="utf-8"?>
 <p:sld xmlns:a="http://schemas.openxmlformats.org/drawingml/2006/main" xmlns:r="http://schemas.openxmlformats.org/officeDocument/2006/relationships" xmlns:p="http://schemas.openxmlformats.org/presentationml/2006/main">
   <p:cSld>
     <p:spTree>
@@ -26929,7 +29364,7 @@
 </p:sld>
 </file>
 
-<file path=ppt/slides/slide12.xml><?xml version="1.0" encoding="utf-8"?>
+<file path=ppt/slides/slide13.xml><?xml version="1.0" encoding="utf-8"?>
 <p:sld xmlns:a="http://schemas.openxmlformats.org/drawingml/2006/main" xmlns:r="http://schemas.openxmlformats.org/officeDocument/2006/relationships" xmlns:p="http://schemas.openxmlformats.org/presentationml/2006/main">
   <p:cSld>
     <p:spTree>
@@ -27025,7 +29460,7 @@
 </p:sld>
 </file>
 
-<file path=ppt/slides/slide13.xml><?xml version="1.0" encoding="utf-8"?>
+<file path=ppt/slides/slide14.xml><?xml version="1.0" encoding="utf-8"?>
 <p:sld xmlns:a="http://schemas.openxmlformats.org/drawingml/2006/main" xmlns:r="http://schemas.openxmlformats.org/officeDocument/2006/relationships" xmlns:p="http://schemas.openxmlformats.org/presentationml/2006/main">
   <p:cSld>
     <p:spTree>
@@ -27146,7 +29581,7 @@
           </a:ln>
           <a:extLst>
             <a:ext uri="{C572A759-6A51-4108-AA02-DFA0A04FC94B}">
-              <ma14:wrappingTextBoxFlag xmlns="" xmlns:m="http://schemas.openxmlformats.org/officeDocument/2006/math" xmlns:a14="http://schemas.microsoft.com/office/drawing/2010/main" xmlns:ma14="http://schemas.microsoft.com/office/mac/drawingml/2011/main" val="1"/>
+              <ma14:wrappingTextBoxFlag xmlns:ma14="http://schemas.microsoft.com/office/mac/drawingml/2011/main" xmlns:a14="http://schemas.microsoft.com/office/drawing/2010/main" xmlns:m="http://schemas.openxmlformats.org/officeDocument/2006/math" xmlns="" val="1"/>
             </a:ext>
           </a:extLst>
         </p:spPr>
@@ -27227,7 +29662,7 @@
 </p:sld>
 </file>
 
-<file path=ppt/slides/slide14.xml><?xml version="1.0" encoding="utf-8"?>
+<file path=ppt/slides/slide15.xml><?xml version="1.0" encoding="utf-8"?>
 <p:sld xmlns:a="http://schemas.openxmlformats.org/drawingml/2006/main" xmlns:r="http://schemas.openxmlformats.org/officeDocument/2006/relationships" xmlns:p="http://schemas.openxmlformats.org/presentationml/2006/main">
   <p:cSld>
     <p:spTree>
@@ -27363,7 +29798,7 @@
 </p:sld>
 </file>
 
-<file path=ppt/slides/slide15.xml><?xml version="1.0" encoding="utf-8"?>
+<file path=ppt/slides/slide16.xml><?xml version="1.0" encoding="utf-8"?>
 <p:sld xmlns:a="http://schemas.openxmlformats.org/drawingml/2006/main" xmlns:r="http://schemas.openxmlformats.org/officeDocument/2006/relationships" xmlns:p="http://schemas.openxmlformats.org/presentationml/2006/main">
   <p:cSld>
     <p:bg>
@@ -27715,7 +30150,7 @@
 </p:sld>
 </file>
 
-<file path=ppt/slides/slide16.xml><?xml version="1.0" encoding="utf-8"?>
+<file path=ppt/slides/slide17.xml><?xml version="1.0" encoding="utf-8"?>
 <p:sld xmlns:a="http://schemas.openxmlformats.org/drawingml/2006/main" xmlns:r="http://schemas.openxmlformats.org/officeDocument/2006/relationships" xmlns:p="http://schemas.openxmlformats.org/presentationml/2006/main">
   <p:cSld>
     <p:bg>
@@ -28494,7 +30929,7 @@
 </p:sld>
 </file>
 
-<file path=ppt/slides/slide17.xml><?xml version="1.0" encoding="utf-8"?>
+<file path=ppt/slides/slide18.xml><?xml version="1.0" encoding="utf-8"?>
 <p:sld xmlns:a="http://schemas.openxmlformats.org/drawingml/2006/main" xmlns:r="http://schemas.openxmlformats.org/officeDocument/2006/relationships" xmlns:p="http://schemas.openxmlformats.org/presentationml/2006/main">
   <p:cSld>
     <p:bg>

</xml_diff>